<commit_message>
docs(submission): track presentation.pdf and link directly in README
</commit_message>
<xml_diff>
--- a/docs/presentation.pptx
+++ b/docs/presentation.pptx
@@ -1,29 +1,29 @@
 
 <file path=ppt/presentation.xml><?xml version="1.0" encoding="utf-8"?>
-<p:presentation xmlns:a="http://schemas.openxmlformats.org/drawingml/2006/main" xmlns:p="http://schemas.openxmlformats.org/presentationml/2006/main" xmlns:r="http://schemas.openxmlformats.org/officeDocument/2006/relationships" saveSubsetFonts="1" autoCompressPictures="0">
+<p:presentation xmlns:a="http://schemas.openxmlformats.org/drawingml/2006/main" xmlns:r="http://schemas.openxmlformats.org/officeDocument/2006/relationships" xmlns:p="http://schemas.openxmlformats.org/presentationml/2006/main" saveSubsetFonts="1" autoCompressPictures="0">
   <p:sldMasterIdLst>
     <p:sldMasterId id="2147483648" r:id="rId1"/>
   </p:sldMasterIdLst>
   <p:notesMasterIdLst>
-    <p:notesMasterId r:id="rId14"/>
+    <p:notesMasterId r:id="rId9"/>
   </p:notesMasterIdLst>
   <p:sldIdLst>
-    <p:sldId id="256" r:id="rId7"/>
-    <p:sldId id="257" r:id="rId8"/>
-    <p:sldId id="258" r:id="rId9"/>
-    <p:sldId id="259" r:id="rId10"/>
-    <p:sldId id="260" r:id="rId11"/>
-    <p:sldId id="261" r:id="rId12"/>
-    <p:sldId id="262" r:id="rId13"/>
+    <p:sldId id="256" r:id="rId2"/>
+    <p:sldId id="257" r:id="rId3"/>
+    <p:sldId id="258" r:id="rId4"/>
+    <p:sldId id="259" r:id="rId5"/>
+    <p:sldId id="260" r:id="rId6"/>
+    <p:sldId id="261" r:id="rId7"/>
+    <p:sldId id="262" r:id="rId8"/>
   </p:sldIdLst>
-  <p:sldSz cx="12192000" cy="6858000" type="screen16x9"/>
+  <p:sldSz cx="12192000" cy="6858000"/>
   <p:notesSz cx="6858000" cy="9144000"/>
   <p:defaultTextStyle>
     <a:defPPr>
       <a:defRPr lang="en-US"/>
     </a:defPPr>
     <a:lvl1pPr marL="0" algn="l" defTabSz="457200" rtl="0" eaLnBrk="1" latinLnBrk="0" hangingPunct="1">
-      <a:defRPr sz="1800" kern="1200" lang="en-US">
+      <a:defRPr lang="en-US" sz="1800" kern="1200">
         <a:solidFill>
           <a:schemeClr val="tx1"/>
         </a:solidFill>
@@ -33,7 +33,7 @@
       </a:defRPr>
     </a:lvl1pPr>
     <a:lvl2pPr marL="457200" algn="l" defTabSz="457200" rtl="0" eaLnBrk="1" latinLnBrk="0" hangingPunct="1">
-      <a:defRPr sz="1800" kern="1200" lang="en-US">
+      <a:defRPr lang="en-US" sz="1800" kern="1200">
         <a:solidFill>
           <a:schemeClr val="tx1"/>
         </a:solidFill>
@@ -43,7 +43,7 @@
       </a:defRPr>
     </a:lvl2pPr>
     <a:lvl3pPr marL="914400" algn="l" defTabSz="457200" rtl="0" eaLnBrk="1" latinLnBrk="0" hangingPunct="1">
-      <a:defRPr sz="1800" kern="1200" lang="en-US">
+      <a:defRPr lang="en-US" sz="1800" kern="1200">
         <a:solidFill>
           <a:schemeClr val="tx1"/>
         </a:solidFill>
@@ -53,7 +53,7 @@
       </a:defRPr>
     </a:lvl3pPr>
     <a:lvl4pPr marL="1371600" algn="l" defTabSz="457200" rtl="0" eaLnBrk="1" latinLnBrk="0" hangingPunct="1">
-      <a:defRPr sz="1800" kern="1200" lang="en-US">
+      <a:defRPr lang="en-US" sz="1800" kern="1200">
         <a:solidFill>
           <a:schemeClr val="tx1"/>
         </a:solidFill>
@@ -63,7 +63,7 @@
       </a:defRPr>
     </a:lvl4pPr>
     <a:lvl5pPr marL="1828800" algn="l" defTabSz="457200" rtl="0" eaLnBrk="1" latinLnBrk="0" hangingPunct="1">
-      <a:defRPr sz="1800" kern="1200" lang="en-US">
+      <a:defRPr lang="en-US" sz="1800" kern="1200">
         <a:solidFill>
           <a:schemeClr val="tx1"/>
         </a:solidFill>
@@ -73,7 +73,7 @@
       </a:defRPr>
     </a:lvl5pPr>
     <a:lvl6pPr marL="2286000" algn="l" defTabSz="457200" rtl="0" eaLnBrk="1" latinLnBrk="0" hangingPunct="1">
-      <a:defRPr sz="1800" kern="1200" lang="en-US">
+      <a:defRPr lang="en-US" sz="1800" kern="1200">
         <a:solidFill>
           <a:schemeClr val="tx1"/>
         </a:solidFill>
@@ -83,7 +83,7 @@
       </a:defRPr>
     </a:lvl6pPr>
     <a:lvl7pPr marL="2743200" algn="l" defTabSz="457200" rtl="0" eaLnBrk="1" latinLnBrk="0" hangingPunct="1">
-      <a:defRPr sz="1800" kern="1200" lang="en-US">
+      <a:defRPr lang="en-US" sz="1800" kern="1200">
         <a:solidFill>
           <a:schemeClr val="tx1"/>
         </a:solidFill>
@@ -93,7 +93,7 @@
       </a:defRPr>
     </a:lvl7pPr>
     <a:lvl8pPr marL="3200400" algn="l" defTabSz="457200" rtl="0" eaLnBrk="1" latinLnBrk="0" hangingPunct="1">
-      <a:defRPr sz="1800" kern="1200" lang="en-US">
+      <a:defRPr lang="en-US" sz="1800" kern="1200">
         <a:solidFill>
           <a:schemeClr val="tx1"/>
         </a:solidFill>
@@ -103,7 +103,7 @@
       </a:defRPr>
     </a:lvl8pPr>
     <a:lvl9pPr marL="3657600" algn="l" defTabSz="457200" rtl="0" eaLnBrk="1" latinLnBrk="0" hangingPunct="1">
-      <a:defRPr sz="1800" kern="1200" lang="en-US">
+      <a:defRPr lang="en-US" sz="1800" kern="1200">
         <a:solidFill>
           <a:schemeClr val="tx1"/>
         </a:solidFill>
@@ -113,12 +113,33 @@
       </a:defRPr>
     </a:lvl9pPr>
   </p:defaultTextStyle>
+  <p:extLst>
+    <p:ext uri="{EFAFB233-063F-42B5-8137-9DF3F51BA10A}">
+      <p15:sldGuideLst xmlns:p15="http://schemas.microsoft.com/office/powerpoint/2012/main">
+        <p15:guide id="1" orient="horz" pos="2160">
+          <p15:clr>
+            <a:srgbClr val="A4A3A4"/>
+          </p15:clr>
+        </p15:guide>
+        <p15:guide id="2" pos="2880">
+          <p15:clr>
+            <a:srgbClr val="A4A3A4"/>
+          </p15:clr>
+        </p15:guide>
+      </p15:sldGuideLst>
+    </p:ext>
+  </p:extLst>
 </p:presentation>
 </file>
 
 <file path=ppt/notesMasters/notesMaster1.xml><?xml version="1.0" encoding="utf-8"?>
 <p:notesMaster xmlns:a="http://schemas.openxmlformats.org/drawingml/2006/main" xmlns:r="http://schemas.openxmlformats.org/officeDocument/2006/relationships" xmlns:p="http://schemas.openxmlformats.org/presentationml/2006/main">
   <p:cSld>
+    <p:bg>
+      <p:bgRef idx="1001">
+        <a:schemeClr val="bg1"/>
+      </p:bgRef>
+    </p:bg>
     <p:spTree>
       <p:nvGrpSpPr>
         <p:cNvPr id="1" name=""/>
@@ -156,7 +177,6 @@
           <a:bodyPr/>
           <a:lstStyle/>
           <a:p>
-            <a:pPr/>
             <a:endParaRPr lang="en-US"/>
           </a:p>
         </p:txBody>
@@ -184,7 +204,6 @@
           <a:bodyPr/>
           <a:lstStyle/>
           <a:p>
-            <a:pPr/>
             <a:endParaRPr lang="en-US"/>
           </a:p>
         </p:txBody>
@@ -232,7 +251,6 @@
           <a:bodyPr/>
           <a:lstStyle/>
           <a:p>
-            <a:pPr/>
             <a:endParaRPr lang="en-US"/>
           </a:p>
         </p:txBody>
@@ -260,7 +278,6 @@
           <a:bodyPr/>
           <a:lstStyle/>
           <a:p>
-            <a:pPr/>
             <a:endParaRPr lang="en-US"/>
           </a:p>
         </p:txBody>
@@ -288,7 +305,6 @@
           <a:bodyPr/>
           <a:lstStyle/>
           <a:p>
-            <a:pPr/>
             <a:endParaRPr lang="en-US"/>
           </a:p>
         </p:txBody>
@@ -299,7 +315,7 @@
   <p:hf/>
   <p:notesStyle>
     <a:lvl1pPr marL="0" algn="l">
-      <a:defRPr sz="1200" lang="en-US"/>
+      <a:defRPr lang="en-US" sz="1200"/>
     </a:lvl1pPr>
   </p:notesStyle>
 </p:notesMaster>
@@ -349,29 +365,24 @@
           <a:bodyPr/>
           <a:lstStyle/>
           <a:p>
-            <a:pPr/>
             <a:r>
               <a:rPr lang="en-US" dirty="0"/>
               <a:t>Good morning, distinguished judges and industry leaders from S&amp;P Global and CRISIL. My name is Mritunjay Senapati, and today I am honored to present our project: the AI/NLP Financial Risk Engine &amp; Strategic Portfolio Stress Testing System.</a:t>
             </a:r>
           </a:p>
           <a:p>
-            <a:pPr/>
             <a:endParaRPr lang="en-US" dirty="0"/>
           </a:p>
           <a:p>
-            <a:pPr/>
             <a:r>
               <a:rPr lang="en-US" dirty="0"/>
               <a:t>In modern financial markets, risk does not wait for quarterly reports or delayed credit rating revisions. Market volatility is increasingly triggered by sudden unstructured intelligence—from sudden geopolitical shifts and regulatory changes to supply chain disruptions and social sentiment. However, institutional risk management desks have historically operated with fragmented tools: qualitative intelligence teams monitor news and filings, while quantitative trading desks rely on backward-looking historical variance models.</a:t>
             </a:r>
           </a:p>
           <a:p>
-            <a:pPr/>
             <a:endParaRPr lang="en-US" dirty="0"/>
           </a:p>
           <a:p>
-            <a:pPr/>
             <a:r>
               <a:rPr lang="en-US" dirty="0"/>
               <a:t>Our engine bridges this fundamental gap. By unifying high-throughput NLP intelligence with multi-asset quantitative risk models, we transform unstructured market signals into real-time, actionable capital stress tests, giving rating agencies, portfolio managers, and risk committees an unprecedented level of predictive resilience.</a:t>
@@ -431,72 +442,60 @@
           <a:bodyPr/>
           <a:lstStyle/>
           <a:p>
-            <a:pPr/>
             <a:r>
               <a:rPr lang="en-US" dirty="0"/>
               <a:t>Let us examine the core dilemma facing modern financial institutions. Today, institutional risk operations suffer from three acute structural bottlenecks:</a:t>
             </a:r>
           </a:p>
           <a:p>
-            <a:pPr/>
             <a:endParaRPr lang="en-US" dirty="0"/>
           </a:p>
           <a:p>
-            <a:pPr/>
             <a:r>
               <a:rPr lang="en-US" dirty="0"/>
               <a:t>First, rating downgrade latency. Traditional credit surveillance and risk evaluations operate on retrospective financial statements, leading to a critical 24- to 48-hour latency window during acute market shocks. By the time a formal rating action or credit review occurs, portfolio capital has already sustained severe impairment.</a:t>
             </a:r>
           </a:p>
           <a:p>
-            <a:pPr/>
             <a:endParaRPr lang="en-US" dirty="0"/>
           </a:p>
           <a:p>
-            <a:pPr/>
             <a:r>
               <a:rPr lang="en-US" dirty="0"/>
               <a:t>Second, the deluge of unstructured data. Over 80% of actionable market signals reside in non-standardized formats—ranging from 10-K/10-Q SEC regulatory filings and earnings call transcripts to breaking financial news feeds and FinTwit disclosures. Human risk analysts cannot process this volume in real time without cognitive fatigue and noise distortion.</a:t>
             </a:r>
           </a:p>
           <a:p>
-            <a:pPr/>
             <a:endParaRPr lang="en-US" dirty="0"/>
           </a:p>
           <a:p>
-            <a:pPr/>
             <a:r>
               <a:rPr lang="en-US" dirty="0"/>
               <a:t>Third, fragmented risk infrastructure. Qualitative market research is historically divorced from quantitative risk engines. Portfolio VaR and stress testing models fail to calibrate immediately when macroeconomic sentiment turns adverse.</a:t>
             </a:r>
           </a:p>
           <a:p>
-            <a:pPr/>
             <a:endParaRPr lang="en-US" dirty="0"/>
           </a:p>
           <a:p>
-            <a:pPr/>
             <a:r>
               <a:rPr lang="en-US" dirty="0"/>
               <a:t>Our solution introduces an integrated, three-layer institutional architecture:</a:t>
             </a:r>
           </a:p>
           <a:p>
-            <a:pPr/>
             <a:r>
               <a:rPr lang="en-US" dirty="0"/>
               <a:t>1. An Unstructured NLP Intelligence Pipeline utilizing domain-adapted FinBERT, Named Entity Recognition, and S&amp;P ESG taxonomy mapping.</a:t>
             </a:r>
           </a:p>
           <a:p>
-            <a:pPr/>
             <a:r>
               <a:rPr lang="en-US" dirty="0"/>
               <a:t>2. A Quantitative Multi-Asset Risk Engine computing dynamic GARCH volatility, Monte Carlo VaR at 99% confidence, and extreme tail-dependency copulas.</a:t>
             </a:r>
           </a:p>
           <a:p>
-            <a:pPr/>
             <a:r>
               <a:rPr lang="en-US" dirty="0"/>
               <a:t>3. An Interactive Portfolio Stress Testing &amp; API Dashboard delivering sub-second scenario simulations and instant board-level insights.</a:t>
@@ -539,7 +538,12 @@
             <p:ph type="sldImg" idx="2"/>
           </p:nvPr>
         </p:nvSpPr>
-        <p:spPr/>
+        <p:spPr>
+          <a:xfrm>
+            <a:off x="381000" y="685800"/>
+            <a:ext cx="6096000" cy="3429000"/>
+          </a:xfrm>
+        </p:spPr>
       </p:sp>
       <p:sp>
         <p:nvSpPr>
@@ -556,51 +560,42 @@
           <a:bodyPr/>
           <a:lstStyle/>
           <a:p>
-            <a:pPr/>
             <a:r>
               <a:rPr lang="en-US" dirty="0"/>
               <a:t>Moving to Slide 3, this diagram depicts the complete end-to-end architecture of our financial risk platform, spanning ingestion, AI inference, quantitative modeling, and executive delivery.</a:t>
             </a:r>
           </a:p>
           <a:p>
-            <a:pPr/>
             <a:endParaRPr lang="en-US" dirty="0"/>
           </a:p>
           <a:p>
-            <a:pPr/>
             <a:r>
               <a:rPr lang="en-US" dirty="0"/>
               <a:t>Starting on the left, our Data Ingestion &amp; Normalization Layer connects directly to diverse market feeds: Yahoo Finance and Alpha Vantage for tick-level and daily asset pricing; SEC EDGAR for continuous 10-K, 10-Q, and 8-K regulatory filings; news wire APIs; and Twitter/X financial streams. Every document is pre-processed through a high-throughput cleaning pipeline that removes boilerplate, strips formatting artifacts, and normalizes text streams.</a:t>
             </a:r>
           </a:p>
           <a:p>
-            <a:pPr/>
             <a:endParaRPr lang="en-US" dirty="0"/>
           </a:p>
           <a:p>
-            <a:pPr/>
             <a:r>
               <a:rPr lang="en-US" dirty="0"/>
               <a:t>In the center, our Hybrid NLP Intelligence Engine executes entity resolution and sentiment scoring. We employ FinBERT—a BERT model specifically fine-tuned on financial corpora—to evaluate nuanced sentiment context rather than simple word polarity. Simultaneously, SpaCy NER extracts target equity tickers and corporate entities, while our domain classifier tags ESG risk pillars. Crucially, we incorporate source credibility weighting to prevent unverified social media rumors from distorting risk signals.</a:t>
             </a:r>
           </a:p>
           <a:p>
-            <a:pPr/>
             <a:endParaRPr lang="en-US" dirty="0"/>
           </a:p>
           <a:p>
-            <a:pPr/>
             <a:r>
               <a:rPr lang="en-US" dirty="0"/>
               <a:t>In the lower pipeline, our Quantitative Risk Layer ingests the NLP risk factors alongside multi-asset return series across equities, fixed income, commodities, and derivatives. Here, we calculate rolling covariance matrices, fit GARCH(1,1) volatility models to capture volatility clustering, run 10,000 Monte Carlo iterations for Value at Risk and Conditional VaR (Expected Shortfall), and apply asymmetric Clayton and Gumbel copulas to model extreme tail co-movements.</a:t>
             </a:r>
           </a:p>
           <a:p>
-            <a:pPr/>
             <a:endParaRPr lang="en-US" dirty="0"/>
           </a:p>
           <a:p>
-            <a:pPr/>
             <a:r>
               <a:rPr lang="en-US" dirty="0"/>
               <a:t>Finally, the results are surfaced through our Enterprise Delivery Layer: high-performance Spring Boot REST APIs, real-time WebSocket alerts, and an executive institutional terminal featuring interactive scenario builders and automated compliance reports.</a:t>
@@ -660,100 +655,84 @@
           <a:bodyPr/>
           <a:lstStyle/>
           <a:p>
-            <a:pPr/>
             <a:r>
               <a:rPr lang="en-US" dirty="0"/>
               <a:t>On Slide 4, we detail the mathematical rigor and algorithmic foundations that power our risk calculations.</a:t>
             </a:r>
           </a:p>
           <a:p>
-            <a:pPr/>
             <a:endParaRPr lang="en-US" dirty="0"/>
           </a:p>
           <a:p>
-            <a:pPr/>
             <a:r>
               <a:rPr lang="en-US" dirty="0"/>
               <a:t>In the NLP pillar, composite sentiment is derived from FinBERT probability vectors weighted by source credibility and entity relevance. Our engine calculates:</a:t>
             </a:r>
           </a:p>
           <a:p>
-            <a:pPr/>
             <a:r>
               <a:rPr lang="en-US" dirty="0"/>
               <a:t>S_composite = sum of w_i multiplied by S_i(FinBERT) multiplied by C_source, normalized by total weights.</a:t>
             </a:r>
           </a:p>
           <a:p>
-            <a:pPr/>
             <a:r>
               <a:rPr lang="en-US" dirty="0"/>
               <a:t>This ensures that official regulatory filings and audited news carry significantly higher weight than speculative retail commentary, completely mitigating adversarial noise.</a:t>
             </a:r>
           </a:p>
           <a:p>
-            <a:pPr/>
             <a:endParaRPr lang="en-US" dirty="0"/>
           </a:p>
           <a:p>
-            <a:pPr/>
             <a:r>
               <a:rPr lang="en-US" dirty="0"/>
               <a:t>In the Quantitative Risk pillar, market return volatility is not treated as static. We implement the GARCH(1,1) process:</a:t>
             </a:r>
           </a:p>
           <a:p>
-            <a:pPr/>
             <a:r>
               <a:rPr lang="en-US" dirty="0"/>
               <a:t>sigma_t squared equals omega plus alpha times epsilon_{t-1} squared plus beta times sigma_{t-1} squared.</a:t>
             </a:r>
           </a:p>
           <a:p>
-            <a:pPr/>
             <a:r>
               <a:rPr lang="en-US" dirty="0"/>
               <a:t>Subject to the stability condition that alpha plus beta is strictly less than one. This dynamically captures volatility clustering, ensuring that periods of high market turbulence feed directly into higher risk margins.</a:t>
             </a:r>
           </a:p>
           <a:p>
-            <a:pPr/>
             <a:endParaRPr lang="en-US" dirty="0"/>
           </a:p>
           <a:p>
-            <a:pPr/>
             <a:r>
               <a:rPr lang="en-US" dirty="0"/>
               <a:t>For portfolio loss quantification, we compute Value at Risk and Conditional Value at Risk (Expected Shortfall) at the 99% confidence level over a 10-day horizon:</a:t>
             </a:r>
           </a:p>
           <a:p>
-            <a:pPr/>
             <a:r>
               <a:rPr lang="en-US" dirty="0"/>
               <a:t>VaR_alpha equals negative infimum of returns such that cumulative distribution is greater than or equal to 1 minus alpha.</a:t>
             </a:r>
           </a:p>
           <a:p>
-            <a:pPr/>
             <a:r>
               <a:rPr lang="en-US" dirty="0"/>
               <a:t>And CVaR_alpha equals the expected loss given that losses exceed the VaR threshold: E[Loss | Loss &gt;= VaR_alpha].</a:t>
             </a:r>
           </a:p>
           <a:p>
-            <a:pPr/>
             <a:r>
               <a:rPr lang="en-US" dirty="0"/>
               <a:t>Furthermore, because joint extreme losses violate normal distribution assumptions, we incorporate Archimedean copulas (Clayton for joint lower tail dependencies during market crashes, and Gumbel for upside asymmetric co-movements).</a:t>
             </a:r>
           </a:p>
           <a:p>
-            <a:pPr/>
             <a:endParaRPr lang="en-US" dirty="0"/>
           </a:p>
           <a:p>
-            <a:pPr/>
             <a:r>
               <a:rPr lang="en-US" dirty="0"/>
               <a:t>This combination of natural language processing and advanced financial econometrics provides an unshakeable mathematical baseline for stress testing.</a:t>
@@ -813,118 +792,99 @@
           <a:bodyPr/>
           <a:lstStyle/>
           <a:p>
-            <a:pPr/>
             <a:r>
               <a:rPr lang="en-US" dirty="0"/>
               <a:t>Slide 5 showcases our empirical validation and stress testing results on an institutional multi-asset benchmark portfolio valued at $585.0 Million USD.</a:t>
             </a:r>
           </a:p>
           <a:p>
-            <a:pPr/>
             <a:endParaRPr lang="en-US" dirty="0"/>
           </a:p>
           <a:p>
-            <a:pPr/>
             <a:r>
               <a:rPr lang="en-US" dirty="0"/>
               <a:t>In our multi-factor stress test scenario—simulating simultaneous stagflation, aggressive central bank interest rate hikes, and geopolitical supply shocks—we trace the cumulative capital impact across each risk component:</a:t>
             </a:r>
           </a:p>
           <a:p>
-            <a:pPr/>
             <a:endParaRPr lang="en-US" dirty="0"/>
           </a:p>
           <a:p>
-            <a:pPr/>
             <a:r>
               <a:rPr lang="en-US" dirty="0"/>
               <a:t>Starting with our baseline portfolio NAV of $585.0M:</a:t>
             </a:r>
           </a:p>
           <a:p>
-            <a:pPr/>
             <a:r>
               <a:rPr lang="en-US" dirty="0"/>
               <a:t>• Equity market beta contraction drives an immediate -$48.2M drawdown across global equities.</a:t>
             </a:r>
           </a:p>
           <a:p>
-            <a:pPr/>
             <a:r>
               <a:rPr lang="en-US" dirty="0"/>
               <a:t>• Fixed income duration compression and yield curve shifts contribute a -$32.4M loss in long-duration debt.</a:t>
             </a:r>
           </a:p>
           <a:p>
-            <a:pPr/>
             <a:r>
               <a:rPr lang="en-US" dirty="0"/>
               <a:t>• Credit spread widening and default probability surges subtract -$18.6M.</a:t>
             </a:r>
           </a:p>
           <a:p>
-            <a:pPr/>
             <a:r>
               <a:rPr lang="en-US" dirty="0"/>
               <a:t>• Our NLP Negative Sentiment Surge identifies early supplier strain and regulatory inquiries, adding an incremental -$16.9M in anticipatory tail-risk revaluation.</a:t>
             </a:r>
           </a:p>
           <a:p>
-            <a:pPr/>
             <a:r>
               <a:rPr lang="en-US" dirty="0"/>
               <a:t>• Commodity and energy price spikes inflict an additional -$23.1M.</a:t>
             </a:r>
           </a:p>
           <a:p>
-            <a:pPr/>
             <a:endParaRPr lang="en-US" dirty="0"/>
           </a:p>
           <a:p>
-            <a:pPr/>
             <a:r>
               <a:rPr lang="en-US" dirty="0"/>
               <a:t>At the lowest unhedged point, the portfolio experiences a maximum peak-to-trough drawdown of -$116.1M, representing an alarming 19.8% capital impairment.</a:t>
             </a:r>
           </a:p>
           <a:p>
-            <a:pPr/>
             <a:endParaRPr lang="en-US" dirty="0"/>
           </a:p>
           <a:p>
-            <a:pPr/>
             <a:r>
               <a:rPr lang="en-US" dirty="0"/>
               <a:t>However, because our engine identifies these cascading risks 36 hours ahead of lagging credit rating actions, it triggers our automated dynamic rebalancing protocol:</a:t>
             </a:r>
           </a:p>
           <a:p>
-            <a:pPr/>
             <a:r>
               <a:rPr lang="en-US" dirty="0"/>
               <a:t>• Liquidating high-vulnerability equity tranches into cash and ultra-short treasuries,</a:t>
             </a:r>
           </a:p>
           <a:p>
-            <a:pPr/>
             <a:r>
               <a:rPr lang="en-US" dirty="0"/>
               <a:t>• Entering defensive volatility hedges (long index puts and inverse commodity ETF spreads),</a:t>
             </a:r>
           </a:p>
           <a:p>
-            <a:pPr/>
             <a:r>
               <a:rPr lang="en-US" dirty="0"/>
               <a:t>• Recovering +$29.5M in capital preservation!</a:t>
             </a:r>
           </a:p>
           <a:p>
-            <a:pPr/>
             <a:endParaRPr lang="en-US" dirty="0"/>
           </a:p>
           <a:p>
-            <a:pPr/>
             <a:r>
               <a:rPr lang="en-US" dirty="0"/>
               <a:t>As a result, terminal portfolio NAV stabilizes at $498.4M. Value at Risk at 99% confidence is measured at $42.6M, with Conditional VaR at $58.1M, delivering a 4.2x stress-tested resilience improvement over unmanaged portfolios.</a:t>
@@ -984,61 +944,51 @@
           <a:bodyPr/>
           <a:lstStyle/>
           <a:p>
-            <a:pPr/>
             <a:r>
               <a:rPr lang="en-US" dirty="0"/>
               <a:t>On Slide 6, we demonstrate how this platform delivers immediate enterprise value across key financial institutions and stakeholder personas:</a:t>
             </a:r>
           </a:p>
           <a:p>
-            <a:pPr/>
             <a:endParaRPr lang="en-US" dirty="0"/>
           </a:p>
           <a:p>
-            <a:pPr/>
             <a:r>
               <a:rPr lang="en-US" dirty="0"/>
               <a:t>First, for Credit Rating Agencies such as CRISIL and S&amp;P Global:</a:t>
             </a:r>
           </a:p>
           <a:p>
-            <a:pPr/>
             <a:r>
               <a:rPr lang="en-US" dirty="0"/>
               <a:t>Our platform slashes credit surveillance latency from 48 hours down to under 15 minutes. By monitoring real-time sentiment trajectories, litigation filings, and supply chain health, rating analysts can issue early credit warnings and CreditWatch outlook revisions well before official bond defaults occur.</a:t>
             </a:r>
           </a:p>
           <a:p>
-            <a:pPr/>
             <a:endParaRPr lang="en-US" dirty="0"/>
           </a:p>
           <a:p>
-            <a:pPr/>
             <a:r>
               <a:rPr lang="en-US" dirty="0"/>
               <a:t>Second, for Institutional Asset Managers &amp; Hedge Funds:</a:t>
             </a:r>
           </a:p>
           <a:p>
-            <a:pPr/>
             <a:r>
               <a:rPr lang="en-US" dirty="0"/>
               <a:t>Portfolio managers gain continuous, real-time visibility into multi-asset tail-risk and factor sensitivities. Instead of running overnight batch risk reports, managers can stress-test rebalancing decisions dynamically during active market hours, protecting client assets from sudden liquidity crunches and cascading margin calls.</a:t>
             </a:r>
           </a:p>
           <a:p>
-            <a:pPr/>
             <a:endParaRPr lang="en-US" dirty="0"/>
           </a:p>
           <a:p>
-            <a:pPr/>
             <a:r>
               <a:rPr lang="en-US" dirty="0"/>
               <a:t>Third, for Corporate Treasuries &amp; Enterprise Risk Committees:</a:t>
             </a:r>
           </a:p>
           <a:p>
-            <a:pPr/>
             <a:r>
               <a:rPr lang="en-US" dirty="0"/>
               <a:t>Treasurers and Chief Risk Officers gain board-ready executive visualizations and automated Basel III / FRTB regulatory compliance audit trails. They can test working capital vulnerabilities against foreign exchange shocks, raw material spikes, and sovereign debt turbulence with clear, defensible mathematical justifications.</a:t>
@@ -1098,103 +1048,87 @@
           <a:bodyPr/>
           <a:lstStyle/>
           <a:p>
-            <a:pPr/>
             <a:r>
               <a:rPr lang="en-US" dirty="0"/>
               <a:t>Finally, on Slide 7, we address our architectural assumptions, compliance governance, and key strategic capability enhancement points:</a:t>
             </a:r>
           </a:p>
           <a:p>
-            <a:pPr/>
             <a:endParaRPr lang="en-US" dirty="0"/>
           </a:p>
           <a:p>
-            <a:pPr/>
             <a:r>
               <a:rPr lang="en-US" dirty="0"/>
               <a:t>We operate on explicit technical and quantitative assumptions:</a:t>
             </a:r>
           </a:p>
           <a:p>
-            <a:pPr/>
             <a:r>
               <a:rPr lang="en-US" dirty="0"/>
               <a:t>• A1: Automated stress triggering on Impact Score &gt;= 7 guarantees immediate capital defense during acute crises without manual bottlenecks.</a:t>
             </a:r>
           </a:p>
           <a:p>
-            <a:pPr/>
             <a:r>
               <a:rPr lang="en-US" dirty="0"/>
               <a:t>• A2 &amp; A3: Standardized NLP bounds [-1.0, +1.0] and 1–10 scoring ensure clear risk interpretation.</a:t>
             </a:r>
           </a:p>
           <a:p>
-            <a:pPr/>
             <a:r>
               <a:rPr lang="en-US" dirty="0"/>
               <a:t>• A4 &amp; A5: Scoped $585M notional valuation and calibrated shock regimes isolate macro vulnerability from tick-level noise.</a:t>
             </a:r>
           </a:p>
           <a:p>
-            <a:pPr/>
             <a:r>
               <a:rPr lang="en-US" dirty="0"/>
               <a:t>• A6: First-order bond duration approximation guarantees sub-75ms valuation throughput.</a:t>
             </a:r>
           </a:p>
           <a:p>
-            <a:pPr/>
             <a:r>
               <a:rPr lang="en-US" dirty="0"/>
               <a:t>• A7 &amp; A8: Rigorous source credibility weighting discounts social noise, while 512 token clipping eliminates transformer OOM bottlenecks.</a:t>
             </a:r>
           </a:p>
           <a:p>
-            <a:pPr/>
             <a:endParaRPr lang="en-US" dirty="0"/>
           </a:p>
           <a:p>
-            <a:pPr/>
             <a:r>
               <a:rPr lang="en-US" dirty="0"/>
               <a:t>To extend this engine to Tier-1 institutional scale, we have established four key strategic capability improvement points:</a:t>
             </a:r>
           </a:p>
           <a:p>
-            <a:pPr/>
             <a:r>
               <a:rPr lang="en-US" dirty="0"/>
               <a:t>1. Advanced Stochastic Monte Carlo &amp; Bond Convexity: Bootstrapping full yield curves, calculating second-order convexity, and running 10,000-path stochastic Monte Carlo simulations for 99% CVaR.</a:t>
             </a:r>
           </a:p>
           <a:p>
-            <a:pPr/>
             <a:r>
               <a:rPr lang="en-US" dirty="0"/>
               <a:t>2. Live Market Streaming &amp; FIX Protocol: Hooking institutional WebSocket and FIX protocol feeds (Bloomberg B-PIPE and Refinitiv) for real-time streaming mark-to-market valuations.</a:t>
             </a:r>
           </a:p>
           <a:p>
-            <a:pPr/>
             <a:r>
               <a:rPr lang="en-US" dirty="0"/>
               <a:t>3. Knowledge Graph Entity Disambiguation: Constructing property graphs across 200k+ global corporate parent-subsidiary trees to track multi-hop contagion pathways.</a:t>
             </a:r>
           </a:p>
           <a:p>
-            <a:pPr/>
             <a:r>
               <a:rPr lang="en-US" dirty="0"/>
               <a:t>4. High-Throughput Distributed Event Mesh: Deploying an Apache Kafka streaming event mesh scaling to over 2,000,000 events per second with active-active fault tolerance.</a:t>
             </a:r>
           </a:p>
           <a:p>
-            <a:pPr/>
             <a:endParaRPr lang="en-US" dirty="0"/>
           </a:p>
           <a:p>
-            <a:pPr/>
             <a:r>
               <a:rPr lang="en-US" dirty="0"/>
               <a:t>In conclusion, our AI/NLP Financial Risk Engine empowers institutions to anticipate market disruptions, quantify tail-risk with mathematical precision, and protect capital with confidence. Thank you very much, and I welcome your questions.</a:t>
@@ -1210,8 +1144,8 @@
 </p:notes>
 </file>
 
-<file path=ppt/slideLayouts/slideLayout7.xml><?xml version="1.0" encoding="utf-8"?>
-<p:sldLayout xmlns:a="http://schemas.openxmlformats.org/drawingml/2006/main" xmlns:p="http://schemas.openxmlformats.org/presentationml/2006/main" type="blank" preserve="1">
+<file path=ppt/slideLayouts/slideLayout1.xml><?xml version="1.0" encoding="utf-8"?>
+<p:sldLayout xmlns:a="http://schemas.openxmlformats.org/drawingml/2006/main" xmlns:r="http://schemas.openxmlformats.org/officeDocument/2006/relationships" xmlns:p="http://schemas.openxmlformats.org/presentationml/2006/main" type="blank" preserve="1">
   <p:cSld name="financial_risk_engine — Blank">
     <p:spTree>
       <p:nvGrpSpPr>
@@ -1244,7 +1178,7 @@
           <a:p>
             <a:fld id="{5BCAD085-E8A6-8845-BD4E-CB4CCA059FC4}" type="datetimeFigureOut">
               <a:rPr lang="en-US" smtClean="0"/>
-              <a:t>1/27/13</a:t>
+              <a:t>10/6/2026</a:t>
             </a:fld>
             <a:endParaRPr lang="en-US"/>
           </a:p>
@@ -1301,7 +1235,7 @@
 </file>
 
 <file path=ppt/slideMasters/slideMaster1.xml><?xml version="1.0" encoding="utf-8"?>
-<p:sldMaster xmlns:a="http://schemas.openxmlformats.org/drawingml/2006/main" xmlns:p="http://schemas.openxmlformats.org/presentationml/2006/main" xmlns:r="http://schemas.openxmlformats.org/officeDocument/2006/relationships">
+<p:sldMaster xmlns:a="http://schemas.openxmlformats.org/drawingml/2006/main" xmlns:r="http://schemas.openxmlformats.org/officeDocument/2006/relationships" xmlns:p="http://schemas.openxmlformats.org/presentationml/2006/main">
   <p:cSld name="financial_risk_engine — Master">
     <p:bg>
       <p:bgRef idx="1001">
@@ -1345,7 +1279,7 @@
           <a:bodyPr vert="horz" lIns="91440" tIns="45720" rIns="91440" bIns="45720" rtlCol="0" anchor="ctr"/>
           <a:lstStyle>
             <a:lvl1pPr algn="l">
-              <a:defRPr sz="1200" lang="en-US">
+              <a:defRPr lang="en-US" sz="1200">
                 <a:solidFill>
                   <a:schemeClr val="tx1">
                     <a:tint val="75000"/>
@@ -1357,7 +1291,7 @@
           <a:p>
             <a:fld id="{5BCAD085-E8A6-8845-BD4E-CB4CCA059FC4}" type="datetimeFigureOut">
               <a:rPr lang="en-US" smtClean="0"/>
-              <a:t>1/27/13</a:t>
+              <a:t>10/6/2026</a:t>
             </a:fld>
             <a:endParaRPr lang="en-US"/>
           </a:p>
@@ -1386,7 +1320,7 @@
           <a:bodyPr vert="horz" lIns="91440" tIns="45720" rIns="91440" bIns="45720" rtlCol="0" anchor="ctr"/>
           <a:lstStyle>
             <a:lvl1pPr algn="ctr">
-              <a:defRPr sz="1200" lang="en-US">
+              <a:defRPr lang="en-US" sz="1200">
                 <a:solidFill>
                   <a:schemeClr val="tx1">
                     <a:tint val="75000"/>
@@ -1423,7 +1357,7 @@
           <a:bodyPr vert="horz" lIns="91440" tIns="45720" rIns="91440" bIns="45720" rtlCol="0" anchor="ctr"/>
           <a:lstStyle>
             <a:lvl1pPr algn="r">
-              <a:defRPr sz="1200" lang="en-US">
+              <a:defRPr lang="en-US" sz="1200">
                 <a:solidFill>
                   <a:schemeClr val="tx1">
                     <a:tint val="75000"/>
@@ -1445,7 +1379,7 @@
   </p:cSld>
   <p:clrMap bg1="lt1" tx1="dk1" bg2="lt2" tx2="dk2" accent1="accent1" accent2="accent2" accent3="accent3" accent4="accent4" accent5="accent5" accent6="accent6" hlink="hlink" folHlink="folHlink"/>
   <p:sldLayoutIdLst>
-    <p:sldLayoutId id="2147483655" r:id="rId7"/>
+    <p:sldLayoutId id="2147483655" r:id="rId1"/>
   </p:sldLayoutIdLst>
   <p:txStyles>
     <p:titleStyle>
@@ -1454,7 +1388,7 @@
           <a:spcPct val="0"/>
         </a:spcBef>
         <a:buNone/>
-        <a:defRPr sz="2400" kern="1200" lang="en-US">
+        <a:defRPr lang="en-US" sz="2400" kern="1200">
           <a:solidFill>
             <a:schemeClr val="tx1"/>
           </a:solidFill>
@@ -1471,7 +1405,7 @@
         </a:spcBef>
         <a:buFont typeface="Arial"/>
         <a:buChar char="•"/>
-        <a:defRPr sz="1100" kern="1200" lang="en-US">
+        <a:defRPr lang="en-US" sz="1100" kern="1200">
           <a:solidFill>
             <a:schemeClr val="tx1"/>
           </a:solidFill>
@@ -1486,7 +1420,7 @@
         </a:spcBef>
         <a:buFont typeface="Arial"/>
         <a:buChar char="–"/>
-        <a:defRPr sz="1050" kern="1200" lang="en-US">
+        <a:defRPr lang="en-US" sz="1050" kern="1200">
           <a:solidFill>
             <a:schemeClr val="tx1"/>
           </a:solidFill>
@@ -1501,7 +1435,7 @@
         </a:spcBef>
         <a:buFont typeface="Arial"/>
         <a:buChar char="•"/>
-        <a:defRPr sz="1000" kern="1200" lang="en-US">
+        <a:defRPr lang="en-US" sz="1000" kern="1200">
           <a:solidFill>
             <a:schemeClr val="tx1"/>
           </a:solidFill>
@@ -1516,7 +1450,7 @@
         </a:spcBef>
         <a:buFont typeface="Arial"/>
         <a:buChar char="–"/>
-        <a:defRPr sz="900" kern="1200" lang="en-US">
+        <a:defRPr lang="en-US" sz="900" kern="1200">
           <a:solidFill>
             <a:schemeClr val="tx1"/>
           </a:solidFill>
@@ -1531,7 +1465,7 @@
         </a:spcBef>
         <a:buFont typeface="Arial"/>
         <a:buChar char="»"/>
-        <a:defRPr sz="850" kern="1200" lang="en-US">
+        <a:defRPr lang="en-US" sz="850" kern="1200">
           <a:solidFill>
             <a:schemeClr val="tx1"/>
           </a:solidFill>
@@ -1546,7 +1480,7 @@
         </a:spcBef>
         <a:buFont typeface="Arial"/>
         <a:buChar char="•"/>
-        <a:defRPr sz="800" kern="1200" lang="en-US">
+        <a:defRPr lang="en-US" sz="800" kern="1200">
           <a:solidFill>
             <a:schemeClr val="tx1"/>
           </a:solidFill>
@@ -1561,7 +1495,7 @@
         </a:spcBef>
         <a:buFont typeface="Arial"/>
         <a:buChar char="•"/>
-        <a:defRPr sz="800" kern="1200" lang="en-US">
+        <a:defRPr lang="en-US" sz="800" kern="1200">
           <a:solidFill>
             <a:schemeClr val="tx1"/>
           </a:solidFill>
@@ -1576,7 +1510,7 @@
         </a:spcBef>
         <a:buFont typeface="Arial"/>
         <a:buChar char="•"/>
-        <a:defRPr sz="800" kern="1200" lang="en-US">
+        <a:defRPr lang="en-US" sz="800" kern="1200">
           <a:solidFill>
             <a:schemeClr val="tx1"/>
           </a:solidFill>
@@ -1591,7 +1525,7 @@
         </a:spcBef>
         <a:buFont typeface="Arial"/>
         <a:buChar char="•"/>
-        <a:defRPr sz="800" kern="1200" lang="en-US">
+        <a:defRPr lang="en-US" sz="800" kern="1200">
           <a:solidFill>
             <a:schemeClr val="tx1"/>
           </a:solidFill>
@@ -1606,7 +1540,7 @@
         <a:defRPr lang="en-US"/>
       </a:defPPr>
       <a:lvl1pPr marL="0" algn="l" defTabSz="457200" rtl="0" eaLnBrk="1" latinLnBrk="0" hangingPunct="1">
-        <a:defRPr sz="1100" kern="1200" lang="en-US">
+        <a:defRPr lang="en-US" sz="1100" kern="1200">
           <a:solidFill>
             <a:schemeClr val="tx1"/>
           </a:solidFill>
@@ -1616,7 +1550,7 @@
         </a:defRPr>
       </a:lvl1pPr>
       <a:lvl2pPr marL="457200" algn="l" defTabSz="457200" rtl="0" eaLnBrk="1" latinLnBrk="0" hangingPunct="1">
-        <a:defRPr sz="1050" kern="1200" lang="en-US">
+        <a:defRPr lang="en-US" sz="1050" kern="1200">
           <a:solidFill>
             <a:schemeClr val="tx1"/>
           </a:solidFill>
@@ -1626,7 +1560,7 @@
         </a:defRPr>
       </a:lvl2pPr>
       <a:lvl3pPr marL="914400" algn="l" defTabSz="457200" rtl="0" eaLnBrk="1" latinLnBrk="0" hangingPunct="1">
-        <a:defRPr sz="1000" kern="1200" lang="en-US">
+        <a:defRPr lang="en-US" sz="1000" kern="1200">
           <a:solidFill>
             <a:schemeClr val="tx1"/>
           </a:solidFill>
@@ -1636,7 +1570,7 @@
         </a:defRPr>
       </a:lvl3pPr>
       <a:lvl4pPr marL="1371600" algn="l" defTabSz="457200" rtl="0" eaLnBrk="1" latinLnBrk="0" hangingPunct="1">
-        <a:defRPr sz="900" kern="1200" lang="en-US">
+        <a:defRPr lang="en-US" sz="900" kern="1200">
           <a:solidFill>
             <a:schemeClr val="tx1"/>
           </a:solidFill>
@@ -1646,7 +1580,7 @@
         </a:defRPr>
       </a:lvl4pPr>
       <a:lvl5pPr marL="1828800" algn="l" defTabSz="457200" rtl="0" eaLnBrk="1" latinLnBrk="0" hangingPunct="1">
-        <a:defRPr sz="850" kern="1200" lang="en-US">
+        <a:defRPr lang="en-US" sz="850" kern="1200">
           <a:solidFill>
             <a:schemeClr val="tx1"/>
           </a:solidFill>
@@ -1656,7 +1590,7 @@
         </a:defRPr>
       </a:lvl5pPr>
       <a:lvl6pPr marL="2286000" algn="l" defTabSz="457200" rtl="0" eaLnBrk="1" latinLnBrk="0" hangingPunct="1">
-        <a:defRPr sz="800" kern="1200" lang="en-US">
+        <a:defRPr lang="en-US" sz="800" kern="1200">
           <a:solidFill>
             <a:schemeClr val="tx1"/>
           </a:solidFill>
@@ -1666,7 +1600,7 @@
         </a:defRPr>
       </a:lvl6pPr>
       <a:lvl7pPr marL="2743200" algn="l" defTabSz="457200" rtl="0" eaLnBrk="1" latinLnBrk="0" hangingPunct="1">
-        <a:defRPr sz="800" kern="1200" lang="en-US">
+        <a:defRPr lang="en-US" sz="800" kern="1200">
           <a:solidFill>
             <a:schemeClr val="tx1"/>
           </a:solidFill>
@@ -1676,7 +1610,7 @@
         </a:defRPr>
       </a:lvl7pPr>
       <a:lvl8pPr marL="3200400" algn="l" defTabSz="457200" rtl="0" eaLnBrk="1" latinLnBrk="0" hangingPunct="1">
-        <a:defRPr sz="800" kern="1200" lang="en-US">
+        <a:defRPr lang="en-US" sz="800" kern="1200">
           <a:solidFill>
             <a:schemeClr val="tx1"/>
           </a:solidFill>
@@ -1686,7 +1620,7 @@
         </a:defRPr>
       </a:lvl8pPr>
       <a:lvl9pPr marL="3657600" algn="l" defTabSz="457200" rtl="0" eaLnBrk="1" latinLnBrk="0" hangingPunct="1">
-        <a:defRPr sz="800" kern="1200" lang="en-US">
+        <a:defRPr lang="en-US" sz="800" kern="1200">
           <a:solidFill>
             <a:schemeClr val="tx1"/>
           </a:solidFill>
@@ -3104,7 +3038,7 @@
             </a:bodyPr>
             <a:lstStyle/>
             <a:p>
-              <a:pPr algn="l" marL="77735" indent="-77735">
+              <a:pPr marL="77735" indent="-77735" algn="l">
                 <a:buClr>
                   <a:srgbClr val="334155"/>
                 </a:buClr>
@@ -3151,7 +3085,7 @@
             </a:bodyPr>
             <a:lstStyle/>
             <a:p>
-              <a:pPr algn="l" marL="77735" indent="-77735">
+              <a:pPr marL="77735" indent="-77735" algn="l">
                 <a:buClr>
                   <a:srgbClr val="334155"/>
                 </a:buClr>
@@ -3198,7 +3132,7 @@
             </a:bodyPr>
             <a:lstStyle/>
             <a:p>
-              <a:pPr algn="l" marL="77735" indent="-77735">
+              <a:pPr marL="77735" indent="-77735" algn="l">
                 <a:buClr>
                   <a:srgbClr val="334155"/>
                 </a:buClr>
@@ -3245,7 +3179,7 @@
             </a:bodyPr>
             <a:lstStyle/>
             <a:p>
-              <a:pPr algn="l" marL="77735" indent="-77735">
+              <a:pPr marL="77735" indent="-77735" algn="l">
                 <a:buClr>
                   <a:srgbClr val="334155"/>
                 </a:buClr>
@@ -3464,7 +3398,7 @@
             </a:bodyPr>
             <a:lstStyle/>
             <a:p>
-              <a:pPr algn="l" marL="77735" indent="-77735">
+              <a:pPr marL="77735" indent="-77735" algn="l">
                 <a:buClr>
                   <a:srgbClr val="334155"/>
                 </a:buClr>
@@ -3511,7 +3445,7 @@
             </a:bodyPr>
             <a:lstStyle/>
             <a:p>
-              <a:pPr algn="l" marL="77735" indent="-77735">
+              <a:pPr marL="77735" indent="-77735" algn="l">
                 <a:buClr>
                   <a:srgbClr val="334155"/>
                 </a:buClr>
@@ -3558,7 +3492,7 @@
             </a:bodyPr>
             <a:lstStyle/>
             <a:p>
-              <a:pPr algn="l" marL="77735" indent="-77735">
+              <a:pPr marL="77735" indent="-77735" algn="l">
                 <a:buClr>
                   <a:srgbClr val="334155"/>
                 </a:buClr>
@@ -3605,7 +3539,7 @@
             </a:bodyPr>
             <a:lstStyle/>
             <a:p>
-              <a:pPr algn="l" marL="77735" indent="-77735">
+              <a:pPr marL="77735" indent="-77735" algn="l">
                 <a:buClr>
                   <a:srgbClr val="334155"/>
                 </a:buClr>
@@ -3824,7 +3758,7 @@
             </a:bodyPr>
             <a:lstStyle/>
             <a:p>
-              <a:pPr algn="l" marL="77735" indent="-77735">
+              <a:pPr marL="77735" indent="-77735" algn="l">
                 <a:buClr>
                   <a:srgbClr val="334155"/>
                 </a:buClr>
@@ -3871,7 +3805,7 @@
             </a:bodyPr>
             <a:lstStyle/>
             <a:p>
-              <a:pPr algn="l" marL="77735" indent="-77735">
+              <a:pPr marL="77735" indent="-77735" algn="l">
                 <a:buClr>
                   <a:srgbClr val="334155"/>
                 </a:buClr>
@@ -3918,7 +3852,7 @@
             </a:bodyPr>
             <a:lstStyle/>
             <a:p>
-              <a:pPr algn="l" marL="77735" indent="-77735">
+              <a:pPr marL="77735" indent="-77735" algn="l">
                 <a:buClr>
                   <a:srgbClr val="334155"/>
                 </a:buClr>
@@ -3965,7 +3899,7 @@
             </a:bodyPr>
             <a:lstStyle/>
             <a:p>
-              <a:pPr algn="l" marL="77735" indent="-77735">
+              <a:pPr marL="77735" indent="-77735" algn="l">
                 <a:buClr>
                   <a:srgbClr val="334155"/>
                 </a:buClr>
@@ -4184,7 +4118,7 @@
             </a:bodyPr>
             <a:lstStyle/>
             <a:p>
-              <a:pPr algn="l" marL="77735" indent="-77735">
+              <a:pPr marL="77735" indent="-77735" algn="l">
                 <a:buClr>
                   <a:srgbClr val="334155"/>
                 </a:buClr>
@@ -4231,7 +4165,7 @@
             </a:bodyPr>
             <a:lstStyle/>
             <a:p>
-              <a:pPr algn="l" marL="77735" indent="-77735">
+              <a:pPr marL="77735" indent="-77735" algn="l">
                 <a:buClr>
                   <a:srgbClr val="334155"/>
                 </a:buClr>
@@ -4278,7 +4212,7 @@
             </a:bodyPr>
             <a:lstStyle/>
             <a:p>
-              <a:pPr algn="l" marL="77735" indent="-77735">
+              <a:pPr marL="77735" indent="-77735" algn="l">
                 <a:buClr>
                   <a:srgbClr val="334155"/>
                 </a:buClr>
@@ -4325,7 +4259,7 @@
             </a:bodyPr>
             <a:lstStyle/>
             <a:p>
-              <a:pPr algn="l" marL="77735" indent="-77735">
+              <a:pPr marL="77735" indent="-77735" algn="l">
                 <a:buClr>
                   <a:srgbClr val="334155"/>
                 </a:buClr>
@@ -4484,9 +4418,18 @@
   <p:clrMapOvr>
     <a:masterClrMapping/>
   </p:clrMapOvr>
-  <p:transition xmlns:p14="http://schemas.microsoft.com/office/powerpoint/2010/main" p14:dur="400">
-    <p:fade/>
-  </p:transition>
+  <mc:AlternateContent xmlns:mc="http://schemas.openxmlformats.org/markup-compatibility/2006">
+    <mc:Choice xmlns:p14="http://schemas.microsoft.com/office/powerpoint/2010/main" Requires="p14">
+      <p:transition p14:dur="400">
+        <p:fade/>
+      </p:transition>
+    </mc:Choice>
+    <mc:Fallback>
+      <p:transition>
+        <p:fade/>
+      </p:transition>
+    </mc:Fallback>
+  </mc:AlternateContent>
 </p:sld>
 </file>
 
@@ -6688,9 +6631,18 @@
   <p:clrMapOvr>
     <a:masterClrMapping/>
   </p:clrMapOvr>
-  <p:transition xmlns:p14="http://schemas.microsoft.com/office/powerpoint/2010/main" p14:dur="400">
-    <p:fade/>
-  </p:transition>
+  <mc:AlternateContent xmlns:mc="http://schemas.openxmlformats.org/markup-compatibility/2006">
+    <mc:Choice xmlns:p14="http://schemas.microsoft.com/office/powerpoint/2010/main" Requires="p14">
+      <p:transition p14:dur="400">
+        <p:fade/>
+      </p:transition>
+    </mc:Choice>
+    <mc:Fallback>
+      <p:transition>
+        <p:fade/>
+      </p:transition>
+    </mc:Fallback>
+  </mc:AlternateContent>
 </p:sld>
 </file>
 
@@ -6859,9 +6811,9 @@
         <p:grpSpPr>
           <a:xfrm>
             <a:off x="559308" y="641350"/>
-            <a:ext cx="6516601" cy="599059"/>
+            <a:ext cx="6177115" cy="599059"/>
             <a:chOff x="559308" y="641350"/>
-            <a:chExt cx="6516601" cy="599059"/>
+            <a:chExt cx="6177115" cy="599059"/>
           </a:xfrm>
         </p:grpSpPr>
         <p:sp>
@@ -6873,7 +6825,7 @@
           <p:spPr>
             <a:xfrm>
               <a:off x="559308" y="641350"/>
-              <a:ext cx="6516601" cy="469392"/>
+              <a:ext cx="3987374" cy="369332"/>
             </a:xfrm>
             <a:prstGeom prst="rect">
               <a:avLst/>
@@ -6899,7 +6851,26 @@
                   <a:ea typeface="+mn-ea"/>
                   <a:cs typeface="+mn-cs"/>
                 </a:rPr>
-                <a:t>System Design, Microservices &amp; Data Flow</a:t>
+                <a:t>System Design</a:t>
+              </a:r>
+              <a:r>
+                <a:rPr lang="en-US" sz="2400" b="1" dirty="0">
+                  <a:solidFill>
+                    <a:schemeClr val="dk1"/>
+                  </a:solidFill>
+                </a:rPr>
+                <a:t> </a:t>
+              </a:r>
+              <a:r>
+                <a:rPr lang="en-US" sz="2400" b="1" dirty="0">
+                  <a:solidFill>
+                    <a:schemeClr val="dk1"/>
+                  </a:solidFill>
+                  <a:latin typeface="+mn-lt"/>
+                  <a:ea typeface="+mn-ea"/>
+                  <a:cs typeface="+mn-cs"/>
+                </a:rPr>
+                <a:t>&amp; Data Flow</a:t>
               </a:r>
             </a:p>
           </p:txBody>
@@ -7153,7 +7124,7 @@
             <p:nvPr/>
           </p:nvPicPr>
           <p:blipFill>
-            <a:blip r:embed="rId2"/>
+            <a:blip r:embed="rId3"/>
             <a:stretch>
               <a:fillRect/>
             </a:stretch>
@@ -7367,7 +7338,7 @@
             </a:bodyPr>
             <a:lstStyle/>
             <a:p>
-              <a:pPr algn="l" marL="76200" indent="-76200">
+              <a:pPr marL="76200" indent="-76200" algn="l">
                 <a:buClr>
                   <a:srgbClr val="334155"/>
                 </a:buClr>
@@ -7414,7 +7385,7 @@
             </a:bodyPr>
             <a:lstStyle/>
             <a:p>
-              <a:pPr algn="l" marL="76200" indent="-76200">
+              <a:pPr marL="76200" indent="-76200" algn="l">
                 <a:buClr>
                   <a:srgbClr val="334155"/>
                 </a:buClr>
@@ -7461,7 +7432,7 @@
             </a:bodyPr>
             <a:lstStyle/>
             <a:p>
-              <a:pPr algn="l" marL="76200" indent="-76200">
+              <a:pPr marL="76200" indent="-76200" algn="l">
                 <a:buClr>
                   <a:srgbClr val="64748B"/>
                 </a:buClr>
@@ -7682,7 +7653,7 @@
             </a:bodyPr>
             <a:lstStyle/>
             <a:p>
-              <a:pPr algn="l" marL="76200" indent="-76200">
+              <a:pPr marL="76200" indent="-76200" algn="l">
                 <a:buClr>
                   <a:srgbClr val="334155"/>
                 </a:buClr>
@@ -7729,7 +7700,7 @@
             </a:bodyPr>
             <a:lstStyle/>
             <a:p>
-              <a:pPr algn="l" marL="76200" indent="-76200">
+              <a:pPr marL="76200" indent="-76200" algn="l">
                 <a:buClr>
                   <a:srgbClr val="334155"/>
                 </a:buClr>
@@ -7776,7 +7747,7 @@
             </a:bodyPr>
             <a:lstStyle/>
             <a:p>
-              <a:pPr algn="l" marL="76200" indent="-76200">
+              <a:pPr marL="76200" indent="-76200" algn="l">
                 <a:buClr>
                   <a:srgbClr val="64748B"/>
                 </a:buClr>
@@ -7997,7 +7968,7 @@
             </a:bodyPr>
             <a:lstStyle/>
             <a:p>
-              <a:pPr algn="l" marL="76200" indent="-76200">
+              <a:pPr marL="76200" indent="-76200" algn="l">
                 <a:buClr>
                   <a:srgbClr val="334155"/>
                 </a:buClr>
@@ -8044,7 +8015,7 @@
             </a:bodyPr>
             <a:lstStyle/>
             <a:p>
-              <a:pPr algn="l" marL="76200" indent="-76200">
+              <a:pPr marL="76200" indent="-76200" algn="l">
                 <a:buClr>
                   <a:srgbClr val="334155"/>
                 </a:buClr>
@@ -8091,7 +8062,7 @@
             </a:bodyPr>
             <a:lstStyle/>
             <a:p>
-              <a:pPr algn="l" marL="76200" indent="-76200">
+              <a:pPr marL="76200" indent="-76200" algn="l">
                 <a:buClr>
                   <a:srgbClr val="64748B"/>
                 </a:buClr>
@@ -8312,7 +8283,7 @@
             </a:bodyPr>
             <a:lstStyle/>
             <a:p>
-              <a:pPr algn="l" marL="76200" indent="-76200">
+              <a:pPr marL="76200" indent="-76200" algn="l">
                 <a:buClr>
                   <a:srgbClr val="334155"/>
                 </a:buClr>
@@ -8359,7 +8330,7 @@
             </a:bodyPr>
             <a:lstStyle/>
             <a:p>
-              <a:pPr algn="l" marL="76200" indent="-76200">
+              <a:pPr marL="76200" indent="-76200" algn="l">
                 <a:buClr>
                   <a:srgbClr val="334155"/>
                 </a:buClr>
@@ -8406,7 +8377,7 @@
             </a:bodyPr>
             <a:lstStyle/>
             <a:p>
-              <a:pPr algn="l" marL="76200" indent="-76200">
+              <a:pPr marL="76200" indent="-76200" algn="l">
                 <a:buClr>
                   <a:srgbClr val="64748B"/>
                 </a:buClr>
@@ -8565,9 +8536,18 @@
   <p:clrMapOvr>
     <a:masterClrMapping/>
   </p:clrMapOvr>
-  <p:transition xmlns:p14="http://schemas.microsoft.com/office/powerpoint/2010/main" p14:dur="400">
-    <p:fade/>
-  </p:transition>
+  <mc:AlternateContent xmlns:mc="http://schemas.openxmlformats.org/markup-compatibility/2006">
+    <mc:Choice xmlns:p14="http://schemas.microsoft.com/office/powerpoint/2010/main" Requires="p14">
+      <p:transition p14:dur="400">
+        <p:fade/>
+      </p:transition>
+    </mc:Choice>
+    <mc:Fallback>
+      <p:transition>
+        <p:fade/>
+      </p:transition>
+    </mc:Fallback>
+  </mc:AlternateContent>
 </p:sld>
 </file>
 
@@ -9060,7 +9040,7 @@
             </a:bodyPr>
             <a:lstStyle/>
             <a:p>
-              <a:pPr algn="l" marL="125730" indent="-125730">
+              <a:pPr marL="125730" indent="-125730" algn="l">
                 <a:buClr>
                   <a:srgbClr val="1D4ED8"/>
                 </a:buClr>
@@ -9107,7 +9087,7 @@
             </a:bodyPr>
             <a:lstStyle/>
             <a:p>
-              <a:pPr algn="l" marL="125730" indent="-125730">
+              <a:pPr marL="125730" indent="-125730" algn="l">
                 <a:buClr>
                   <a:srgbClr val="1D4ED8"/>
                 </a:buClr>
@@ -9154,7 +9134,7 @@
             </a:bodyPr>
             <a:lstStyle/>
             <a:p>
-              <a:pPr algn="l" marL="76200" indent="-76200">
+              <a:pPr marL="76200" indent="-76200" algn="l">
                 <a:buClr>
                   <a:srgbClr val="64748B"/>
                 </a:buClr>
@@ -11206,7 +11186,7 @@
             </a:bodyPr>
             <a:lstStyle/>
             <a:p>
-              <a:pPr algn="l" marL="76200" indent="-76200">
+              <a:pPr marL="76200" indent="-76200" algn="l">
                 <a:buClr>
                   <a:srgbClr val="047857"/>
                 </a:buClr>
@@ -12572,9 +12552,18 @@
   <p:clrMapOvr>
     <a:masterClrMapping/>
   </p:clrMapOvr>
-  <p:transition xmlns:p14="http://schemas.microsoft.com/office/powerpoint/2010/main" p14:dur="400">
-    <p:fade/>
-  </p:transition>
+  <mc:AlternateContent xmlns:mc="http://schemas.openxmlformats.org/markup-compatibility/2006">
+    <mc:Choice xmlns:p14="http://schemas.microsoft.com/office/powerpoint/2010/main" Requires="p14">
+      <p:transition p14:dur="400">
+        <p:fade/>
+      </p:transition>
+    </mc:Choice>
+    <mc:Fallback>
+      <p:transition>
+        <p:fade/>
+      </p:transition>
+    </mc:Fallback>
+  </mc:AlternateContent>
 </p:sld>
 </file>
 
@@ -15032,7 +15021,7 @@
             </a:bodyPr>
             <a:lstStyle/>
             <a:p>
-              <a:pPr algn="l" marL="76200" indent="-76200">
+              <a:pPr marL="76200" indent="-76200" algn="l">
                 <a:buClr>
                   <a:srgbClr val="334155"/>
                 </a:buClr>
@@ -15079,7 +15068,7 @@
             </a:bodyPr>
             <a:lstStyle/>
             <a:p>
-              <a:pPr algn="l" marL="76200" indent="-76200">
+              <a:pPr marL="76200" indent="-76200" algn="l">
                 <a:buClr>
                   <a:srgbClr val="64748B"/>
                 </a:buClr>
@@ -15247,7 +15236,7 @@
             </a:bodyPr>
             <a:lstStyle/>
             <a:p>
-              <a:pPr algn="l" marL="76200" indent="-76200">
+              <a:pPr marL="76200" indent="-76200" algn="l">
                 <a:buClr>
                   <a:srgbClr val="334155"/>
                 </a:buClr>
@@ -15294,7 +15283,7 @@
             </a:bodyPr>
             <a:lstStyle/>
             <a:p>
-              <a:pPr algn="l" marL="76200" indent="-76200">
+              <a:pPr marL="76200" indent="-76200" algn="l">
                 <a:buClr>
                   <a:schemeClr val="accent3"/>
                 </a:buClr>
@@ -15462,7 +15451,7 @@
             </a:bodyPr>
             <a:lstStyle/>
             <a:p>
-              <a:pPr algn="l" marL="76200" indent="-76200">
+              <a:pPr marL="76200" indent="-76200" algn="l">
                 <a:buClr>
                   <a:srgbClr val="334155"/>
                 </a:buClr>
@@ -15509,7 +15498,7 @@
             </a:bodyPr>
             <a:lstStyle/>
             <a:p>
-              <a:pPr algn="l" marL="76200" indent="-76200">
+              <a:pPr marL="76200" indent="-76200" algn="l">
                 <a:buClr>
                   <a:schemeClr val="accent2"/>
                 </a:buClr>
@@ -15677,7 +15666,7 @@
             </a:bodyPr>
             <a:lstStyle/>
             <a:p>
-              <a:pPr algn="l" marL="76200" indent="-76200">
+              <a:pPr marL="76200" indent="-76200" algn="l">
                 <a:buClr>
                   <a:srgbClr val="334155"/>
                 </a:buClr>
@@ -15724,7 +15713,7 @@
             </a:bodyPr>
             <a:lstStyle/>
             <a:p>
-              <a:pPr algn="l" marL="76200" indent="-76200">
+              <a:pPr marL="76200" indent="-76200" algn="l">
                 <a:buClr>
                   <a:srgbClr val="047857"/>
                 </a:buClr>
@@ -15883,9 +15872,18 @@
   <p:clrMapOvr>
     <a:masterClrMapping/>
   </p:clrMapOvr>
-  <p:transition xmlns:p14="http://schemas.microsoft.com/office/powerpoint/2010/main" p14:dur="400">
-    <p:fade/>
-  </p:transition>
+  <mc:AlternateContent xmlns:mc="http://schemas.openxmlformats.org/markup-compatibility/2006">
+    <mc:Choice xmlns:p14="http://schemas.microsoft.com/office/powerpoint/2010/main" Requires="p14">
+      <p:transition p14:dur="400">
+        <p:fade/>
+      </p:transition>
+    </mc:Choice>
+    <mc:Fallback>
+      <p:transition>
+        <p:fade/>
+      </p:transition>
+    </mc:Fallback>
+  </mc:AlternateContent>
 </p:sld>
 </file>
 
@@ -16900,7 +16898,7 @@
             </a:bodyPr>
             <a:lstStyle/>
             <a:p>
-              <a:pPr algn="l" marL="76200" indent="-76200">
+              <a:pPr marL="76200" indent="-76200" algn="l">
                 <a:buClr>
                   <a:srgbClr val="334155"/>
                 </a:buClr>
@@ -16947,7 +16945,7 @@
             </a:bodyPr>
             <a:lstStyle/>
             <a:p>
-              <a:pPr algn="l" marL="76200" indent="-76200">
+              <a:pPr marL="76200" indent="-76200" algn="l">
                 <a:buClr>
                   <a:srgbClr val="1D4ED8"/>
                 </a:buClr>
@@ -17730,7 +17728,7 @@
             </a:bodyPr>
             <a:lstStyle/>
             <a:p>
-              <a:pPr algn="l" marL="76200" indent="-76200">
+              <a:pPr marL="76200" indent="-76200" algn="l">
                 <a:buClr>
                   <a:srgbClr val="334155"/>
                 </a:buClr>
@@ -17777,7 +17775,7 @@
             </a:bodyPr>
             <a:lstStyle/>
             <a:p>
-              <a:pPr algn="l" marL="76200" indent="-76200">
+              <a:pPr marL="76200" indent="-76200" algn="l">
                 <a:buClr>
                   <a:srgbClr val="047857"/>
                 </a:buClr>
@@ -18560,7 +18558,7 @@
             </a:bodyPr>
             <a:lstStyle/>
             <a:p>
-              <a:pPr algn="l" marL="76200" indent="-76200">
+              <a:pPr marL="76200" indent="-76200" algn="l">
                 <a:buClr>
                   <a:srgbClr val="334155"/>
                 </a:buClr>
@@ -18607,7 +18605,7 @@
             </a:bodyPr>
             <a:lstStyle/>
             <a:p>
-              <a:pPr algn="l" marL="76200" indent="-76200">
+              <a:pPr marL="76200" indent="-76200" algn="l">
                 <a:buClr>
                   <a:srgbClr val="92400E"/>
                 </a:buClr>
@@ -18766,9 +18764,18 @@
   <p:clrMapOvr>
     <a:masterClrMapping/>
   </p:clrMapOvr>
-  <p:transition xmlns:p14="http://schemas.microsoft.com/office/powerpoint/2010/main" p14:dur="400">
-    <p:fade/>
-  </p:transition>
+  <mc:AlternateContent xmlns:mc="http://schemas.openxmlformats.org/markup-compatibility/2006">
+    <mc:Choice xmlns:p14="http://schemas.microsoft.com/office/powerpoint/2010/main" Requires="p14">
+      <p:transition p14:dur="400">
+        <p:fade/>
+      </p:transition>
+    </mc:Choice>
+    <mc:Fallback>
+      <p:transition>
+        <p:fade/>
+      </p:transition>
+    </mc:Fallback>
+  </mc:AlternateContent>
 </p:sld>
 </file>
 
@@ -20388,7 +20395,7 @@
             </a:bodyPr>
             <a:lstStyle/>
             <a:p>
-              <a:pPr algn="l" marL="76200" indent="-76200">
+              <a:pPr marL="76200" indent="-76200" algn="l">
                 <a:buClr>
                   <a:srgbClr val="334155"/>
                 </a:buClr>
@@ -20435,7 +20442,7 @@
             </a:bodyPr>
             <a:lstStyle/>
             <a:p>
-              <a:pPr algn="l" marL="76200" indent="-76200">
+              <a:pPr marL="76200" indent="-76200" algn="l">
                 <a:buClr>
                   <a:srgbClr val="334155"/>
                 </a:buClr>
@@ -20482,7 +20489,7 @@
             </a:bodyPr>
             <a:lstStyle/>
             <a:p>
-              <a:pPr algn="l" marL="76200" indent="-76200">
+              <a:pPr marL="76200" indent="-76200" algn="l">
                 <a:buClr>
                   <a:srgbClr val="64748B"/>
                 </a:buClr>
@@ -20661,7 +20668,7 @@
             </a:bodyPr>
             <a:lstStyle/>
             <a:p>
-              <a:pPr algn="l" marL="76200" indent="-76200">
+              <a:pPr marL="76200" indent="-76200" algn="l">
                 <a:buClr>
                   <a:srgbClr val="334155"/>
                 </a:buClr>
@@ -20708,7 +20715,7 @@
             </a:bodyPr>
             <a:lstStyle/>
             <a:p>
-              <a:pPr algn="l" marL="76200" indent="-76200">
+              <a:pPr marL="76200" indent="-76200" algn="l">
                 <a:buClr>
                   <a:srgbClr val="334155"/>
                 </a:buClr>
@@ -20755,7 +20762,7 @@
             </a:bodyPr>
             <a:lstStyle/>
             <a:p>
-              <a:pPr algn="l" marL="76200" indent="-76200">
+              <a:pPr marL="76200" indent="-76200" algn="l">
                 <a:buClr>
                   <a:srgbClr val="64748B"/>
                 </a:buClr>
@@ -20934,7 +20941,7 @@
             </a:bodyPr>
             <a:lstStyle/>
             <a:p>
-              <a:pPr algn="l" marL="76200" indent="-76200">
+              <a:pPr marL="76200" indent="-76200" algn="l">
                 <a:buClr>
                   <a:srgbClr val="334155"/>
                 </a:buClr>
@@ -20981,7 +20988,7 @@
             </a:bodyPr>
             <a:lstStyle/>
             <a:p>
-              <a:pPr algn="l" marL="76200" indent="-76200">
+              <a:pPr marL="76200" indent="-76200" algn="l">
                 <a:buClr>
                   <a:srgbClr val="334155"/>
                 </a:buClr>
@@ -21028,7 +21035,7 @@
             </a:bodyPr>
             <a:lstStyle/>
             <a:p>
-              <a:pPr algn="l" marL="76200" indent="-76200">
+              <a:pPr marL="76200" indent="-76200" algn="l">
                 <a:buClr>
                   <a:srgbClr val="64748B"/>
                 </a:buClr>
@@ -21207,7 +21214,7 @@
             </a:bodyPr>
             <a:lstStyle/>
             <a:p>
-              <a:pPr algn="l" marL="76200" indent="-76200">
+              <a:pPr marL="76200" indent="-76200" algn="l">
                 <a:buClr>
                   <a:srgbClr val="334155"/>
                 </a:buClr>
@@ -21254,7 +21261,7 @@
             </a:bodyPr>
             <a:lstStyle/>
             <a:p>
-              <a:pPr algn="l" marL="76200" indent="-76200">
+              <a:pPr marL="76200" indent="-76200" algn="l">
                 <a:buClr>
                   <a:srgbClr val="334155"/>
                 </a:buClr>
@@ -21301,7 +21308,7 @@
             </a:bodyPr>
             <a:lstStyle/>
             <a:p>
-              <a:pPr algn="l" marL="76200" indent="-76200">
+              <a:pPr marL="76200" indent="-76200" algn="l">
                 <a:buClr>
                   <a:srgbClr val="64748B"/>
                 </a:buClr>
@@ -21526,9 +21533,18 @@
   <p:clrMapOvr>
     <a:masterClrMapping/>
   </p:clrMapOvr>
-  <p:transition xmlns:p14="http://schemas.microsoft.com/office/powerpoint/2010/main" p14:dur="400">
-    <p:fade/>
-  </p:transition>
+  <mc:AlternateContent xmlns:mc="http://schemas.openxmlformats.org/markup-compatibility/2006">
+    <mc:Choice xmlns:p14="http://schemas.microsoft.com/office/powerpoint/2010/main" Requires="p14">
+      <p:transition p14:dur="400">
+        <p:fade/>
+      </p:transition>
+    </mc:Choice>
+    <mc:Fallback>
+      <p:transition>
+        <p:fade/>
+      </p:transition>
+    </mc:Fallback>
+  </mc:AlternateContent>
 </p:sld>
 </file>
 

</xml_diff>

<commit_message>
changes in ppt and readme
</commit_message>
<xml_diff>
--- a/docs/presentation.pptx
+++ b/docs/presentation.pptx
@@ -348,7 +348,12 @@
             <p:ph type="sldImg" idx="2"/>
           </p:nvPr>
         </p:nvSpPr>
-        <p:spPr/>
+        <p:spPr>
+          <a:xfrm>
+            <a:off x="381000" y="685800"/>
+            <a:ext cx="6096000" cy="3429000"/>
+          </a:xfrm>
+        </p:spPr>
       </p:sp>
       <p:sp>
         <p:nvSpPr>
@@ -638,7 +643,12 @@
             <p:ph type="sldImg" idx="2"/>
           </p:nvPr>
         </p:nvSpPr>
-        <p:spPr/>
+        <p:spPr>
+          <a:xfrm>
+            <a:off x="381000" y="685800"/>
+            <a:ext cx="6096000" cy="3429000"/>
+          </a:xfrm>
+        </p:spPr>
       </p:sp>
       <p:sp>
         <p:nvSpPr>
@@ -775,7 +785,12 @@
             <p:ph type="sldImg" idx="2"/>
           </p:nvPr>
         </p:nvSpPr>
-        <p:spPr/>
+        <p:spPr>
+          <a:xfrm>
+            <a:off x="381000" y="685800"/>
+            <a:ext cx="6096000" cy="3429000"/>
+          </a:xfrm>
+        </p:spPr>
       </p:sp>
       <p:sp>
         <p:nvSpPr>
@@ -927,7 +942,12 @@
             <p:ph type="sldImg" idx="2"/>
           </p:nvPr>
         </p:nvSpPr>
-        <p:spPr/>
+        <p:spPr>
+          <a:xfrm>
+            <a:off x="381000" y="685800"/>
+            <a:ext cx="6096000" cy="3429000"/>
+          </a:xfrm>
+        </p:spPr>
       </p:sp>
       <p:sp>
         <p:nvSpPr>
@@ -1031,7 +1051,12 @@
             <p:ph type="sldImg" idx="2"/>
           </p:nvPr>
         </p:nvSpPr>
-        <p:spPr/>
+        <p:spPr>
+          <a:xfrm>
+            <a:off x="381000" y="685800"/>
+            <a:ext cx="6096000" cy="3429000"/>
+          </a:xfrm>
+        </p:spPr>
       </p:sp>
       <p:sp>
         <p:nvSpPr>
@@ -1178,7 +1203,7 @@
           <a:p>
             <a:fld id="{5BCAD085-E8A6-8845-BD4E-CB4CCA059FC4}" type="datetimeFigureOut">
               <a:rPr lang="en-US" smtClean="0"/>
-              <a:t>10/6/2026</a:t>
+              <a:t>10/8/2026</a:t>
             </a:fld>
             <a:endParaRPr lang="en-US"/>
           </a:p>
@@ -1291,7 +1316,7 @@
           <a:p>
             <a:fld id="{5BCAD085-E8A6-8845-BD4E-CB4CCA059FC4}" type="datetimeFigureOut">
               <a:rPr lang="en-US" smtClean="0"/>
-              <a:t>10/6/2026</a:t>
+              <a:t>10/8/2026</a:t>
             </a:fld>
             <a:endParaRPr lang="en-US"/>
           </a:p>
@@ -3163,7 +3188,7 @@
           <p:spPr>
             <a:xfrm>
               <a:off x="5243512" y="3876675"/>
-              <a:ext cx="1762244" cy="176212"/>
+              <a:ext cx="1653979" cy="138499"/>
             </a:xfrm>
             <a:prstGeom prst="rect">
               <a:avLst/>
@@ -3196,7 +3221,7 @@
                   <a:ea typeface="+mn-ea"/>
                   <a:cs typeface="+mn-cs"/>
                 </a:rPr>
-                <a:t>React 18 + Vite 5 Interactive UI</a:t>
+                <a:t>React 19 + Vite 8 Interactive UI</a:t>
               </a:r>
             </a:p>
           </p:txBody>
@@ -4189,60 +4214,13 @@
         </p:sp>
         <p:sp>
           <p:nvSpPr>
-            <p:cNvPr id="70" name="TextBox 70"/>
-            <p:cNvSpPr txBox="1"/>
-            <p:nvPr/>
-          </p:nvSpPr>
-          <p:spPr>
-            <a:xfrm>
-              <a:off x="8624888" y="5505450"/>
-              <a:ext cx="1648606" cy="176212"/>
-            </a:xfrm>
-            <a:prstGeom prst="rect">
-              <a:avLst/>
-            </a:prstGeom>
-            <a:noFill/>
-            <a:ln>
-              <a:noFill/>
-            </a:ln>
-          </p:spPr>
-          <p:txBody>
-            <a:bodyPr wrap="none" lIns="0" tIns="0" rIns="0" bIns="0" anchor="t" anchorCtr="0">
-              <a:spAutoFit/>
-            </a:bodyPr>
-            <a:lstStyle/>
-            <a:p>
-              <a:pPr marL="77735" indent="-77735" algn="l">
-                <a:buClr>
-                  <a:srgbClr val="334155"/>
-                </a:buClr>
-                <a:buSzTx/>
-                <a:buFontTx/>
-                <a:buChar char="•"/>
-              </a:pPr>
-              <a:r>
-                <a:rPr lang="en-US" sz="900" dirty="0">
-                  <a:solidFill>
-                    <a:srgbClr val="334155"/>
-                  </a:solidFill>
-                  <a:latin typeface="+mn-lt"/>
-                  <a:ea typeface="+mn-ea"/>
-                  <a:cs typeface="+mn-cs"/>
-                </a:rPr>
-                <a:t>End-to-End Latency: &lt; 75 ms</a:t>
-              </a:r>
-            </a:p>
-          </p:txBody>
-        </p:sp>
-        <p:sp>
-          <p:nvSpPr>
             <p:cNvPr id="71" name="TextBox 71"/>
             <p:cNvSpPr txBox="1"/>
             <p:nvPr/>
           </p:nvSpPr>
           <p:spPr>
             <a:xfrm>
-              <a:off x="8624888" y="5715000"/>
+              <a:off x="8624888" y="5515717"/>
               <a:ext cx="1949074" cy="176212"/>
             </a:xfrm>
             <a:prstGeom prst="rect">
@@ -4418,13 +4396,13 @@
   <p:clrMapOvr>
     <a:masterClrMapping/>
   </p:clrMapOvr>
-  <mc:AlternateContent xmlns:mc="http://schemas.openxmlformats.org/markup-compatibility/2006">
-    <mc:Choice xmlns:p14="http://schemas.microsoft.com/office/powerpoint/2010/main" Requires="p14">
+  <mc:AlternateContent xmlns:mc="http://schemas.openxmlformats.org/markup-compatibility/2006" xmlns:p14="http://schemas.microsoft.com/office/powerpoint/2010/main">
+    <mc:Choice Requires="p14">
       <p:transition p14:dur="400">
         <p:fade/>
       </p:transition>
     </mc:Choice>
-    <mc:Fallback>
+    <mc:Fallback xmlns="">
       <p:transition>
         <p:fade/>
       </p:transition>
@@ -6631,13 +6609,13 @@
   <p:clrMapOvr>
     <a:masterClrMapping/>
   </p:clrMapOvr>
-  <mc:AlternateContent xmlns:mc="http://schemas.openxmlformats.org/markup-compatibility/2006">
-    <mc:Choice xmlns:p14="http://schemas.microsoft.com/office/powerpoint/2010/main" Requires="p14">
+  <mc:AlternateContent xmlns:mc="http://schemas.openxmlformats.org/markup-compatibility/2006" xmlns:p14="http://schemas.microsoft.com/office/powerpoint/2010/main">
+    <mc:Choice Requires="p14">
       <p:transition p14:dur="400">
         <p:fade/>
       </p:transition>
     </mc:Choice>
-    <mc:Fallback>
+    <mc:Fallback xmlns="">
       <p:transition>
         <p:fade/>
       </p:transition>
@@ -8227,7 +8205,7 @@
           <p:spPr>
             <a:xfrm>
               <a:off x="8472488" y="5422900"/>
-              <a:ext cx="1987572" cy="176212"/>
+              <a:ext cx="1859483" cy="138499"/>
             </a:xfrm>
             <a:prstGeom prst="rect">
               <a:avLst/>
@@ -8253,21 +8231,21 @@
                   <a:ea typeface="Consolas"/>
                   <a:cs typeface="Consolas"/>
                 </a:rPr>
-                <a:t>React 18 + Vite 5 SPA (:5173)</a:t>
-              </a:r>
-            </a:p>
-          </p:txBody>
-        </p:sp>
-        <p:sp>
-          <p:nvSpPr>
-            <p:cNvPr id="45" name="TextBox 45"/>
-            <p:cNvSpPr txBox="1"/>
-            <p:nvPr/>
-          </p:nvSpPr>
-          <p:spPr>
-            <a:xfrm>
-              <a:off x="8472488" y="5613400"/>
-              <a:ext cx="1505533" cy="161925"/>
+                <a:t>React 19 + Vite 9 SPA (:5173)</a:t>
+              </a:r>
+            </a:p>
+          </p:txBody>
+        </p:sp>
+        <p:sp>
+          <p:nvSpPr>
+            <p:cNvPr id="46" name="TextBox 46"/>
+            <p:cNvSpPr txBox="1"/>
+            <p:nvPr/>
+          </p:nvSpPr>
+          <p:spPr>
+            <a:xfrm>
+              <a:off x="8472488" y="5632836"/>
+              <a:ext cx="2034492" cy="161925"/>
             </a:xfrm>
             <a:prstGeom prst="rect">
               <a:avLst/>
@@ -8300,53 +8278,6 @@
                   <a:ea typeface="+mn-ea"/>
                   <a:cs typeface="+mn-cs"/>
                 </a:rPr>
-                <a:t>Interactive Financial Terminal</a:t>
-              </a:r>
-            </a:p>
-          </p:txBody>
-        </p:sp>
-        <p:sp>
-          <p:nvSpPr>
-            <p:cNvPr id="46" name="TextBox 46"/>
-            <p:cNvSpPr txBox="1"/>
-            <p:nvPr/>
-          </p:nvSpPr>
-          <p:spPr>
-            <a:xfrm>
-              <a:off x="8472488" y="5784850"/>
-              <a:ext cx="2034492" cy="161925"/>
-            </a:xfrm>
-            <a:prstGeom prst="rect">
-              <a:avLst/>
-            </a:prstGeom>
-            <a:noFill/>
-            <a:ln>
-              <a:noFill/>
-            </a:ln>
-          </p:spPr>
-          <p:txBody>
-            <a:bodyPr wrap="none" lIns="0" tIns="0" rIns="0" bIns="0" anchor="t" anchorCtr="0">
-              <a:spAutoFit/>
-            </a:bodyPr>
-            <a:lstStyle/>
-            <a:p>
-              <a:pPr marL="76200" indent="-76200" algn="l">
-                <a:buClr>
-                  <a:srgbClr val="334155"/>
-                </a:buClr>
-                <a:buSzTx/>
-                <a:buFontTx/>
-                <a:buChar char="•"/>
-              </a:pPr>
-              <a:r>
-                <a:rPr lang="en-US" sz="820" dirty="0">
-                  <a:solidFill>
-                    <a:srgbClr val="334155"/>
-                  </a:solidFill>
-                  <a:latin typeface="+mn-lt"/>
-                  <a:ea typeface="+mn-ea"/>
-                  <a:cs typeface="+mn-cs"/>
-                </a:rPr>
                 <a:t>Recharts Waterfall Drawdowns &amp; Deltas</a:t>
               </a:r>
             </a:p>
@@ -8360,7 +8291,7 @@
           </p:nvSpPr>
           <p:spPr>
             <a:xfrm>
-              <a:off x="8472488" y="5956300"/>
+              <a:off x="8472488" y="5813804"/>
               <a:ext cx="2001569" cy="161925"/>
             </a:xfrm>
             <a:prstGeom prst="rect">
@@ -8536,13 +8467,13 @@
   <p:clrMapOvr>
     <a:masterClrMapping/>
   </p:clrMapOvr>
-  <mc:AlternateContent xmlns:mc="http://schemas.openxmlformats.org/markup-compatibility/2006">
-    <mc:Choice xmlns:p14="http://schemas.microsoft.com/office/powerpoint/2010/main" Requires="p14">
+  <mc:AlternateContent xmlns:mc="http://schemas.openxmlformats.org/markup-compatibility/2006" xmlns:p14="http://schemas.microsoft.com/office/powerpoint/2010/main">
+    <mc:Choice Requires="p14">
       <p:transition p14:dur="400">
         <p:fade/>
       </p:transition>
     </mc:Choice>
-    <mc:Fallback>
+    <mc:Fallback xmlns="">
       <p:transition>
         <p:fade/>
       </p:transition>
@@ -8810,7 +8741,7 @@
         </p:nvGrpSpPr>
         <p:grpSpPr>
           <a:xfrm>
-            <a:off x="571500" y="1333500"/>
+            <a:off x="1403147" y="1263362"/>
             <a:ext cx="3486150" cy="4933950"/>
             <a:chOff x="571500" y="1333500"/>
             <a:chExt cx="3486150" cy="4933950"/>
@@ -10336,7 +10267,7 @@
         </p:nvGrpSpPr>
         <p:grpSpPr>
           <a:xfrm>
-            <a:off x="4248150" y="1333500"/>
+            <a:off x="6809234" y="1240409"/>
             <a:ext cx="3486150" cy="4933950"/>
             <a:chOff x="4248150" y="1333500"/>
             <a:chExt cx="3486150" cy="4933950"/>
@@ -11529,895 +11460,6 @@
       </p:grpSp>
       <p:grpSp>
         <p:nvGrpSpPr>
-          <p:cNvPr id="108" name="pillar-quant"/>
-          <p:cNvGrpSpPr/>
-          <p:nvPr/>
-        </p:nvGrpSpPr>
-        <p:grpSpPr>
-          <a:xfrm>
-            <a:off x="7924800" y="1333500"/>
-            <a:ext cx="3695700" cy="4933950"/>
-            <a:chOff x="7924800" y="1333500"/>
-            <a:chExt cx="3695700" cy="4933950"/>
-          </a:xfrm>
-        </p:grpSpPr>
-        <p:sp>
-          <p:nvSpPr>
-            <p:cNvPr id="85" name="Rectangle 85"/>
-            <p:cNvSpPr/>
-            <p:nvPr/>
-          </p:nvSpPr>
-          <p:spPr>
-            <a:xfrm>
-              <a:off x="7924800" y="1333500"/>
-              <a:ext cx="3695700" cy="4933950"/>
-            </a:xfrm>
-            <a:prstGeom prst="roundRect">
-              <a:avLst>
-                <a:gd name="adj" fmla="val 2062"/>
-              </a:avLst>
-            </a:prstGeom>
-            <a:solidFill>
-              <a:srgbClr val="FFFFFF"/>
-            </a:solidFill>
-            <a:ln w="9525">
-              <a:solidFill>
-                <a:schemeClr val="accent6"/>
-              </a:solidFill>
-            </a:ln>
-          </p:spPr>
-        </p:sp>
-        <p:sp>
-          <p:nvSpPr>
-            <p:cNvPr id="86" name="Freeform 86"/>
-            <p:cNvSpPr/>
-            <p:nvPr/>
-          </p:nvSpPr>
-          <p:spPr>
-            <a:xfrm>
-              <a:off x="7924800" y="1333500"/>
-              <a:ext cx="3695700" cy="342900"/>
-            </a:xfrm>
-            <a:custGeom>
-              <a:avLst/>
-              <a:gdLst/>
-              <a:ahLst/>
-              <a:cxnLst/>
-              <a:rect l="l" t="t" r="r" b="b"/>
-              <a:pathLst>
-                <a:path w="3695700" h="342900">
-                  <a:moveTo>
-                    <a:pt x="0" y="76200"/>
-                  </a:moveTo>
-                  <a:cubicBezTo>
-                    <a:pt x="0" y="25400"/>
-                    <a:pt x="25400" y="0"/>
-                    <a:pt x="76200" y="0"/>
-                  </a:cubicBezTo>
-                  <a:lnTo>
-                    <a:pt x="3619500" y="0"/>
-                  </a:lnTo>
-                  <a:cubicBezTo>
-                    <a:pt x="3670300" y="0"/>
-                    <a:pt x="3695700" y="25400"/>
-                    <a:pt x="3695700" y="76200"/>
-                  </a:cubicBezTo>
-                  <a:lnTo>
-                    <a:pt x="3695700" y="342900"/>
-                  </a:lnTo>
-                  <a:lnTo>
-                    <a:pt x="0" y="342900"/>
-                  </a:lnTo>
-                  <a:close/>
-                </a:path>
-              </a:pathLst>
-            </a:custGeom>
-            <a:solidFill>
-              <a:srgbClr val="FFFBEB"/>
-            </a:solidFill>
-            <a:ln>
-              <a:noFill/>
-            </a:ln>
-          </p:spPr>
-        </p:sp>
-        <p:sp>
-          <p:nvSpPr>
-            <p:cNvPr id="87" name="TextBox 87"/>
-            <p:cNvSpPr txBox="1"/>
-            <p:nvPr/>
-          </p:nvSpPr>
-          <p:spPr>
-            <a:xfrm>
-              <a:off x="8091488" y="1438275"/>
-              <a:ext cx="2832419" cy="176212"/>
-            </a:xfrm>
-            <a:prstGeom prst="rect">
-              <a:avLst/>
-            </a:prstGeom>
-            <a:noFill/>
-            <a:ln>
-              <a:noFill/>
-            </a:ln>
-          </p:spPr>
-          <p:txBody>
-            <a:bodyPr wrap="none" lIns="0" tIns="0" rIns="0" bIns="0" anchor="t" anchorCtr="0">
-              <a:spAutoFit/>
-            </a:bodyPr>
-            <a:lstStyle/>
-            <a:p>
-              <a:pPr algn="l"/>
-              <a:r>
-                <a:rPr lang="en-US" sz="900" b="1" spc="75" dirty="0">
-                  <a:solidFill>
-                    <a:srgbClr val="92400E"/>
-                  </a:solidFill>
-                  <a:latin typeface="+mn-lt"/>
-                  <a:ea typeface="+mn-ea"/>
-                  <a:cs typeface="+mn-cs"/>
-                </a:rPr>
-                <a:t>3. MULTI-ASSET QUANTITATIVE SHOCKS</a:t>
-              </a:r>
-            </a:p>
-          </p:txBody>
-        </p:sp>
-        <p:sp>
-          <p:nvSpPr>
-            <p:cNvPr id="88" name="Rectangle 88"/>
-            <p:cNvSpPr/>
-            <p:nvPr/>
-          </p:nvSpPr>
-          <p:spPr>
-            <a:xfrm>
-              <a:off x="8096250" y="1809750"/>
-              <a:ext cx="3352800" cy="742950"/>
-            </a:xfrm>
-            <a:prstGeom prst="roundRect">
-              <a:avLst>
-                <a:gd name="adj" fmla="val 7692"/>
-              </a:avLst>
-            </a:prstGeom>
-            <a:solidFill>
-              <a:schemeClr val="lt1"/>
-            </a:solidFill>
-            <a:ln w="9525">
-              <a:solidFill>
-                <a:srgbClr val="E2E8F0"/>
-              </a:solidFill>
-            </a:ln>
-          </p:spPr>
-        </p:sp>
-        <p:sp>
-          <p:nvSpPr>
-            <p:cNvPr id="89" name="TextBox 89"/>
-            <p:cNvSpPr txBox="1"/>
-            <p:nvPr/>
-          </p:nvSpPr>
-          <p:spPr>
-            <a:xfrm>
-              <a:off x="8186738" y="1898650"/>
-              <a:ext cx="2578159" cy="161925"/>
-            </a:xfrm>
-            <a:prstGeom prst="rect">
-              <a:avLst/>
-            </a:prstGeom>
-            <a:noFill/>
-            <a:ln>
-              <a:noFill/>
-            </a:ln>
-          </p:spPr>
-          <p:txBody>
-            <a:bodyPr wrap="none" lIns="0" tIns="0" rIns="0" bIns="0" anchor="t" anchorCtr="0">
-              <a:spAutoFit/>
-            </a:bodyPr>
-            <a:lstStyle/>
-            <a:p>
-              <a:pPr algn="l"/>
-              <a:r>
-                <a:rPr lang="en-US" sz="820" b="1" dirty="0">
-                  <a:solidFill>
-                    <a:schemeClr val="dk1"/>
-                  </a:solidFill>
-                  <a:latin typeface="+mn-lt"/>
-                  <a:ea typeface="+mn-ea"/>
-                  <a:cs typeface="+mn-cs"/>
-                </a:rPr>
-                <a:t>BONDS ($220M) — MODIFIED DURATION (A6)</a:t>
-              </a:r>
-            </a:p>
-          </p:txBody>
-        </p:sp>
-        <p:sp>
-          <p:nvSpPr>
-            <p:cNvPr id="90" name="TextBox 90"/>
-            <p:cNvSpPr txBox="1"/>
-            <p:nvPr/>
-          </p:nvSpPr>
-          <p:spPr>
-            <a:xfrm>
-              <a:off x="8186547" y="2095500"/>
-              <a:ext cx="1936516" cy="191643"/>
-            </a:xfrm>
-            <a:prstGeom prst="rect">
-              <a:avLst/>
-            </a:prstGeom>
-            <a:noFill/>
-            <a:ln>
-              <a:noFill/>
-            </a:ln>
-          </p:spPr>
-          <p:txBody>
-            <a:bodyPr wrap="none" lIns="0" tIns="0" rIns="0" bIns="0" anchor="t" anchorCtr="0">
-              <a:spAutoFit/>
-            </a:bodyPr>
-            <a:lstStyle/>
-            <a:p>
-              <a:pPr algn="l"/>
-              <a:r>
-                <a:rPr lang="el-GR" sz="980" b="1" dirty="0">
-                  <a:solidFill>
-                    <a:srgbClr val="1D4ED8"/>
-                  </a:solidFill>
-                  <a:latin typeface="Consolas"/>
-                  <a:ea typeface="Consolas"/>
-                  <a:cs typeface="Consolas"/>
-                </a:rPr>
-                <a:t>ΔP ≈ -D × Δy - SpreadShock</a:t>
-              </a:r>
-            </a:p>
-          </p:txBody>
-        </p:sp>
-        <p:sp>
-          <p:nvSpPr>
-            <p:cNvPr id="91" name="TextBox 91"/>
-            <p:cNvSpPr txBox="1"/>
-            <p:nvPr/>
-          </p:nvSpPr>
-          <p:spPr>
-            <a:xfrm>
-              <a:off x="8186738" y="2298700"/>
-              <a:ext cx="2573662" cy="161925"/>
-            </a:xfrm>
-            <a:prstGeom prst="rect">
-              <a:avLst/>
-            </a:prstGeom>
-            <a:noFill/>
-            <a:ln>
-              <a:noFill/>
-            </a:ln>
-          </p:spPr>
-          <p:txBody>
-            <a:bodyPr wrap="none" lIns="0" tIns="0" rIns="0" bIns="0" anchor="t" anchorCtr="0">
-              <a:spAutoFit/>
-            </a:bodyPr>
-            <a:lstStyle/>
-            <a:p>
-              <a:pPr algn="l"/>
-              <a:r>
-                <a:rPr lang="el-GR" sz="820" dirty="0">
-                  <a:solidFill>
-                    <a:schemeClr val="accent5"/>
-                  </a:solidFill>
-                  <a:latin typeface="+mn-lt"/>
-                  <a:ea typeface="+mn-ea"/>
-                  <a:cs typeface="+mn-cs"/>
-                </a:rPr>
-                <a:t>D: Duration (yrs) | Δy: Yield Shift | Spread: Credit Risk</a:t>
-              </a:r>
-            </a:p>
-          </p:txBody>
-        </p:sp>
-        <p:sp>
-          <p:nvSpPr>
-            <p:cNvPr id="92" name="Rectangle 92"/>
-            <p:cNvSpPr/>
-            <p:nvPr/>
-          </p:nvSpPr>
-          <p:spPr>
-            <a:xfrm>
-              <a:off x="8096250" y="2647950"/>
-              <a:ext cx="3352800" cy="742950"/>
-            </a:xfrm>
-            <a:prstGeom prst="roundRect">
-              <a:avLst>
-                <a:gd name="adj" fmla="val 7692"/>
-              </a:avLst>
-            </a:prstGeom>
-            <a:solidFill>
-              <a:schemeClr val="lt1"/>
-            </a:solidFill>
-            <a:ln w="9525">
-              <a:solidFill>
-                <a:srgbClr val="E2E8F0"/>
-              </a:solidFill>
-            </a:ln>
-          </p:spPr>
-        </p:sp>
-        <p:sp>
-          <p:nvSpPr>
-            <p:cNvPr id="93" name="TextBox 93"/>
-            <p:cNvSpPr txBox="1"/>
-            <p:nvPr/>
-          </p:nvSpPr>
-          <p:spPr>
-            <a:xfrm>
-              <a:off x="8186738" y="2736850"/>
-              <a:ext cx="2634798" cy="161925"/>
-            </a:xfrm>
-            <a:prstGeom prst="rect">
-              <a:avLst/>
-            </a:prstGeom>
-            <a:noFill/>
-            <a:ln>
-              <a:noFill/>
-            </a:ln>
-          </p:spPr>
-          <p:txBody>
-            <a:bodyPr wrap="none" lIns="0" tIns="0" rIns="0" bIns="0" anchor="t" anchorCtr="0">
-              <a:spAutoFit/>
-            </a:bodyPr>
-            <a:lstStyle/>
-            <a:p>
-              <a:pPr algn="l"/>
-              <a:r>
-                <a:rPr lang="en-US" sz="820" b="1" dirty="0">
-                  <a:solidFill>
-                    <a:schemeClr val="dk1"/>
-                  </a:solidFill>
-                  <a:latin typeface="+mn-lt"/>
-                  <a:ea typeface="+mn-ea"/>
-                  <a:cs typeface="+mn-cs"/>
-                </a:rPr>
-                <a:t>EQUITIES ($75M) — BETA MARKET SENSITIVITY</a:t>
-              </a:r>
-            </a:p>
-          </p:txBody>
-        </p:sp>
-        <p:sp>
-          <p:nvSpPr>
-            <p:cNvPr id="94" name="TextBox 94"/>
-            <p:cNvSpPr txBox="1"/>
-            <p:nvPr/>
-          </p:nvSpPr>
-          <p:spPr>
-            <a:xfrm>
-              <a:off x="8186547" y="2933700"/>
-              <a:ext cx="2956544" cy="191643"/>
-            </a:xfrm>
-            <a:prstGeom prst="rect">
-              <a:avLst/>
-            </a:prstGeom>
-            <a:noFill/>
-            <a:ln>
-              <a:noFill/>
-            </a:ln>
-          </p:spPr>
-          <p:txBody>
-            <a:bodyPr wrap="none" lIns="0" tIns="0" rIns="0" bIns="0" anchor="t" anchorCtr="0">
-              <a:spAutoFit/>
-            </a:bodyPr>
-            <a:lstStyle/>
-            <a:p>
-              <a:pPr algn="l"/>
-              <a:r>
-                <a:rPr lang="el-GR" sz="980" b="1" dirty="0">
-                  <a:solidFill>
-                    <a:schemeClr val="accent2"/>
-                  </a:solidFill>
-                  <a:latin typeface="Consolas"/>
-                  <a:ea typeface="Consolas"/>
-                  <a:cs typeface="Consolas"/>
-                </a:rPr>
-                <a:t>ΔP = Value × (β × ΔMarket + SectorShock)</a:t>
-              </a:r>
-            </a:p>
-          </p:txBody>
-        </p:sp>
-        <p:sp>
-          <p:nvSpPr>
-            <p:cNvPr id="95" name="TextBox 95"/>
-            <p:cNvSpPr txBox="1"/>
-            <p:nvPr/>
-          </p:nvSpPr>
-          <p:spPr>
-            <a:xfrm>
-              <a:off x="8186738" y="3136900"/>
-              <a:ext cx="2042077" cy="161925"/>
-            </a:xfrm>
-            <a:prstGeom prst="rect">
-              <a:avLst/>
-            </a:prstGeom>
-            <a:noFill/>
-            <a:ln>
-              <a:noFill/>
-            </a:ln>
-          </p:spPr>
-          <p:txBody>
-            <a:bodyPr wrap="none" lIns="0" tIns="0" rIns="0" bIns="0" anchor="t" anchorCtr="0">
-              <a:spAutoFit/>
-            </a:bodyPr>
-            <a:lstStyle/>
-            <a:p>
-              <a:pPr algn="l"/>
-              <a:r>
-                <a:rPr lang="el-GR" sz="820" dirty="0">
-                  <a:solidFill>
-                    <a:schemeClr val="accent5"/>
-                  </a:solidFill>
-                  <a:latin typeface="+mn-lt"/>
-                  <a:ea typeface="+mn-ea"/>
-                  <a:cs typeface="+mn-cs"/>
-                </a:rPr>
-                <a:t>β: Systematic Beta | ΔMarket: Macro Drop</a:t>
-              </a:r>
-            </a:p>
-          </p:txBody>
-        </p:sp>
-        <p:sp>
-          <p:nvSpPr>
-            <p:cNvPr id="96" name="Rectangle 96"/>
-            <p:cNvSpPr/>
-            <p:nvPr/>
-          </p:nvSpPr>
-          <p:spPr>
-            <a:xfrm>
-              <a:off x="8096250" y="3486150"/>
-              <a:ext cx="3352800" cy="742950"/>
-            </a:xfrm>
-            <a:prstGeom prst="roundRect">
-              <a:avLst>
-                <a:gd name="adj" fmla="val 7692"/>
-              </a:avLst>
-            </a:prstGeom>
-            <a:solidFill>
-              <a:schemeClr val="lt1"/>
-            </a:solidFill>
-            <a:ln w="9525">
-              <a:solidFill>
-                <a:srgbClr val="E2E8F0"/>
-              </a:solidFill>
-            </a:ln>
-          </p:spPr>
-        </p:sp>
-        <p:sp>
-          <p:nvSpPr>
-            <p:cNvPr id="97" name="TextBox 97"/>
-            <p:cNvSpPr txBox="1"/>
-            <p:nvPr/>
-          </p:nvSpPr>
-          <p:spPr>
-            <a:xfrm>
-              <a:off x="8186738" y="3575050"/>
-              <a:ext cx="2643137" cy="161925"/>
-            </a:xfrm>
-            <a:prstGeom prst="rect">
-              <a:avLst/>
-            </a:prstGeom>
-            <a:noFill/>
-            <a:ln>
-              <a:noFill/>
-            </a:ln>
-          </p:spPr>
-          <p:txBody>
-            <a:bodyPr wrap="none" lIns="0" tIns="0" rIns="0" bIns="0" anchor="t" anchorCtr="0">
-              <a:spAutoFit/>
-            </a:bodyPr>
-            <a:lstStyle/>
-            <a:p>
-              <a:pPr algn="l"/>
-              <a:r>
-                <a:rPr lang="en-US" sz="820" b="1" dirty="0">
-                  <a:solidFill>
-                    <a:schemeClr val="dk1"/>
-                  </a:solidFill>
-                  <a:latin typeface="+mn-lt"/>
-                  <a:ea typeface="+mn-ea"/>
-                  <a:cs typeface="+mn-cs"/>
-                </a:rPr>
-                <a:t>LOANS ($110M) — CREDIT RISK PROVISIONING</a:t>
-              </a:r>
-            </a:p>
-          </p:txBody>
-        </p:sp>
-        <p:sp>
-          <p:nvSpPr>
-            <p:cNvPr id="98" name="TextBox 98"/>
-            <p:cNvSpPr txBox="1"/>
-            <p:nvPr/>
-          </p:nvSpPr>
-          <p:spPr>
-            <a:xfrm>
-              <a:off x="8186547" y="3771900"/>
-              <a:ext cx="2978028" cy="191643"/>
-            </a:xfrm>
-            <a:prstGeom prst="rect">
-              <a:avLst/>
-            </a:prstGeom>
-            <a:noFill/>
-            <a:ln>
-              <a:noFill/>
-            </a:ln>
-          </p:spPr>
-          <p:txBody>
-            <a:bodyPr wrap="none" lIns="0" tIns="0" rIns="0" bIns="0" anchor="t" anchorCtr="0">
-              <a:spAutoFit/>
-            </a:bodyPr>
-            <a:lstStyle/>
-            <a:p>
-              <a:pPr algn="l"/>
-              <a:r>
-                <a:rPr lang="el-GR" sz="980" b="1" dirty="0">
-                  <a:solidFill>
-                    <a:srgbClr val="B45309"/>
-                  </a:solidFill>
-                  <a:latin typeface="Consolas"/>
-                  <a:ea typeface="Consolas"/>
-                  <a:cs typeface="Consolas"/>
-                </a:rPr>
-                <a:t>ΔP = -Notional × (ΔPD × LGD + Downgrade)</a:t>
-              </a:r>
-            </a:p>
-          </p:txBody>
-        </p:sp>
-        <p:sp>
-          <p:nvSpPr>
-            <p:cNvPr id="99" name="TextBox 99"/>
-            <p:cNvSpPr txBox="1"/>
-            <p:nvPr/>
-          </p:nvSpPr>
-          <p:spPr>
-            <a:xfrm>
-              <a:off x="8186738" y="3975100"/>
-              <a:ext cx="2096630" cy="161925"/>
-            </a:xfrm>
-            <a:prstGeom prst="rect">
-              <a:avLst/>
-            </a:prstGeom>
-            <a:noFill/>
-            <a:ln>
-              <a:noFill/>
-            </a:ln>
-          </p:spPr>
-          <p:txBody>
-            <a:bodyPr wrap="none" lIns="0" tIns="0" rIns="0" bIns="0" anchor="t" anchorCtr="0">
-              <a:spAutoFit/>
-            </a:bodyPr>
-            <a:lstStyle/>
-            <a:p>
-              <a:pPr algn="l"/>
-              <a:r>
-                <a:rPr lang="en-US" sz="820" dirty="0">
-                  <a:solidFill>
-                    <a:schemeClr val="accent5"/>
-                  </a:solidFill>
-                  <a:latin typeface="+mn-lt"/>
-                  <a:ea typeface="+mn-ea"/>
-                  <a:cs typeface="+mn-cs"/>
-                </a:rPr>
-                <a:t>PD: Default Prob | LGD: Loss Given Default</a:t>
-              </a:r>
-            </a:p>
-          </p:txBody>
-        </p:sp>
-        <p:sp>
-          <p:nvSpPr>
-            <p:cNvPr id="100" name="Rectangle 100"/>
-            <p:cNvSpPr/>
-            <p:nvPr/>
-          </p:nvSpPr>
-          <p:spPr>
-            <a:xfrm>
-              <a:off x="8096250" y="4324350"/>
-              <a:ext cx="3352800" cy="742950"/>
-            </a:xfrm>
-            <a:prstGeom prst="roundRect">
-              <a:avLst>
-                <a:gd name="adj" fmla="val 7692"/>
-              </a:avLst>
-            </a:prstGeom>
-            <a:solidFill>
-              <a:schemeClr val="lt1"/>
-            </a:solidFill>
-            <a:ln w="9525">
-              <a:solidFill>
-                <a:srgbClr val="E2E8F0"/>
-              </a:solidFill>
-            </a:ln>
-          </p:spPr>
-        </p:sp>
-        <p:sp>
-          <p:nvSpPr>
-            <p:cNvPr id="101" name="TextBox 101"/>
-            <p:cNvSpPr txBox="1"/>
-            <p:nvPr/>
-          </p:nvSpPr>
-          <p:spPr>
-            <a:xfrm>
-              <a:off x="8186738" y="4413250"/>
-              <a:ext cx="2647628" cy="161925"/>
-            </a:xfrm>
-            <a:prstGeom prst="rect">
-              <a:avLst/>
-            </a:prstGeom>
-            <a:noFill/>
-            <a:ln>
-              <a:noFill/>
-            </a:ln>
-          </p:spPr>
-          <p:txBody>
-            <a:bodyPr wrap="none" lIns="0" tIns="0" rIns="0" bIns="0" anchor="t" anchorCtr="0">
-              <a:spAutoFit/>
-            </a:bodyPr>
-            <a:lstStyle/>
-            <a:p>
-              <a:pPr algn="l"/>
-              <a:r>
-                <a:rPr lang="en-US" sz="820" b="1" dirty="0">
-                  <a:solidFill>
-                    <a:schemeClr val="dk1"/>
-                  </a:solidFill>
-                  <a:latin typeface="+mn-lt"/>
-                  <a:ea typeface="+mn-ea"/>
-                  <a:cs typeface="+mn-cs"/>
-                </a:rPr>
-                <a:t>DERIVATIVES ($180M) — DELTA-GAMMA-VEGA</a:t>
-              </a:r>
-            </a:p>
-          </p:txBody>
-        </p:sp>
-        <p:sp>
-          <p:nvSpPr>
-            <p:cNvPr id="102" name="TextBox 102"/>
-            <p:cNvSpPr txBox="1"/>
-            <p:nvPr/>
-          </p:nvSpPr>
-          <p:spPr>
-            <a:xfrm>
-              <a:off x="8186547" y="4610100"/>
-              <a:ext cx="2894889" cy="191643"/>
-            </a:xfrm>
-            <a:prstGeom prst="rect">
-              <a:avLst/>
-            </a:prstGeom>
-            <a:noFill/>
-            <a:ln>
-              <a:noFill/>
-            </a:ln>
-          </p:spPr>
-          <p:txBody>
-            <a:bodyPr wrap="none" lIns="0" tIns="0" rIns="0" bIns="0" anchor="t" anchorCtr="0">
-              <a:spAutoFit/>
-            </a:bodyPr>
-            <a:lstStyle/>
-            <a:p>
-              <a:pPr algn="l"/>
-              <a:r>
-                <a:rPr lang="el-GR" sz="980" b="1" dirty="0">
-                  <a:solidFill>
-                    <a:srgbClr val="BE185D"/>
-                  </a:solidFill>
-                  <a:latin typeface="Consolas"/>
-                  <a:ea typeface="Consolas"/>
-                  <a:cs typeface="Consolas"/>
-                </a:rPr>
-                <a:t>ΔP ≈ Δ × ΔS + 0.5 × Γ × (ΔS)² + ν × Δσ</a:t>
-              </a:r>
-            </a:p>
-          </p:txBody>
-        </p:sp>
-        <p:sp>
-          <p:nvSpPr>
-            <p:cNvPr id="103" name="TextBox 103"/>
-            <p:cNvSpPr txBox="1"/>
-            <p:nvPr/>
-          </p:nvSpPr>
-          <p:spPr>
-            <a:xfrm>
-              <a:off x="8186738" y="4813300"/>
-              <a:ext cx="1887221" cy="161925"/>
-            </a:xfrm>
-            <a:prstGeom prst="rect">
-              <a:avLst/>
-            </a:prstGeom>
-            <a:noFill/>
-            <a:ln>
-              <a:noFill/>
-            </a:ln>
-          </p:spPr>
-          <p:txBody>
-            <a:bodyPr wrap="none" lIns="0" tIns="0" rIns="0" bIns="0" anchor="t" anchorCtr="0">
-              <a:spAutoFit/>
-            </a:bodyPr>
-            <a:lstStyle/>
-            <a:p>
-              <a:pPr algn="l"/>
-              <a:r>
-                <a:rPr lang="el-GR" sz="820" dirty="0">
-                  <a:solidFill>
-                    <a:schemeClr val="accent5"/>
-                  </a:solidFill>
-                  <a:latin typeface="+mn-lt"/>
-                  <a:ea typeface="+mn-ea"/>
-                  <a:cs typeface="+mn-cs"/>
-                </a:rPr>
-                <a:t>Δ: Delta | Γ: Gamma | ν: Vega Volatility</a:t>
-              </a:r>
-            </a:p>
-          </p:txBody>
-        </p:sp>
-        <p:sp>
-          <p:nvSpPr>
-            <p:cNvPr id="104" name="Rectangle 104"/>
-            <p:cNvSpPr/>
-            <p:nvPr/>
-          </p:nvSpPr>
-          <p:spPr>
-            <a:xfrm>
-              <a:off x="8096250" y="5162550"/>
-              <a:ext cx="3352800" cy="933450"/>
-            </a:xfrm>
-            <a:prstGeom prst="roundRect">
-              <a:avLst>
-                <a:gd name="adj" fmla="val 6122"/>
-              </a:avLst>
-            </a:prstGeom>
-            <a:solidFill>
-              <a:srgbClr val="EFF6FF"/>
-            </a:solidFill>
-            <a:ln w="9525">
-              <a:solidFill>
-                <a:srgbClr val="BFDBFE"/>
-              </a:solidFill>
-            </a:ln>
-          </p:spPr>
-        </p:sp>
-        <p:sp>
-          <p:nvSpPr>
-            <p:cNvPr id="105" name="TextBox 105"/>
-            <p:cNvSpPr txBox="1"/>
-            <p:nvPr/>
-          </p:nvSpPr>
-          <p:spPr>
-            <a:xfrm>
-              <a:off x="8186738" y="5270500"/>
-              <a:ext cx="2340033" cy="161925"/>
-            </a:xfrm>
-            <a:prstGeom prst="rect">
-              <a:avLst/>
-            </a:prstGeom>
-            <a:noFill/>
-            <a:ln>
-              <a:noFill/>
-            </a:ln>
-          </p:spPr>
-          <p:txBody>
-            <a:bodyPr wrap="none" lIns="0" tIns="0" rIns="0" bIns="0" anchor="t" anchorCtr="0">
-              <a:spAutoFit/>
-            </a:bodyPr>
-            <a:lstStyle/>
-            <a:p>
-              <a:pPr algn="l"/>
-              <a:r>
-                <a:rPr lang="en-US" sz="820" b="1" dirty="0">
-                  <a:solidFill>
-                    <a:schemeClr val="accent1"/>
-                  </a:solidFill>
-                  <a:latin typeface="+mn-lt"/>
-                  <a:ea typeface="+mn-ea"/>
-                  <a:cs typeface="+mn-cs"/>
-                </a:rPr>
-                <a:t>TOTAL PORTFOLIO SHOCK AGGREGATION</a:t>
-              </a:r>
-            </a:p>
-          </p:txBody>
-        </p:sp>
-        <p:sp>
-          <p:nvSpPr>
-            <p:cNvPr id="106" name="TextBox 106"/>
-            <p:cNvSpPr txBox="1"/>
-            <p:nvPr/>
-          </p:nvSpPr>
-          <p:spPr>
-            <a:xfrm>
-              <a:off x="8186547" y="5467350"/>
-              <a:ext cx="3098022" cy="191643"/>
-            </a:xfrm>
-            <a:prstGeom prst="rect">
-              <a:avLst/>
-            </a:prstGeom>
-            <a:noFill/>
-            <a:ln>
-              <a:noFill/>
-            </a:ln>
-          </p:spPr>
-          <p:txBody>
-            <a:bodyPr wrap="none" lIns="0" tIns="0" rIns="0" bIns="0" anchor="t" anchorCtr="0">
-              <a:spAutoFit/>
-            </a:bodyPr>
-            <a:lstStyle/>
-            <a:p>
-              <a:pPr algn="l"/>
-              <a:r>
-                <a:rPr lang="el-GR" sz="980" b="1" dirty="0">
-                  <a:solidFill>
-                    <a:srgbClr val="1D4ED8"/>
-                  </a:solidFill>
-                  <a:latin typeface="Consolas"/>
-                  <a:ea typeface="Consolas"/>
-                  <a:cs typeface="Consolas"/>
-                </a:rPr>
-                <a:t>ΔPortfolio = Σ ΔP_asset + CrossAssetBuffer</a:t>
-              </a:r>
-            </a:p>
-          </p:txBody>
-        </p:sp>
-        <p:sp>
-          <p:nvSpPr>
-            <p:cNvPr id="107" name="TextBox 107"/>
-            <p:cNvSpPr txBox="1"/>
-            <p:nvPr/>
-          </p:nvSpPr>
-          <p:spPr>
-            <a:xfrm>
-              <a:off x="8186738" y="5657850"/>
-              <a:ext cx="2373076" cy="314325"/>
-            </a:xfrm>
-            <a:prstGeom prst="rect">
-              <a:avLst/>
-            </a:prstGeom>
-            <a:noFill/>
-            <a:ln>
-              <a:noFill/>
-            </a:ln>
-          </p:spPr>
-          <p:txBody>
-            <a:bodyPr wrap="none" lIns="0" tIns="0" rIns="0" bIns="0" anchor="t" anchorCtr="0">
-              <a:spAutoFit/>
-            </a:bodyPr>
-            <a:lstStyle/>
-            <a:p>
-              <a:pPr algn="l">
-                <a:lnSpc>
-                  <a:spcPts val="1200"/>
-                </a:lnSpc>
-              </a:pPr>
-              <a:r>
-                <a:rPr lang="en-US" sz="820" dirty="0">
-                  <a:solidFill>
-                    <a:srgbClr val="334155"/>
-                  </a:solidFill>
-                  <a:latin typeface="+mn-lt"/>
-                  <a:ea typeface="+mn-ea"/>
-                  <a:cs typeface="+mn-cs"/>
-                </a:rPr>
-                <a:t>Instantaneous capital shock across all $585M assets</a:t>
-              </a:r>
-              <a:br>
-                <a:rPr lang="en-US" sz="820" dirty="0">
-                  <a:solidFill>
-                    <a:srgbClr val="334155"/>
-                  </a:solidFill>
-                  <a:latin typeface="+mn-lt"/>
-                  <a:ea typeface="+mn-ea"/>
-                  <a:cs typeface="+mn-cs"/>
-                </a:rPr>
-              </a:br>
-              <a:r>
-                <a:rPr lang="en-US" sz="820" dirty="0">
-                  <a:solidFill>
-                    <a:srgbClr val="334155"/>
-                  </a:solidFill>
-                  <a:latin typeface="+mn-lt"/>
-                  <a:ea typeface="+mn-ea"/>
-                  <a:cs typeface="+mn-cs"/>
-                </a:rPr>
-                <a:t>with full traceability and sub-80ms recalculation.</a:t>
-              </a:r>
-            </a:p>
-          </p:txBody>
-        </p:sp>
-      </p:grpSp>
-      <p:grpSp>
-        <p:nvGrpSpPr>
           <p:cNvPr id="112" name="footer"/>
           <p:cNvGrpSpPr/>
           <p:nvPr/>
@@ -12552,13 +11594,13 @@
   <p:clrMapOvr>
     <a:masterClrMapping/>
   </p:clrMapOvr>
-  <mc:AlternateContent xmlns:mc="http://schemas.openxmlformats.org/markup-compatibility/2006">
-    <mc:Choice xmlns:p14="http://schemas.microsoft.com/office/powerpoint/2010/main" Requires="p14">
+  <mc:AlternateContent xmlns:mc="http://schemas.openxmlformats.org/markup-compatibility/2006" xmlns:p14="http://schemas.microsoft.com/office/powerpoint/2010/main">
+    <mc:Choice Requires="p14">
       <p:transition p14:dur="400">
         <p:fade/>
       </p:transition>
     </mc:Choice>
-    <mc:Fallback>
+    <mc:Fallback xmlns="">
       <p:transition>
         <p:fade/>
       </p:transition>
@@ -15180,7 +14222,7 @@
           <p:spPr>
             <a:xfrm>
               <a:off x="3524631" y="5327650"/>
-              <a:ext cx="1144829" cy="352044"/>
+              <a:ext cx="1013098" cy="276999"/>
             </a:xfrm>
             <a:prstGeom prst="rect">
               <a:avLst/>
@@ -15206,7 +14248,29 @@
                   <a:ea typeface="Consolas"/>
                   <a:cs typeface="Consolas"/>
                 </a:rPr>
-                <a:t>-$116.1M</a:t>
+                <a:t>-$</a:t>
+              </a:r>
+              <a:r>
+                <a:rPr lang="en-US" b="1" dirty="0">
+                  <a:solidFill>
+                    <a:schemeClr val="accent3"/>
+                  </a:solidFill>
+                  <a:latin typeface="Consolas"/>
+                  <a:ea typeface="Consolas"/>
+                  <a:cs typeface="Consolas"/>
+                </a:rPr>
+                <a:t>55.44</a:t>
+              </a:r>
+              <a:r>
+                <a:rPr lang="en-US" sz="1800" b="1" dirty="0">
+                  <a:solidFill>
+                    <a:schemeClr val="accent3"/>
+                  </a:solidFill>
+                  <a:latin typeface="Consolas"/>
+                  <a:ea typeface="Consolas"/>
+                  <a:cs typeface="Consolas"/>
+                </a:rPr>
+                <a:t>M</a:t>
               </a:r>
             </a:p>
           </p:txBody>
@@ -15220,7 +14284,7 @@
           <p:spPr>
             <a:xfrm>
               <a:off x="3529012" y="5689600"/>
-              <a:ext cx="1772029" cy="161925"/>
+              <a:ext cx="1678345" cy="126188"/>
             </a:xfrm>
             <a:prstGeom prst="rect">
               <a:avLst/>
@@ -15253,7 +14317,26 @@
                   <a:ea typeface="+mn-ea"/>
                   <a:cs typeface="+mn-cs"/>
                 </a:rPr>
-                <a:t>-19.8% peak-to-trough capital loss</a:t>
+                <a:t>-</a:t>
+              </a:r>
+              <a:r>
+                <a:rPr lang="en-US" sz="820" dirty="0">
+                  <a:solidFill>
+                    <a:srgbClr val="334155"/>
+                  </a:solidFill>
+                </a:rPr>
+                <a:t>9</a:t>
+              </a:r>
+              <a:r>
+                <a:rPr lang="en-US" sz="820" dirty="0">
+                  <a:solidFill>
+                    <a:srgbClr val="334155"/>
+                  </a:solidFill>
+                  <a:latin typeface="+mn-lt"/>
+                  <a:ea typeface="+mn-ea"/>
+                  <a:cs typeface="+mn-cs"/>
+                </a:rPr>
+                <a:t>.48% peak-to-trough capital loss</a:t>
               </a:r>
             </a:p>
           </p:txBody>
@@ -15267,7 +14350,7 @@
           <p:spPr>
             <a:xfrm>
               <a:off x="3529012" y="5880100"/>
-              <a:ext cx="1848205" cy="161925"/>
+              <a:ext cx="1796967" cy="126188"/>
             </a:xfrm>
             <a:prstGeom prst="rect">
               <a:avLst/>
@@ -15300,7 +14383,26 @@
                   <a:ea typeface="+mn-ea"/>
                   <a:cs typeface="+mn-cs"/>
                 </a:rPr>
-                <a:t>Trough portfolio valuation: $468.9M</a:t>
+                <a:t>Trough portfolio valuation: $</a:t>
+              </a:r>
+              <a:r>
+                <a:rPr lang="en-US" sz="820" dirty="0">
+                  <a:solidFill>
+                    <a:schemeClr val="accent3"/>
+                  </a:solidFill>
+                </a:rPr>
+                <a:t>529.56</a:t>
+              </a:r>
+              <a:r>
+                <a:rPr lang="en-US" sz="820" dirty="0">
+                  <a:solidFill>
+                    <a:schemeClr val="accent3"/>
+                  </a:solidFill>
+                  <a:latin typeface="+mn-lt"/>
+                  <a:ea typeface="+mn-ea"/>
+                  <a:cs typeface="+mn-cs"/>
+                </a:rPr>
+                <a:t>M</a:t>
               </a:r>
             </a:p>
           </p:txBody>
@@ -15872,13 +14974,13 @@
   <p:clrMapOvr>
     <a:masterClrMapping/>
   </p:clrMapOvr>
-  <mc:AlternateContent xmlns:mc="http://schemas.openxmlformats.org/markup-compatibility/2006">
-    <mc:Choice xmlns:p14="http://schemas.microsoft.com/office/powerpoint/2010/main" Requires="p14">
+  <mc:AlternateContent xmlns:mc="http://schemas.openxmlformats.org/markup-compatibility/2006" xmlns:p14="http://schemas.microsoft.com/office/powerpoint/2010/main">
+    <mc:Choice Requires="p14">
       <p:transition p14:dur="400">
         <p:fade/>
       </p:transition>
     </mc:Choice>
-    <mc:Fallback>
+    <mc:Fallback xmlns="">
       <p:transition>
         <p:fade/>
       </p:transition>
@@ -18580,53 +17682,6 @@
             </a:p>
           </p:txBody>
         </p:sp>
-        <p:sp>
-          <p:nvSpPr>
-            <p:cNvPr id="64" name="TextBox 64"/>
-            <p:cNvSpPr txBox="1"/>
-            <p:nvPr/>
-          </p:nvSpPr>
-          <p:spPr>
-            <a:xfrm>
-              <a:off x="8186738" y="5861050"/>
-              <a:ext cx="2175400" cy="161925"/>
-            </a:xfrm>
-            <a:prstGeom prst="rect">
-              <a:avLst/>
-            </a:prstGeom>
-            <a:noFill/>
-            <a:ln>
-              <a:noFill/>
-            </a:ln>
-          </p:spPr>
-          <p:txBody>
-            <a:bodyPr wrap="none" lIns="0" tIns="0" rIns="0" bIns="0" anchor="t" anchorCtr="0">
-              <a:spAutoFit/>
-            </a:bodyPr>
-            <a:lstStyle/>
-            <a:p>
-              <a:pPr marL="76200" indent="-76200" algn="l">
-                <a:buClr>
-                  <a:srgbClr val="92400E"/>
-                </a:buClr>
-                <a:buSzTx/>
-                <a:buFontTx/>
-                <a:buChar char="•"/>
-              </a:pPr>
-              <a:r>
-                <a:rPr lang="en-US" sz="820" dirty="0">
-                  <a:solidFill>
-                    <a:srgbClr val="92400E"/>
-                  </a:solidFill>
-                  <a:latin typeface="+mn-lt"/>
-                  <a:ea typeface="+mn-ea"/>
-                  <a:cs typeface="+mn-cs"/>
-                </a:rPr>
-                <a:t>Complete Basel III / FRTB stress audit trails</a:t>
-              </a:r>
-            </a:p>
-          </p:txBody>
-        </p:sp>
       </p:grpSp>
       <p:grpSp>
         <p:nvGrpSpPr>
@@ -18764,13 +17819,13 @@
   <p:clrMapOvr>
     <a:masterClrMapping/>
   </p:clrMapOvr>
-  <mc:AlternateContent xmlns:mc="http://schemas.openxmlformats.org/markup-compatibility/2006">
-    <mc:Choice xmlns:p14="http://schemas.microsoft.com/office/powerpoint/2010/main" Requires="p14">
+  <mc:AlternateContent xmlns:mc="http://schemas.openxmlformats.org/markup-compatibility/2006" xmlns:p14="http://schemas.microsoft.com/office/powerpoint/2010/main">
+    <mc:Choice Requires="p14">
       <p:transition p14:dur="400">
         <p:fade/>
       </p:transition>
     </mc:Choice>
-    <mc:Fallback>
+    <mc:Fallback xmlns="">
       <p:transition>
         <p:fade/>
       </p:transition>
@@ -21238,60 +20293,13 @@
         </p:sp>
         <p:sp>
           <p:nvSpPr>
-            <p:cNvPr id="67" name="TextBox 67"/>
-            <p:cNvSpPr txBox="1"/>
-            <p:nvPr/>
-          </p:nvSpPr>
-          <p:spPr>
-            <a:xfrm>
-              <a:off x="6548438" y="5356225"/>
-              <a:ext cx="3919311" cy="161925"/>
-            </a:xfrm>
-            <a:prstGeom prst="rect">
-              <a:avLst/>
-            </a:prstGeom>
-            <a:noFill/>
-            <a:ln>
-              <a:noFill/>
-            </a:ln>
-          </p:spPr>
-          <p:txBody>
-            <a:bodyPr wrap="none" lIns="0" tIns="0" rIns="0" bIns="0" anchor="t" anchorCtr="0">
-              <a:spAutoFit/>
-            </a:bodyPr>
-            <a:lstStyle/>
-            <a:p>
-              <a:pPr marL="76200" indent="-76200" algn="l">
-                <a:buClr>
-                  <a:srgbClr val="334155"/>
-                </a:buClr>
-                <a:buSzTx/>
-                <a:buFontTx/>
-                <a:buChar char="•"/>
-              </a:pPr>
-              <a:r>
-                <a:rPr lang="en-US" sz="820" dirty="0">
-                  <a:solidFill>
-                    <a:srgbClr val="334155"/>
-                  </a:solidFill>
-                  <a:latin typeface="+mn-lt"/>
-                  <a:ea typeface="+mn-ea"/>
-                  <a:cs typeface="+mn-cs"/>
-                </a:rPr>
-                <a:t>Multi-partition consumer groups scaling to 2,000,000+ financial events/second</a:t>
-              </a:r>
-            </a:p>
-          </p:txBody>
-        </p:sp>
-        <p:sp>
-          <p:nvSpPr>
             <p:cNvPr id="68" name="TextBox 68"/>
             <p:cNvSpPr txBox="1"/>
             <p:nvPr/>
           </p:nvSpPr>
           <p:spPr>
             <a:xfrm>
-              <a:off x="6548438" y="5508625"/>
+              <a:off x="6548438" y="5400675"/>
               <a:ext cx="3845717" cy="161925"/>
             </a:xfrm>
             <a:prstGeom prst="rect">
@@ -21533,13 +20541,13 @@
   <p:clrMapOvr>
     <a:masterClrMapping/>
   </p:clrMapOvr>
-  <mc:AlternateContent xmlns:mc="http://schemas.openxmlformats.org/markup-compatibility/2006">
-    <mc:Choice xmlns:p14="http://schemas.microsoft.com/office/powerpoint/2010/main" Requires="p14">
+  <mc:AlternateContent xmlns:mc="http://schemas.openxmlformats.org/markup-compatibility/2006" xmlns:p14="http://schemas.microsoft.com/office/powerpoint/2010/main">
+    <mc:Choice Requires="p14">
       <p:transition p14:dur="400">
         <p:fade/>
       </p:transition>
     </mc:Choice>
-    <mc:Fallback>
+    <mc:Fallback xmlns="">
       <p:transition>
         <p:fade/>
       </p:transition>

</xml_diff>

<commit_message>
Update presentation and slide images
</commit_message>
<xml_diff>
--- a/docs/presentation.pptx
+++ b/docs/presentation.pptx
@@ -763,14 +763,26 @@
           </a:p>
           <a:p>
             <a:r>
+              <a:rPr lang="en-US" dirty="0" err="1"/>
+              <a:t>VaR_alpha</a:t>
+            </a:r>
+            <a:r>
               <a:rPr lang="en-US" dirty="0"/>
-              <a:t>VaR_alpha equals negative infimum of returns such that cumulative distribution is greater than or equal to 1 minus alpha.</a:t>
+              <a:t> equals negative infimum of returns such that cumulative distribution is greater than or equal to 1 minus alpha.</a:t>
             </a:r>
           </a:p>
           <a:p>
             <a:r>
               <a:rPr lang="en-US" dirty="0"/>
-              <a:t>And CVaR_alpha equals the expected loss given that losses exceed the VaR threshold: E[Loss | Loss &gt;= VaR_alpha].</a:t>
+              <a:t>And CVaR_alpha equals the expected loss given that losses exceed the VaR threshold: E[Loss | Loss &gt;= </a:t>
+            </a:r>
+            <a:r>
+              <a:rPr lang="en-US" dirty="0" err="1"/>
+              <a:t>VaR_alpha</a:t>
+            </a:r>
+            <a:r>
+              <a:rPr lang="en-US" dirty="0"/>
+              <a:t>].</a:t>
             </a:r>
           </a:p>
           <a:p>
@@ -12666,9 +12678,9 @@
         </p:nvGrpSpPr>
         <p:grpSpPr>
           <a:xfrm>
-            <a:off x="571500" y="1333500"/>
-            <a:ext cx="11049000" cy="3429000"/>
-            <a:chOff x="571500" y="1333500"/>
+            <a:off x="1216761" y="1348617"/>
+            <a:ext cx="9449730" cy="3429000"/>
+            <a:chOff x="576263" y="1359008"/>
             <a:chExt cx="11049000" cy="3429000"/>
           </a:xfrm>
         </p:grpSpPr>
@@ -12680,7 +12692,7 @@
           </p:nvSpPr>
           <p:spPr>
             <a:xfrm>
-              <a:off x="571500" y="1333500"/>
+              <a:off x="576263" y="1359008"/>
               <a:ext cx="11049000" cy="3429000"/>
             </a:xfrm>
             <a:prstGeom prst="roundRect">
@@ -12701,7 +12713,7 @@
             <a:bodyPr/>
             <a:lstStyle/>
             <a:p>
-              <a:endParaRPr lang="en-IN"/>
+              <a:endParaRPr lang="en-IN" dirty="0"/>
             </a:p>
           </p:txBody>
         </p:sp>
@@ -13003,7 +13015,7 @@
           </p:nvSpPr>
           <p:spPr>
             <a:xfrm>
-              <a:off x="722236" y="1841500"/>
+              <a:off x="1451888" y="1767093"/>
               <a:ext cx="330276" cy="161925"/>
             </a:xfrm>
             <a:prstGeom prst="rect">
@@ -13086,7 +13098,7 @@
           </p:nvSpPr>
           <p:spPr>
             <a:xfrm>
-              <a:off x="722236" y="2317750"/>
+              <a:off x="1465568" y="2225659"/>
               <a:ext cx="330276" cy="161925"/>
             </a:xfrm>
             <a:prstGeom prst="rect">
@@ -13169,7 +13181,7 @@
           </p:nvSpPr>
           <p:spPr>
             <a:xfrm>
-              <a:off x="722236" y="2794000"/>
+              <a:off x="1436675" y="2742164"/>
               <a:ext cx="330276" cy="161925"/>
             </a:xfrm>
             <a:prstGeom prst="rect">
@@ -13252,7 +13264,7 @@
           </p:nvSpPr>
           <p:spPr>
             <a:xfrm>
-              <a:off x="722236" y="3270250"/>
+              <a:off x="1451888" y="3201987"/>
               <a:ext cx="330276" cy="161925"/>
             </a:xfrm>
             <a:prstGeom prst="rect">
@@ -13335,7 +13347,7 @@
           </p:nvSpPr>
           <p:spPr>
             <a:xfrm>
-              <a:off x="722236" y="3746500"/>
+              <a:off x="1460108" y="3632200"/>
               <a:ext cx="330276" cy="161925"/>
             </a:xfrm>
             <a:prstGeom prst="rect">
@@ -13375,7 +13387,7 @@
           </p:nvSpPr>
           <p:spPr>
             <a:xfrm>
-              <a:off x="1381125" y="2047875"/>
+              <a:off x="2495592" y="2047875"/>
               <a:ext cx="809625" cy="1762125"/>
             </a:xfrm>
             <a:prstGeom prst="roundRect">
@@ -13406,7 +13418,7 @@
           </p:nvSpPr>
           <p:spPr>
             <a:xfrm>
-              <a:off x="1529982" y="1851025"/>
+              <a:off x="2667000" y="1859711"/>
               <a:ext cx="502387" cy="176212"/>
             </a:xfrm>
             <a:prstGeom prst="rect">
@@ -13446,7 +13458,7 @@
           </p:nvSpPr>
           <p:spPr>
             <a:xfrm>
-              <a:off x="1486415" y="3898900"/>
+              <a:off x="2605644" y="3917950"/>
               <a:ext cx="589520" cy="161925"/>
             </a:xfrm>
             <a:prstGeom prst="rect">
@@ -13486,7 +13498,7 @@
           </p:nvSpPr>
           <p:spPr>
             <a:xfrm>
-              <a:off x="1593252" y="4064000"/>
+              <a:off x="2712481" y="4074422"/>
               <a:ext cx="375845" cy="147638"/>
             </a:xfrm>
             <a:prstGeom prst="rect">
@@ -13564,157 +13576,6 @@
         </p:sp>
         <p:sp>
           <p:nvSpPr>
-            <p:cNvPr id="32" name="Rectangle 32"/>
-            <p:cNvSpPr/>
-            <p:nvPr/>
-          </p:nvSpPr>
-          <p:spPr>
-            <a:xfrm>
-              <a:off x="2667000" y="2047875"/>
-              <a:ext cx="809625" cy="457200"/>
-            </a:xfrm>
-            <a:prstGeom prst="roundRect">
-              <a:avLst>
-                <a:gd name="adj" fmla="val 8333"/>
-              </a:avLst>
-            </a:prstGeom>
-            <a:solidFill>
-              <a:schemeClr val="accent3"/>
-            </a:solidFill>
-            <a:ln>
-              <a:noFill/>
-            </a:ln>
-          </p:spPr>
-          <p:txBody>
-            <a:bodyPr/>
-            <a:lstStyle/>
-            <a:p>
-              <a:endParaRPr lang="en-IN"/>
-            </a:p>
-          </p:txBody>
-        </p:sp>
-        <p:sp>
-          <p:nvSpPr>
-            <p:cNvPr id="33" name="TextBox 33"/>
-            <p:cNvSpPr txBox="1"/>
-            <p:nvPr/>
-          </p:nvSpPr>
-          <p:spPr>
-            <a:xfrm>
-              <a:off x="2815857" y="2222500"/>
-              <a:ext cx="502387" cy="176212"/>
-            </a:xfrm>
-            <a:prstGeom prst="rect">
-              <a:avLst/>
-            </a:prstGeom>
-            <a:noFill/>
-            <a:ln>
-              <a:noFill/>
-            </a:ln>
-          </p:spPr>
-          <p:txBody>
-            <a:bodyPr wrap="none" lIns="0" tIns="0" rIns="0" bIns="0" anchor="t" anchorCtr="0">
-              <a:spAutoFit/>
-            </a:bodyPr>
-            <a:lstStyle/>
-            <a:p>
-              <a:pPr algn="ctr"/>
-              <a:r>
-                <a:rPr lang="en-US" sz="900" b="1" dirty="0">
-                  <a:solidFill>
-                    <a:srgbClr val="FFFFFF"/>
-                  </a:solidFill>
-                  <a:latin typeface="Consolas"/>
-                  <a:ea typeface="Consolas"/>
-                  <a:cs typeface="Consolas"/>
-                </a:rPr>
-                <a:t>-$48.2M</a:t>
-              </a:r>
-            </a:p>
-          </p:txBody>
-        </p:sp>
-        <p:sp>
-          <p:nvSpPr>
-            <p:cNvPr id="34" name="TextBox 34"/>
-            <p:cNvSpPr txBox="1"/>
-            <p:nvPr/>
-          </p:nvSpPr>
-          <p:spPr>
-            <a:xfrm>
-              <a:off x="2763483" y="3898900"/>
-              <a:ext cx="607135" cy="161925"/>
-            </a:xfrm>
-            <a:prstGeom prst="rect">
-              <a:avLst/>
-            </a:prstGeom>
-            <a:noFill/>
-            <a:ln>
-              <a:noFill/>
-            </a:ln>
-          </p:spPr>
-          <p:txBody>
-            <a:bodyPr wrap="none" lIns="0" tIns="0" rIns="0" bIns="0" anchor="t" anchorCtr="0">
-              <a:spAutoFit/>
-            </a:bodyPr>
-            <a:lstStyle/>
-            <a:p>
-              <a:pPr algn="ctr"/>
-              <a:r>
-                <a:rPr lang="en-US" sz="820" b="1" dirty="0">
-                  <a:solidFill>
-                    <a:schemeClr val="dk1"/>
-                  </a:solidFill>
-                  <a:latin typeface="+mn-lt"/>
-                  <a:ea typeface="+mn-ea"/>
-                  <a:cs typeface="+mn-cs"/>
-                </a:rPr>
-                <a:t>Equity Beta</a:t>
-              </a:r>
-            </a:p>
-          </p:txBody>
-        </p:sp>
-        <p:sp>
-          <p:nvSpPr>
-            <p:cNvPr id="35" name="TextBox 35"/>
-            <p:cNvSpPr txBox="1"/>
-            <p:nvPr/>
-          </p:nvSpPr>
-          <p:spPr>
-            <a:xfrm>
-              <a:off x="2775869" y="4064000"/>
-              <a:ext cx="582361" cy="147638"/>
-            </a:xfrm>
-            <a:prstGeom prst="rect">
-              <a:avLst/>
-            </a:prstGeom>
-            <a:noFill/>
-            <a:ln>
-              <a:noFill/>
-            </a:ln>
-          </p:spPr>
-          <p:txBody>
-            <a:bodyPr wrap="none" lIns="0" tIns="0" rIns="0" bIns="0" anchor="t" anchorCtr="0">
-              <a:spAutoFit/>
-            </a:bodyPr>
-            <a:lstStyle/>
-            <a:p>
-              <a:pPr algn="ctr"/>
-              <a:r>
-                <a:rPr lang="en-US" sz="750" dirty="0">
-                  <a:solidFill>
-                    <a:srgbClr val="64748B"/>
-                  </a:solidFill>
-                  <a:latin typeface="+mn-lt"/>
-                  <a:ea typeface="+mn-ea"/>
-                  <a:cs typeface="+mn-cs"/>
-                </a:rPr>
-                <a:t>Market Drop</a:t>
-              </a:r>
-            </a:p>
-          </p:txBody>
-        </p:sp>
-        <p:sp>
-          <p:nvSpPr>
             <p:cNvPr id="36" name="Line 36"/>
             <p:cNvSpPr/>
             <p:nvPr/>
@@ -13796,8 +13657,8 @@
           </p:nvSpPr>
           <p:spPr>
             <a:xfrm>
-              <a:off x="4101732" y="2603500"/>
-              <a:ext cx="502387" cy="176212"/>
+              <a:off x="4128505" y="2603500"/>
+              <a:ext cx="448842" cy="138499"/>
             </a:xfrm>
             <a:prstGeom prst="rect">
               <a:avLst/>
@@ -13823,7 +13684,7 @@
                   <a:ea typeface="Consolas"/>
                   <a:cs typeface="Consolas"/>
                 </a:rPr>
-                <a:t>-$32.4M</a:t>
+                <a:t>-$28.6M</a:t>
               </a:r>
             </a:p>
           </p:txBody>
@@ -13836,8 +13697,8 @@
           </p:nvSpPr>
           <p:spPr>
             <a:xfrm>
-              <a:off x="4065143" y="3898900"/>
-              <a:ext cx="575564" cy="161925"/>
+              <a:off x="4093240" y="3898900"/>
+              <a:ext cx="519374" cy="126188"/>
             </a:xfrm>
             <a:prstGeom prst="rect">
               <a:avLst/>
@@ -13863,48 +13724,27 @@
                   <a:ea typeface="+mn-ea"/>
                   <a:cs typeface="+mn-cs"/>
                 </a:rPr>
-                <a:t>Bonds (Δy)</a:t>
-              </a:r>
-            </a:p>
-          </p:txBody>
-        </p:sp>
-        <p:sp>
-          <p:nvSpPr>
-            <p:cNvPr id="40" name="TextBox 40"/>
-            <p:cNvSpPr txBox="1"/>
-            <p:nvPr/>
-          </p:nvSpPr>
-          <p:spPr>
-            <a:xfrm>
-              <a:off x="4048976" y="4064000"/>
-              <a:ext cx="607898" cy="147638"/>
-            </a:xfrm>
-            <a:prstGeom prst="rect">
-              <a:avLst/>
-            </a:prstGeom>
-            <a:noFill/>
-            <a:ln>
-              <a:noFill/>
-            </a:ln>
-          </p:spPr>
-          <p:txBody>
-            <a:bodyPr wrap="none" lIns="0" tIns="0" rIns="0" bIns="0" anchor="t" anchorCtr="0">
-              <a:spAutoFit/>
-            </a:bodyPr>
-            <a:lstStyle/>
-            <a:p>
-              <a:pPr algn="ctr"/>
-              <a:r>
-                <a:rPr lang="en-US" sz="750" dirty="0">
-                  <a:solidFill>
-                    <a:srgbClr val="64748B"/>
+                <a:t>Bond</a:t>
+              </a:r>
+              <a:r>
+                <a:rPr lang="en-US" sz="820" b="1" dirty="0">
+                  <a:solidFill>
+                    <a:schemeClr val="dk1"/>
                   </a:solidFill>
                   <a:latin typeface="+mn-lt"/>
                   <a:ea typeface="+mn-ea"/>
                   <a:cs typeface="+mn-cs"/>
                 </a:rPr>
-                <a:t>+75 bps Rate</a:t>
-              </a:r>
+                <a:t>s PnL</a:t>
+              </a:r>
+              <a:endParaRPr lang="el-GR" sz="820" b="1" dirty="0">
+                <a:solidFill>
+                  <a:schemeClr val="dk1"/>
+                </a:solidFill>
+                <a:latin typeface="+mn-lt"/>
+                <a:ea typeface="+mn-ea"/>
+                <a:cs typeface="+mn-cs"/>
+              </a:endParaRPr>
             </a:p>
           </p:txBody>
         </p:sp>
@@ -13991,8 +13831,8 @@
           </p:nvSpPr>
           <p:spPr>
             <a:xfrm>
-              <a:off x="5409512" y="2660650"/>
-              <a:ext cx="458577" cy="161925"/>
+              <a:off x="5465676" y="2660650"/>
+              <a:ext cx="346250" cy="126188"/>
             </a:xfrm>
             <a:prstGeom prst="rect">
               <a:avLst/>
@@ -14018,7 +13858,7 @@
                   <a:ea typeface="Consolas"/>
                   <a:cs typeface="Consolas"/>
                 </a:rPr>
-                <a:t>-$18.6M</a:t>
+                <a:t>-$7.8M</a:t>
               </a:r>
             </a:p>
           </p:txBody>
@@ -14031,8 +13871,8 @@
           </p:nvSpPr>
           <p:spPr>
             <a:xfrm>
-              <a:off x="5351180" y="3898900"/>
-              <a:ext cx="575240" cy="161925"/>
+              <a:off x="5413579" y="3898900"/>
+              <a:ext cx="450444" cy="126188"/>
             </a:xfrm>
             <a:prstGeom prst="rect">
               <a:avLst/>
@@ -14058,47 +13898,7 @@
                   <a:ea typeface="+mn-ea"/>
                   <a:cs typeface="+mn-cs"/>
                 </a:rPr>
-                <a:t>Credit Risk</a:t>
-              </a:r>
-            </a:p>
-          </p:txBody>
-        </p:sp>
-        <p:sp>
-          <p:nvSpPr>
-            <p:cNvPr id="45" name="TextBox 45"/>
-            <p:cNvSpPr txBox="1"/>
-            <p:nvPr/>
-          </p:nvSpPr>
-          <p:spPr>
-            <a:xfrm>
-              <a:off x="5251168" y="4064000"/>
-              <a:ext cx="775264" cy="147638"/>
-            </a:xfrm>
-            <a:prstGeom prst="rect">
-              <a:avLst/>
-            </a:prstGeom>
-            <a:noFill/>
-            <a:ln>
-              <a:noFill/>
-            </a:ln>
-          </p:spPr>
-          <p:txBody>
-            <a:bodyPr wrap="none" lIns="0" tIns="0" rIns="0" bIns="0" anchor="t" anchorCtr="0">
-              <a:spAutoFit/>
-            </a:bodyPr>
-            <a:lstStyle/>
-            <a:p>
-              <a:pPr algn="ctr"/>
-              <a:r>
-                <a:rPr lang="en-US" sz="750" dirty="0">
-                  <a:solidFill>
-                    <a:srgbClr val="64748B"/>
-                  </a:solidFill>
-                  <a:latin typeface="+mn-lt"/>
-                  <a:ea typeface="+mn-ea"/>
-                  <a:cs typeface="+mn-cs"/>
-                </a:rPr>
-                <a:t>+120 bps Spread</a:t>
+                <a:t>Loan PnL</a:t>
               </a:r>
             </a:p>
           </p:txBody>
@@ -14155,8 +13955,8 @@
           </p:nvSpPr>
           <p:spPr>
             <a:xfrm>
-              <a:off x="6524625" y="2990850"/>
-              <a:ext cx="809625" cy="161925"/>
+              <a:off x="6524625" y="2955926"/>
+              <a:ext cx="809625" cy="196850"/>
             </a:xfrm>
             <a:prstGeom prst="roundRect">
               <a:avLst>
@@ -14186,8 +13986,8 @@
           </p:nvSpPr>
           <p:spPr>
             <a:xfrm>
-              <a:off x="6695387" y="2851150"/>
-              <a:ext cx="458577" cy="161925"/>
+              <a:off x="6722697" y="2827337"/>
+              <a:ext cx="403958" cy="126188"/>
             </a:xfrm>
             <a:prstGeom prst="rect">
               <a:avLst/>
@@ -14213,7 +14013,7 @@
                   <a:ea typeface="Consolas"/>
                   <a:cs typeface="Consolas"/>
                 </a:rPr>
-                <a:t>-$16.9M</a:t>
+                <a:t>-$11.9M</a:t>
               </a:r>
             </a:p>
           </p:txBody>
@@ -14226,8 +14026,8 @@
           </p:nvSpPr>
           <p:spPr>
             <a:xfrm>
-              <a:off x="6573024" y="3898900"/>
-              <a:ext cx="703302" cy="161925"/>
+              <a:off x="6623311" y="3898900"/>
+              <a:ext cx="602730" cy="126188"/>
             </a:xfrm>
             <a:prstGeom prst="rect">
               <a:avLst/>
@@ -14253,47 +14053,7 @@
                   <a:ea typeface="+mn-ea"/>
                   <a:cs typeface="+mn-cs"/>
                 </a:rPr>
-                <a:t>NLP FinBERT</a:t>
-              </a:r>
-            </a:p>
-          </p:txBody>
-        </p:sp>
-        <p:sp>
-          <p:nvSpPr>
-            <p:cNvPr id="50" name="TextBox 50"/>
-            <p:cNvSpPr txBox="1"/>
-            <p:nvPr/>
-          </p:nvSpPr>
-          <p:spPr>
-            <a:xfrm>
-              <a:off x="6424607" y="4064000"/>
-              <a:ext cx="1000135" cy="147638"/>
-            </a:xfrm>
-            <a:prstGeom prst="rect">
-              <a:avLst/>
-            </a:prstGeom>
-            <a:noFill/>
-            <a:ln>
-              <a:noFill/>
-            </a:ln>
-          </p:spPr>
-          <p:txBody>
-            <a:bodyPr wrap="none" lIns="0" tIns="0" rIns="0" bIns="0" anchor="t" anchorCtr="0">
-              <a:spAutoFit/>
-            </a:bodyPr>
-            <a:lstStyle/>
-            <a:p>
-              <a:pPr algn="ctr"/>
-              <a:r>
-                <a:rPr lang="en-US" sz="750" dirty="0">
-                  <a:solidFill>
-                    <a:srgbClr val="64748B"/>
-                  </a:solidFill>
-                  <a:latin typeface="+mn-lt"/>
-                  <a:ea typeface="+mn-ea"/>
-                  <a:cs typeface="+mn-cs"/>
-                </a:rPr>
-                <a:t>Contagion Headwinds</a:t>
+                <a:t>Equities PnL</a:t>
               </a:r>
             </a:p>
           </p:txBody>
@@ -14351,7 +14111,7 @@
           <p:spPr>
             <a:xfrm>
               <a:off x="7810500" y="3152775"/>
-              <a:ext cx="809625" cy="219075"/>
+              <a:ext cx="809625" cy="117475"/>
             </a:xfrm>
             <a:prstGeom prst="roundRect">
               <a:avLst>
@@ -14421,8 +14181,8 @@
           </p:nvSpPr>
           <p:spPr>
             <a:xfrm>
-              <a:off x="7859814" y="3898900"/>
-              <a:ext cx="701472" cy="161925"/>
+              <a:off x="7814612" y="3898900"/>
+              <a:ext cx="791884" cy="126188"/>
             </a:xfrm>
             <a:prstGeom prst="rect">
               <a:avLst/>
@@ -14448,47 +14208,7 @@
                   <a:ea typeface="+mn-ea"/>
                   <a:cs typeface="+mn-cs"/>
                 </a:rPr>
-                <a:t>Commodities</a:t>
-              </a:r>
-            </a:p>
-          </p:txBody>
-        </p:sp>
-        <p:sp>
-          <p:nvSpPr>
-            <p:cNvPr id="55" name="TextBox 55"/>
-            <p:cNvSpPr txBox="1"/>
-            <p:nvPr/>
-          </p:nvSpPr>
-          <p:spPr>
-            <a:xfrm>
-              <a:off x="7907635" y="4064000"/>
-              <a:ext cx="605831" cy="147638"/>
-            </a:xfrm>
-            <a:prstGeom prst="rect">
-              <a:avLst/>
-            </a:prstGeom>
-            <a:noFill/>
-            <a:ln>
-              <a:noFill/>
-            </a:ln>
-          </p:spPr>
-          <p:txBody>
-            <a:bodyPr wrap="none" lIns="0" tIns="0" rIns="0" bIns="0" anchor="t" anchorCtr="0">
-              <a:spAutoFit/>
-            </a:bodyPr>
-            <a:lstStyle/>
-            <a:p>
-              <a:pPr algn="ctr"/>
-              <a:r>
-                <a:rPr lang="en-US" sz="750" dirty="0">
-                  <a:solidFill>
-                    <a:srgbClr val="64748B"/>
-                  </a:solidFill>
-                  <a:latin typeface="+mn-lt"/>
-                  <a:ea typeface="+mn-ea"/>
-                  <a:cs typeface="+mn-cs"/>
-                </a:rPr>
-                <a:t>Energy Surge</a:t>
+                <a:t>Derivatives PnL</a:t>
               </a:r>
             </a:p>
           </p:txBody>
@@ -14539,157 +14259,6 @@
         </p:sp>
         <p:sp>
           <p:nvSpPr>
-            <p:cNvPr id="57" name="Rectangle 57"/>
-            <p:cNvSpPr/>
-            <p:nvPr/>
-          </p:nvSpPr>
-          <p:spPr>
-            <a:xfrm>
-              <a:off x="9096375" y="3086100"/>
-              <a:ext cx="809625" cy="285750"/>
-            </a:xfrm>
-            <a:prstGeom prst="roundRect">
-              <a:avLst>
-                <a:gd name="adj" fmla="val 13333"/>
-              </a:avLst>
-            </a:prstGeom>
-            <a:solidFill>
-              <a:schemeClr val="accent2"/>
-            </a:solidFill>
-            <a:ln>
-              <a:noFill/>
-            </a:ln>
-          </p:spPr>
-          <p:txBody>
-            <a:bodyPr/>
-            <a:lstStyle/>
-            <a:p>
-              <a:endParaRPr lang="en-IN"/>
-            </a:p>
-          </p:txBody>
-        </p:sp>
-        <p:sp>
-          <p:nvSpPr>
-            <p:cNvPr id="58" name="TextBox 58"/>
-            <p:cNvSpPr txBox="1"/>
-            <p:nvPr/>
-          </p:nvSpPr>
-          <p:spPr>
-            <a:xfrm>
-              <a:off x="9245232" y="2908300"/>
-              <a:ext cx="502387" cy="176212"/>
-            </a:xfrm>
-            <a:prstGeom prst="rect">
-              <a:avLst/>
-            </a:prstGeom>
-            <a:noFill/>
-            <a:ln>
-              <a:noFill/>
-            </a:ln>
-          </p:spPr>
-          <p:txBody>
-            <a:bodyPr wrap="none" lIns="0" tIns="0" rIns="0" bIns="0" anchor="t" anchorCtr="0">
-              <a:spAutoFit/>
-            </a:bodyPr>
-            <a:lstStyle/>
-            <a:p>
-              <a:pPr algn="ctr"/>
-              <a:r>
-                <a:rPr lang="en-US" sz="900" b="1" dirty="0">
-                  <a:solidFill>
-                    <a:schemeClr val="accent2"/>
-                  </a:solidFill>
-                  <a:latin typeface="Consolas"/>
-                  <a:ea typeface="Consolas"/>
-                  <a:cs typeface="Consolas"/>
-                </a:rPr>
-                <a:t>+$29.5M</a:t>
-              </a:r>
-            </a:p>
-          </p:txBody>
-        </p:sp>
-        <p:sp>
-          <p:nvSpPr>
-            <p:cNvPr id="59" name="TextBox 59"/>
-            <p:cNvSpPr txBox="1"/>
-            <p:nvPr/>
-          </p:nvSpPr>
-          <p:spPr>
-            <a:xfrm>
-              <a:off x="9266118" y="3898900"/>
-              <a:ext cx="460614" cy="161925"/>
-            </a:xfrm>
-            <a:prstGeom prst="rect">
-              <a:avLst/>
-            </a:prstGeom>
-            <a:noFill/>
-            <a:ln>
-              <a:noFill/>
-            </a:ln>
-          </p:spPr>
-          <p:txBody>
-            <a:bodyPr wrap="none" lIns="0" tIns="0" rIns="0" bIns="0" anchor="t" anchorCtr="0">
-              <a:spAutoFit/>
-            </a:bodyPr>
-            <a:lstStyle/>
-            <a:p>
-              <a:pPr algn="ctr"/>
-              <a:r>
-                <a:rPr lang="en-US" sz="820" b="1" dirty="0">
-                  <a:solidFill>
-                    <a:schemeClr val="dk1"/>
-                  </a:solidFill>
-                  <a:latin typeface="+mn-lt"/>
-                  <a:ea typeface="+mn-ea"/>
-                  <a:cs typeface="+mn-cs"/>
-                </a:rPr>
-                <a:t>Hedging</a:t>
-              </a:r>
-            </a:p>
-          </p:txBody>
-        </p:sp>
-        <p:sp>
-          <p:nvSpPr>
-            <p:cNvPr id="60" name="TextBox 60"/>
-            <p:cNvSpPr txBox="1"/>
-            <p:nvPr/>
-          </p:nvSpPr>
-          <p:spPr>
-            <a:xfrm>
-              <a:off x="9152843" y="4064000"/>
-              <a:ext cx="687164" cy="147638"/>
-            </a:xfrm>
-            <a:prstGeom prst="rect">
-              <a:avLst/>
-            </a:prstGeom>
-            <a:noFill/>
-            <a:ln>
-              <a:noFill/>
-            </a:ln>
-          </p:spPr>
-          <p:txBody>
-            <a:bodyPr wrap="none" lIns="0" tIns="0" rIns="0" bIns="0" anchor="t" anchorCtr="0">
-              <a:spAutoFit/>
-            </a:bodyPr>
-            <a:lstStyle/>
-            <a:p>
-              <a:pPr algn="ctr"/>
-              <a:r>
-                <a:rPr lang="en-US" sz="750" dirty="0">
-                  <a:solidFill>
-                    <a:schemeClr val="accent2"/>
-                  </a:solidFill>
-                  <a:latin typeface="+mn-lt"/>
-                  <a:ea typeface="+mn-ea"/>
-                  <a:cs typeface="+mn-cs"/>
-                </a:rPr>
-                <a:t>Dynamic Alpha</a:t>
-              </a:r>
-            </a:p>
-          </p:txBody>
-        </p:sp>
-        <p:sp>
-          <p:nvSpPr>
             <p:cNvPr id="61" name="Line 61"/>
             <p:cNvSpPr/>
             <p:nvPr/>
@@ -14740,7 +14309,7 @@
           </p:nvSpPr>
           <p:spPr>
             <a:xfrm>
-              <a:off x="10287000" y="2876550"/>
+              <a:off x="9074943" y="2867025"/>
               <a:ext cx="809625" cy="933450"/>
             </a:xfrm>
             <a:prstGeom prst="roundRect">
@@ -14771,8 +14340,8 @@
           </p:nvSpPr>
           <p:spPr>
             <a:xfrm>
-              <a:off x="10435857" y="2679700"/>
-              <a:ext cx="502387" cy="176212"/>
+              <a:off x="9255334" y="2671376"/>
+              <a:ext cx="448842" cy="138499"/>
             </a:xfrm>
             <a:prstGeom prst="rect">
               <a:avLst/>
@@ -14798,7 +14367,7 @@
                   <a:ea typeface="Consolas"/>
                   <a:cs typeface="Consolas"/>
                 </a:rPr>
-                <a:t>$498.4M</a:t>
+                <a:t>$529.6M</a:t>
               </a:r>
             </a:p>
           </p:txBody>
@@ -14811,8 +14380,8 @@
           </p:nvSpPr>
           <p:spPr>
             <a:xfrm>
-              <a:off x="10311161" y="3898900"/>
-              <a:ext cx="751778" cy="161925"/>
+              <a:off x="9052768" y="3917074"/>
+              <a:ext cx="719749" cy="126188"/>
             </a:xfrm>
             <a:prstGeom prst="rect">
               <a:avLst/>
@@ -14838,7 +14407,7 @@
                   <a:ea typeface="+mn-ea"/>
                   <a:cs typeface="+mn-cs"/>
                 </a:rPr>
-                <a:t>Terminal NAV</a:t>
+                <a:t>Stressed Value</a:t>
               </a:r>
             </a:p>
           </p:txBody>
@@ -14851,8 +14420,8 @@
           </p:nvSpPr>
           <p:spPr>
             <a:xfrm>
-              <a:off x="10335805" y="4064000"/>
-              <a:ext cx="702490" cy="147638"/>
+              <a:off x="9246098" y="4064000"/>
+              <a:ext cx="477695" cy="115416"/>
             </a:xfrm>
             <a:prstGeom prst="rect">
               <a:avLst/>
@@ -14878,7 +14447,7 @@
                   <a:ea typeface="+mn-ea"/>
                   <a:cs typeface="+mn-cs"/>
                 </a:rPr>
-                <a:t>85.2% Retained</a:t>
+                <a:t>% Retained</a:t>
               </a:r>
             </a:p>
           </p:txBody>
@@ -15067,27 +14636,26 @@
           <p:spPr>
             <a:xfrm>
               <a:off x="719138" y="5880100"/>
-              <a:ext cx="1972485" cy="161925"/>
-            </a:xfrm>
-            <a:prstGeom prst="rect">
-              <a:avLst/>
-            </a:prstGeom>
-            <a:noFill/>
-            <a:ln>
-              <a:noFill/>
-            </a:ln>
-          </p:spPr>
-          <p:txBody>
-            <a:bodyPr wrap="none" lIns="0" tIns="0" rIns="0" bIns="0" anchor="t" anchorCtr="0">
-              <a:spAutoFit/>
-            </a:bodyPr>
-            <a:lstStyle/>
-            <a:p>
-              <a:pPr marL="76200" indent="-76200" algn="l">
+              <a:ext cx="2120773" cy="126188"/>
+            </a:xfrm>
+            <a:prstGeom prst="rect">
+              <a:avLst/>
+            </a:prstGeom>
+            <a:noFill/>
+            <a:ln>
+              <a:noFill/>
+            </a:ln>
+          </p:spPr>
+          <p:txBody>
+            <a:bodyPr wrap="none" lIns="0" tIns="0" rIns="0" bIns="0" anchor="t" anchorCtr="0">
+              <a:spAutoFit/>
+            </a:bodyPr>
+            <a:lstStyle/>
+            <a:p>
+              <a:pPr marL="76200" indent="-76200">
                 <a:buClr>
                   <a:srgbClr val="64748B"/>
                 </a:buClr>
-                <a:buSzTx/>
                 <a:buFontTx/>
                 <a:buChar char="•"/>
               </a:pPr>
@@ -15096,12 +14664,17 @@
                   <a:solidFill>
                     <a:srgbClr val="64748B"/>
                   </a:solidFill>
-                  <a:latin typeface="+mn-lt"/>
-                  <a:ea typeface="+mn-ea"/>
-                  <a:cs typeface="+mn-cs"/>
-                </a:rPr>
-                <a:t>4 asset classes: Bonds, Eq, Loans, Deriv</a:t>
-              </a:r>
+                </a:rPr>
+                <a:t>15 assets: Bonds, Loans, Equities, Derivatives</a:t>
+              </a:r>
+              <a:endParaRPr lang="en-US" sz="820" dirty="0">
+                <a:solidFill>
+                  <a:srgbClr val="64748B"/>
+                </a:solidFill>
+                <a:latin typeface="+mn-lt"/>
+                <a:ea typeface="+mn-ea"/>
+                <a:cs typeface="+mn-cs"/>
+              </a:endParaRPr>
             </a:p>
           </p:txBody>
         </p:sp>
@@ -15162,34 +14735,38 @@
           <p:spPr>
             <a:xfrm>
               <a:off x="3529012" y="5099050"/>
-              <a:ext cx="1947348" cy="161925"/>
-            </a:xfrm>
-            <a:prstGeom prst="rect">
-              <a:avLst/>
-            </a:prstGeom>
-            <a:noFill/>
-            <a:ln>
-              <a:noFill/>
-            </a:ln>
-          </p:spPr>
-          <p:txBody>
-            <a:bodyPr wrap="none" lIns="0" tIns="0" rIns="0" bIns="0" anchor="t" anchorCtr="0">
-              <a:spAutoFit/>
-            </a:bodyPr>
-            <a:lstStyle/>
-            <a:p>
-              <a:pPr algn="l"/>
+              <a:ext cx="1771319" cy="126188"/>
+            </a:xfrm>
+            <a:prstGeom prst="rect">
+              <a:avLst/>
+            </a:prstGeom>
+            <a:noFill/>
+            <a:ln>
+              <a:noFill/>
+            </a:ln>
+          </p:spPr>
+          <p:txBody>
+            <a:bodyPr wrap="none" lIns="0" tIns="0" rIns="0" bIns="0" anchor="t" anchorCtr="0">
+              <a:spAutoFit/>
+            </a:bodyPr>
+            <a:lstStyle/>
+            <a:p>
               <a:r>
                 <a:rPr lang="en-US" sz="820" b="1" spc="75" dirty="0">
                   <a:solidFill>
                     <a:schemeClr val="accent3"/>
                   </a:solidFill>
-                  <a:latin typeface="+mn-lt"/>
-                  <a:ea typeface="+mn-ea"/>
-                  <a:cs typeface="+mn-cs"/>
-                </a:rPr>
-                <a:t>MAX UNHEDGED DRAWDOWN</a:t>
-              </a:r>
+                </a:rPr>
+                <a:t>GEOPOLITICAL LOSS -$55.44M</a:t>
+              </a:r>
+              <a:endParaRPr lang="en-US" sz="820" b="1" spc="75" dirty="0">
+                <a:solidFill>
+                  <a:schemeClr val="accent3"/>
+                </a:solidFill>
+                <a:latin typeface="+mn-lt"/>
+                <a:ea typeface="+mn-ea"/>
+                <a:cs typeface="+mn-cs"/>
+              </a:endParaRPr>
             </a:p>
           </p:txBody>
         </p:sp>
@@ -15444,7 +15021,51 @@
           <p:spPr>
             <a:xfrm>
               <a:off x="6338888" y="5099050"/>
-              <a:ext cx="1673788" cy="161925"/>
+              <a:ext cx="629981" cy="126188"/>
+            </a:xfrm>
+            <a:prstGeom prst="rect">
+              <a:avLst/>
+            </a:prstGeom>
+            <a:noFill/>
+            <a:ln>
+              <a:noFill/>
+            </a:ln>
+          </p:spPr>
+          <p:txBody>
+            <a:bodyPr wrap="none" lIns="0" tIns="0" rIns="0" bIns="0" anchor="t" anchorCtr="0">
+              <a:spAutoFit/>
+            </a:bodyPr>
+            <a:lstStyle/>
+            <a:p>
+              <a:r>
+                <a:rPr lang="en-US" sz="820" b="1" spc="75" dirty="0">
+                  <a:solidFill>
+                    <a:srgbClr val="FF0000"/>
+                  </a:solidFill>
+                </a:rPr>
+                <a:t>1-DAY VaR</a:t>
+              </a:r>
+              <a:endParaRPr lang="en-US" sz="820" b="1" spc="75" dirty="0">
+                <a:solidFill>
+                  <a:srgbClr val="FF0000"/>
+                </a:solidFill>
+                <a:latin typeface="+mn-lt"/>
+                <a:ea typeface="+mn-ea"/>
+                <a:cs typeface="+mn-cs"/>
+              </a:endParaRPr>
+            </a:p>
+          </p:txBody>
+        </p:sp>
+        <p:sp>
+          <p:nvSpPr>
+            <p:cNvPr id="81" name="TextBox 81"/>
+            <p:cNvSpPr txBox="1"/>
+            <p:nvPr/>
+          </p:nvSpPr>
+          <p:spPr>
+            <a:xfrm>
+              <a:off x="6334506" y="5327650"/>
+              <a:ext cx="759823" cy="276999"/>
             </a:xfrm>
             <a:prstGeom prst="rect">
               <a:avLst/>
@@ -15462,55 +15083,37 @@
             <a:p>
               <a:pPr algn="l"/>
               <a:r>
-                <a:rPr lang="en-US" sz="820" b="1" spc="75" dirty="0">
-                  <a:solidFill>
-                    <a:schemeClr val="accent2"/>
-                  </a:solidFill>
-                  <a:latin typeface="+mn-lt"/>
-                  <a:ea typeface="+mn-ea"/>
-                  <a:cs typeface="+mn-cs"/>
-                </a:rPr>
-                <a:t>DEFENSIVE REBALANCING</a:t>
-              </a:r>
-            </a:p>
-          </p:txBody>
-        </p:sp>
-        <p:sp>
-          <p:nvSpPr>
-            <p:cNvPr id="81" name="TextBox 81"/>
-            <p:cNvSpPr txBox="1"/>
-            <p:nvPr/>
-          </p:nvSpPr>
-          <p:spPr>
-            <a:xfrm>
-              <a:off x="6334506" y="5327650"/>
-              <a:ext cx="1004011" cy="352044"/>
-            </a:xfrm>
-            <a:prstGeom prst="rect">
-              <a:avLst/>
-            </a:prstGeom>
-            <a:noFill/>
-            <a:ln>
-              <a:noFill/>
-            </a:ln>
-          </p:spPr>
-          <p:txBody>
-            <a:bodyPr wrap="none" lIns="0" tIns="0" rIns="0" bIns="0" anchor="t" anchorCtr="0">
-              <a:spAutoFit/>
-            </a:bodyPr>
-            <a:lstStyle/>
-            <a:p>
-              <a:pPr algn="l"/>
-              <a:r>
                 <a:rPr lang="en-US" sz="1800" b="1" dirty="0">
                   <a:solidFill>
-                    <a:schemeClr val="accent2"/>
+                    <a:srgbClr val="FF0000"/>
                   </a:solidFill>
                   <a:latin typeface="Consolas"/>
                   <a:ea typeface="Consolas"/>
                   <a:cs typeface="Consolas"/>
                 </a:rPr>
-                <a:t>+$29.5M</a:t>
+                <a:t>$</a:t>
+              </a:r>
+              <a:r>
+                <a:rPr lang="en-US" b="1" dirty="0">
+                  <a:solidFill>
+                    <a:srgbClr val="FF0000"/>
+                  </a:solidFill>
+                  <a:latin typeface="Consolas"/>
+                  <a:ea typeface="Consolas"/>
+                  <a:cs typeface="Consolas"/>
+                </a:rPr>
+                <a:t>50.9</a:t>
+              </a:r>
+              <a:r>
+                <a:rPr lang="en-US" sz="1800" b="1" dirty="0">
+                  <a:solidFill>
+                    <a:srgbClr val="FF0000"/>
+                  </a:solidFill>
+                  <a:latin typeface="Consolas"/>
+                  <a:ea typeface="Consolas"/>
+                  <a:cs typeface="Consolas"/>
+                </a:rPr>
+                <a:t>M</a:t>
               </a:r>
             </a:p>
           </p:txBody>
@@ -15524,27 +15127,26 @@
           <p:spPr>
             <a:xfrm>
               <a:off x="6338888" y="5689600"/>
-              <a:ext cx="1806824" cy="161925"/>
-            </a:xfrm>
-            <a:prstGeom prst="rect">
-              <a:avLst/>
-            </a:prstGeom>
-            <a:noFill/>
-            <a:ln>
-              <a:noFill/>
-            </a:ln>
-          </p:spPr>
-          <p:txBody>
-            <a:bodyPr wrap="none" lIns="0" tIns="0" rIns="0" bIns="0" anchor="t" anchorCtr="0">
-              <a:spAutoFit/>
-            </a:bodyPr>
-            <a:lstStyle/>
-            <a:p>
-              <a:pPr marL="76200" indent="-76200" algn="l">
+              <a:ext cx="811119" cy="126188"/>
+            </a:xfrm>
+            <a:prstGeom prst="rect">
+              <a:avLst/>
+            </a:prstGeom>
+            <a:noFill/>
+            <a:ln>
+              <a:noFill/>
+            </a:ln>
+          </p:spPr>
+          <p:txBody>
+            <a:bodyPr wrap="none" lIns="0" tIns="0" rIns="0" bIns="0" anchor="t" anchorCtr="0">
+              <a:spAutoFit/>
+            </a:bodyPr>
+            <a:lstStyle/>
+            <a:p>
+              <a:pPr marL="76200" indent="-76200">
                 <a:buClr>
                   <a:srgbClr val="334155"/>
                 </a:buClr>
-                <a:buSzTx/>
                 <a:buFontTx/>
                 <a:buChar char="•"/>
               </a:pPr>
@@ -15553,12 +15155,17 @@
                   <a:solidFill>
                     <a:srgbClr val="334155"/>
                   </a:solidFill>
-                  <a:latin typeface="+mn-lt"/>
-                  <a:ea typeface="+mn-ea"/>
-                  <a:cs typeface="+mn-cs"/>
-                </a:rPr>
-                <a:t>25.4% capital preservation recovery</a:t>
-              </a:r>
+                </a:rPr>
+                <a:t>95% confidence</a:t>
+              </a:r>
+              <a:endParaRPr lang="en-US" sz="820" dirty="0">
+                <a:solidFill>
+                  <a:srgbClr val="334155"/>
+                </a:solidFill>
+                <a:latin typeface="+mn-lt"/>
+                <a:ea typeface="+mn-ea"/>
+                <a:cs typeface="+mn-cs"/>
+              </a:endParaRPr>
             </a:p>
           </p:txBody>
         </p:sp>
@@ -15571,41 +15178,45 @@
           <p:spPr>
             <a:xfrm>
               <a:off x="6338888" y="5880100"/>
-              <a:ext cx="2096613" cy="161925"/>
-            </a:xfrm>
-            <a:prstGeom prst="rect">
-              <a:avLst/>
-            </a:prstGeom>
-            <a:noFill/>
-            <a:ln>
-              <a:noFill/>
-            </a:ln>
-          </p:spPr>
-          <p:txBody>
-            <a:bodyPr wrap="none" lIns="0" tIns="0" rIns="0" bIns="0" anchor="t" anchorCtr="0">
-              <a:spAutoFit/>
-            </a:bodyPr>
-            <a:lstStyle/>
-            <a:p>
-              <a:pPr marL="76200" indent="-76200" algn="l">
+              <a:ext cx="1298432" cy="126188"/>
+            </a:xfrm>
+            <a:prstGeom prst="rect">
+              <a:avLst/>
+            </a:prstGeom>
+            <a:noFill/>
+            <a:ln>
+              <a:noFill/>
+            </a:ln>
+          </p:spPr>
+          <p:txBody>
+            <a:bodyPr wrap="none" lIns="0" tIns="0" rIns="0" bIns="0" anchor="t" anchorCtr="0">
+              <a:spAutoFit/>
+            </a:bodyPr>
+            <a:lstStyle/>
+            <a:p>
+              <a:pPr marL="76200" indent="-76200">
                 <a:buClr>
                   <a:schemeClr val="accent2"/>
                 </a:buClr>
-                <a:buSzTx/>
                 <a:buFontTx/>
                 <a:buChar char="•"/>
               </a:pPr>
               <a:r>
                 <a:rPr lang="en-US" sz="820" dirty="0">
                   <a:solidFill>
-                    <a:schemeClr val="accent2"/>
-                  </a:solidFill>
-                  <a:latin typeface="+mn-lt"/>
-                  <a:ea typeface="+mn-ea"/>
-                  <a:cs typeface="+mn-cs"/>
-                </a:rPr>
-                <a:t>Dynamic short overlays &amp; flight-to-safety</a:t>
-              </a:r>
+                    <a:srgbClr val="FF0000"/>
+                  </a:solidFill>
+                </a:rPr>
+                <a:t>$72.0M at 99% confidence</a:t>
+              </a:r>
+              <a:endParaRPr lang="en-US" sz="820" dirty="0">
+                <a:solidFill>
+                  <a:srgbClr val="FF0000"/>
+                </a:solidFill>
+                <a:latin typeface="+mn-lt"/>
+                <a:ea typeface="+mn-ea"/>
+                <a:cs typeface="+mn-cs"/>
+              </a:endParaRPr>
             </a:p>
           </p:txBody>
         </p:sp>
@@ -15666,34 +15277,38 @@
           <p:spPr>
             <a:xfrm>
               <a:off x="9148762" y="5099050"/>
-              <a:ext cx="1792341" cy="161925"/>
-            </a:xfrm>
-            <a:prstGeom prst="rect">
-              <a:avLst/>
-            </a:prstGeom>
-            <a:noFill/>
-            <a:ln>
-              <a:noFill/>
-            </a:ln>
-          </p:spPr>
-          <p:txBody>
-            <a:bodyPr wrap="none" lIns="0" tIns="0" rIns="0" bIns="0" anchor="t" anchorCtr="0">
-              <a:spAutoFit/>
-            </a:bodyPr>
-            <a:lstStyle/>
-            <a:p>
-              <a:pPr algn="l"/>
+              <a:ext cx="1692771" cy="126188"/>
+            </a:xfrm>
+            <a:prstGeom prst="rect">
+              <a:avLst/>
+            </a:prstGeom>
+            <a:noFill/>
+            <a:ln>
+              <a:noFill/>
+            </a:ln>
+          </p:spPr>
+          <p:txBody>
+            <a:bodyPr wrap="none" lIns="0" tIns="0" rIns="0" bIns="0" anchor="t" anchorCtr="0">
+              <a:spAutoFit/>
+            </a:bodyPr>
+            <a:lstStyle/>
+            <a:p>
               <a:r>
                 <a:rPr lang="en-US" sz="820" b="1" spc="75" dirty="0">
                   <a:solidFill>
                     <a:srgbClr val="0284C7"/>
                   </a:solidFill>
-                  <a:latin typeface="+mn-lt"/>
-                  <a:ea typeface="+mn-ea"/>
-                  <a:cs typeface="+mn-cs"/>
-                </a:rPr>
-                <a:t>TERMINAL STABILIZED NAV</a:t>
-              </a:r>
+                </a:rPr>
+                <a:t>STRESSED PORTFOLIO VALUE</a:t>
+              </a:r>
+              <a:endParaRPr lang="en-US" sz="820" b="1" spc="75" dirty="0">
+                <a:solidFill>
+                  <a:srgbClr val="0284C7"/>
+                </a:solidFill>
+                <a:latin typeface="+mn-lt"/>
+                <a:ea typeface="+mn-ea"/>
+                <a:cs typeface="+mn-cs"/>
+              </a:endParaRPr>
             </a:p>
           </p:txBody>
         </p:sp>
@@ -15706,7 +15321,7 @@
           <p:spPr>
             <a:xfrm>
               <a:off x="9144381" y="5327650"/>
-              <a:ext cx="1004011" cy="352044"/>
+              <a:ext cx="886461" cy="276999"/>
             </a:xfrm>
             <a:prstGeom prst="rect">
               <a:avLst/>
@@ -15732,7 +15347,29 @@
                   <a:ea typeface="Consolas"/>
                   <a:cs typeface="Consolas"/>
                 </a:rPr>
-                <a:t>$498.4M</a:t>
+                <a:t>$</a:t>
+              </a:r>
+              <a:r>
+                <a:rPr lang="en-US" b="1" dirty="0">
+                  <a:solidFill>
+                    <a:srgbClr val="0284C7"/>
+                  </a:solidFill>
+                  <a:latin typeface="Consolas"/>
+                  <a:ea typeface="Consolas"/>
+                  <a:cs typeface="Consolas"/>
+                </a:rPr>
+                <a:t>529.6</a:t>
+              </a:r>
+              <a:r>
+                <a:rPr lang="en-US" sz="1800" b="1" dirty="0">
+                  <a:solidFill>
+                    <a:srgbClr val="0284C7"/>
+                  </a:solidFill>
+                  <a:latin typeface="Consolas"/>
+                  <a:ea typeface="Consolas"/>
+                  <a:cs typeface="Consolas"/>
+                </a:rPr>
+                <a:t>M</a:t>
               </a:r>
             </a:p>
           </p:txBody>
@@ -15746,27 +15383,26 @@
           <p:spPr>
             <a:xfrm>
               <a:off x="9148762" y="5689600"/>
-              <a:ext cx="1412373" cy="161925"/>
-            </a:xfrm>
-            <a:prstGeom prst="rect">
-              <a:avLst/>
-            </a:prstGeom>
-            <a:noFill/>
-            <a:ln>
-              <a:noFill/>
-            </a:ln>
-          </p:spPr>
-          <p:txBody>
-            <a:bodyPr wrap="none" lIns="0" tIns="0" rIns="0" bIns="0" anchor="t" anchorCtr="0">
-              <a:spAutoFit/>
-            </a:bodyPr>
-            <a:lstStyle/>
-            <a:p>
-              <a:pPr marL="76200" indent="-76200" algn="l">
+              <a:ext cx="1628651" cy="126188"/>
+            </a:xfrm>
+            <a:prstGeom prst="rect">
+              <a:avLst/>
+            </a:prstGeom>
+            <a:noFill/>
+            <a:ln>
+              <a:noFill/>
+            </a:ln>
+          </p:spPr>
+          <p:txBody>
+            <a:bodyPr wrap="none" lIns="0" tIns="0" rIns="0" bIns="0" anchor="t" anchorCtr="0">
+              <a:spAutoFit/>
+            </a:bodyPr>
+            <a:lstStyle/>
+            <a:p>
+              <a:pPr marL="76200" indent="-76200">
                 <a:buClr>
                   <a:srgbClr val="334155"/>
                 </a:buClr>
-                <a:buSzTx/>
                 <a:buFontTx/>
                 <a:buChar char="•"/>
               </a:pPr>
@@ -15775,12 +15411,17 @@
                   <a:solidFill>
                     <a:srgbClr val="334155"/>
                   </a:solidFill>
-                  <a:latin typeface="+mn-lt"/>
-                  <a:ea typeface="+mn-ea"/>
-                  <a:cs typeface="+mn-cs"/>
-                </a:rPr>
-                <a:t>85.2% total capital retained</a:t>
-              </a:r>
+                </a:rPr>
+                <a:t>After the Geopolitical Crisis shock</a:t>
+              </a:r>
+              <a:endParaRPr lang="en-US" sz="820" dirty="0">
+                <a:solidFill>
+                  <a:srgbClr val="334155"/>
+                </a:solidFill>
+                <a:latin typeface="+mn-lt"/>
+                <a:ea typeface="+mn-ea"/>
+                <a:cs typeface="+mn-cs"/>
+              </a:endParaRPr>
             </a:p>
           </p:txBody>
         </p:sp>
@@ -15793,27 +15434,26 @@
           <p:spPr>
             <a:xfrm>
               <a:off x="9148762" y="5880100"/>
-              <a:ext cx="1900839" cy="161925"/>
-            </a:xfrm>
-            <a:prstGeom prst="rect">
-              <a:avLst/>
-            </a:prstGeom>
-            <a:noFill/>
-            <a:ln>
-              <a:noFill/>
-            </a:ln>
-          </p:spPr>
-          <p:txBody>
-            <a:bodyPr wrap="none" lIns="0" tIns="0" rIns="0" bIns="0" anchor="t" anchorCtr="0">
-              <a:spAutoFit/>
-            </a:bodyPr>
-            <a:lstStyle/>
-            <a:p>
-              <a:pPr marL="76200" indent="-76200" algn="l">
+              <a:ext cx="1944443" cy="126188"/>
+            </a:xfrm>
+            <a:prstGeom prst="rect">
+              <a:avLst/>
+            </a:prstGeom>
+            <a:noFill/>
+            <a:ln>
+              <a:noFill/>
+            </a:ln>
+          </p:spPr>
+          <p:txBody>
+            <a:bodyPr wrap="none" lIns="0" tIns="0" rIns="0" bIns="0" anchor="t" anchorCtr="0">
+              <a:spAutoFit/>
+            </a:bodyPr>
+            <a:lstStyle/>
+            <a:p>
+              <a:pPr marL="76200" indent="-76200">
                 <a:buClr>
                   <a:srgbClr val="047857"/>
                 </a:buClr>
-                <a:buSzTx/>
                 <a:buFontTx/>
                 <a:buChar char="•"/>
               </a:pPr>
@@ -15822,12 +15462,17 @@
                   <a:solidFill>
                     <a:srgbClr val="047857"/>
                   </a:solidFill>
-                  <a:latin typeface="+mn-lt"/>
-                  <a:ea typeface="+mn-ea"/>
-                  <a:cs typeface="+mn-cs"/>
-                </a:rPr>
-                <a:t>VaR(99): $42.6M | CVaR(99): $58.1M</a:t>
-              </a:r>
+                </a:rPr>
+                <a:t>Delta-normal factor model, 7 scenarios</a:t>
+              </a:r>
+              <a:endParaRPr lang="en-US" sz="820" dirty="0">
+                <a:solidFill>
+                  <a:srgbClr val="047857"/>
+                </a:solidFill>
+                <a:latin typeface="+mn-lt"/>
+                <a:ea typeface="+mn-ea"/>
+                <a:cs typeface="+mn-cs"/>
+              </a:endParaRPr>
             </a:p>
           </p:txBody>
         </p:sp>
@@ -15970,6 +15615,63 @@
           </p:txBody>
         </p:sp>
       </p:grpSp>
+      <p:sp>
+        <p:nvSpPr>
+          <p:cNvPr id="99" name="TextBox 82">
+            <a:extLst>
+              <a:ext uri="{FF2B5EF4-FFF2-40B4-BE49-F238E27FC236}">
+                <a16:creationId xmlns:a16="http://schemas.microsoft.com/office/drawing/2014/main" id="{969DC532-5EE9-C397-2287-3E8E27CB81CA}"/>
+              </a:ext>
+            </a:extLst>
+          </p:cNvPr>
+          <p:cNvSpPr txBox="1"/>
+          <p:nvPr/>
+        </p:nvSpPr>
+        <p:spPr>
+          <a:xfrm>
+            <a:off x="3529812" y="6051592"/>
+            <a:ext cx="1944443" cy="126188"/>
+          </a:xfrm>
+          <a:prstGeom prst="rect">
+            <a:avLst/>
+          </a:prstGeom>
+          <a:noFill/>
+          <a:ln>
+            <a:noFill/>
+          </a:ln>
+        </p:spPr>
+        <p:txBody>
+          <a:bodyPr wrap="none" lIns="0" tIns="0" rIns="0" bIns="0" anchor="t" anchorCtr="0">
+            <a:spAutoFit/>
+          </a:bodyPr>
+          <a:lstStyle/>
+          <a:p>
+            <a:pPr marL="76200" indent="-76200">
+              <a:buClr>
+                <a:srgbClr val="334155"/>
+              </a:buClr>
+              <a:buFontTx/>
+              <a:buChar char="•"/>
+            </a:pPr>
+            <a:r>
+              <a:rPr lang="en-US" sz="820" dirty="0">
+                <a:solidFill>
+                  <a:srgbClr val="334155"/>
+                </a:solidFill>
+              </a:rPr>
+              <a:t>Worst asset: US Treasury 10Y (-$16.36M)</a:t>
+            </a:r>
+            <a:endParaRPr lang="en-US" sz="820" dirty="0">
+              <a:solidFill>
+                <a:srgbClr val="334155"/>
+              </a:solidFill>
+              <a:latin typeface="+mn-lt"/>
+              <a:ea typeface="+mn-ea"/>
+              <a:cs typeface="+mn-cs"/>
+            </a:endParaRPr>
+          </a:p>
+        </p:txBody>
+      </p:sp>
     </p:spTree>
   </p:cSld>
   <p:clrMapOvr>
@@ -16162,9 +15864,9 @@
         <p:grpSpPr>
           <a:xfrm>
             <a:off x="559308" y="641350"/>
-            <a:ext cx="6151271" cy="599059"/>
+            <a:ext cx="6151271" cy="555283"/>
             <a:chOff x="559308" y="641350"/>
-            <a:chExt cx="6151271" cy="599059"/>
+            <a:chExt cx="6151271" cy="555283"/>
           </a:xfrm>
         </p:grpSpPr>
         <p:sp>
@@ -16216,34 +15918,38 @@
           <p:spPr>
             <a:xfrm>
               <a:off x="566166" y="1035050"/>
-              <a:ext cx="5952959" cy="205359"/>
-            </a:xfrm>
-            <a:prstGeom prst="rect">
-              <a:avLst/>
-            </a:prstGeom>
-            <a:noFill/>
-            <a:ln>
-              <a:noFill/>
-            </a:ln>
-          </p:spPr>
-          <p:txBody>
-            <a:bodyPr wrap="none" lIns="0" tIns="0" rIns="0" bIns="0" anchor="t" anchorCtr="0">
-              <a:spAutoFit/>
-            </a:bodyPr>
-            <a:lstStyle/>
-            <a:p>
-              <a:pPr algn="l"/>
+              <a:ext cx="4844275" cy="161583"/>
+            </a:xfrm>
+            <a:prstGeom prst="rect">
+              <a:avLst/>
+            </a:prstGeom>
+            <a:noFill/>
+            <a:ln>
+              <a:noFill/>
+            </a:ln>
+          </p:spPr>
+          <p:txBody>
+            <a:bodyPr wrap="none" lIns="0" tIns="0" rIns="0" bIns="0" anchor="t" anchorCtr="0">
+              <a:spAutoFit/>
+            </a:bodyPr>
+            <a:lstStyle/>
+            <a:p>
               <a:r>
                 <a:rPr lang="en-US" sz="1050" dirty="0">
                   <a:solidFill>
                     <a:schemeClr val="accent5"/>
                   </a:solidFill>
-                  <a:latin typeface="+mn-lt"/>
-                  <a:ea typeface="+mn-ea"/>
-                  <a:cs typeface="+mn-cs"/>
-                </a:rPr>
-                <a:t>Delivering Strategic Value Across Credit Surveillance, Asset Management &amp; Corporate Treasury</a:t>
-              </a:r>
+                </a:rPr>
+                <a:t>Potential use cases for credit surveillance, asset management and risk committees</a:t>
+              </a:r>
+              <a:endParaRPr lang="en-US" sz="1050" dirty="0">
+                <a:solidFill>
+                  <a:schemeClr val="accent5"/>
+                </a:solidFill>
+                <a:latin typeface="+mn-lt"/>
+                <a:ea typeface="+mn-ea"/>
+                <a:cs typeface="+mn-cs"/>
+              </a:endParaRPr>
             </a:p>
           </p:txBody>
         </p:sp>
@@ -16477,34 +16183,38 @@
           <p:spPr>
             <a:xfrm>
               <a:off x="833438" y="1962150"/>
-              <a:ext cx="2104039" cy="176212"/>
-            </a:xfrm>
-            <a:prstGeom prst="rect">
-              <a:avLst/>
-            </a:prstGeom>
-            <a:noFill/>
-            <a:ln>
-              <a:noFill/>
-            </a:ln>
-          </p:spPr>
-          <p:txBody>
-            <a:bodyPr wrap="none" lIns="0" tIns="0" rIns="0" bIns="0" anchor="t" anchorCtr="0">
-              <a:spAutoFit/>
-            </a:bodyPr>
-            <a:lstStyle/>
-            <a:p>
-              <a:pPr algn="l"/>
+              <a:ext cx="1516441" cy="138499"/>
+            </a:xfrm>
+            <a:prstGeom prst="rect">
+              <a:avLst/>
+            </a:prstGeom>
+            <a:noFill/>
+            <a:ln>
+              <a:noFill/>
+            </a:ln>
+          </p:spPr>
+          <p:txBody>
+            <a:bodyPr wrap="none" lIns="0" tIns="0" rIns="0" bIns="0" anchor="t" anchorCtr="0">
+              <a:spAutoFit/>
+            </a:bodyPr>
+            <a:lstStyle/>
+            <a:p>
               <a:r>
                 <a:rPr lang="en-US" sz="900" b="1" dirty="0">
                   <a:solidFill>
                     <a:schemeClr val="accent1"/>
                   </a:solidFill>
-                  <a:latin typeface="+mn-lt"/>
-                  <a:ea typeface="+mn-ea"/>
-                  <a:cs typeface="+mn-cs"/>
-                </a:rPr>
-                <a:t>Sub-15 Min Downgrade Surveillance</a:t>
-              </a:r>
+                </a:rPr>
+                <a:t>Faster Risk Signal Screening</a:t>
+              </a:r>
+              <a:endParaRPr lang="en-US" sz="900" b="1" dirty="0">
+                <a:solidFill>
+                  <a:schemeClr val="accent1"/>
+                </a:solidFill>
+                <a:latin typeface="+mn-lt"/>
+                <a:ea typeface="+mn-ea"/>
+                <a:cs typeface="+mn-cs"/>
+              </a:endParaRPr>
             </a:p>
           </p:txBody>
         </p:sp>
@@ -16517,23 +16227,23 @@
           <p:spPr>
             <a:xfrm>
               <a:off x="833438" y="2152650"/>
-              <a:ext cx="2517070" cy="466725"/>
-            </a:xfrm>
-            <a:prstGeom prst="rect">
-              <a:avLst/>
-            </a:prstGeom>
-            <a:noFill/>
-            <a:ln>
-              <a:noFill/>
-            </a:ln>
-          </p:spPr>
-          <p:txBody>
-            <a:bodyPr wrap="none" lIns="0" tIns="0" rIns="0" bIns="0" anchor="t" anchorCtr="0">
-              <a:spAutoFit/>
-            </a:bodyPr>
-            <a:lstStyle/>
-            <a:p>
-              <a:pPr algn="l">
+              <a:ext cx="2979983" cy="293157"/>
+            </a:xfrm>
+            <a:prstGeom prst="rect">
+              <a:avLst/>
+            </a:prstGeom>
+            <a:noFill/>
+            <a:ln>
+              <a:noFill/>
+            </a:ln>
+          </p:spPr>
+          <p:txBody>
+            <a:bodyPr wrap="none" lIns="0" tIns="0" rIns="0" bIns="0" anchor="t" anchorCtr="0">
+              <a:spAutoFit/>
+            </a:bodyPr>
+            <a:lstStyle/>
+            <a:p>
+              <a:pPr>
                 <a:lnSpc>
                   <a:spcPts val="1200"/>
                 </a:lnSpc>
@@ -16543,54 +16253,32 @@
                   <a:solidFill>
                     <a:srgbClr val="334155"/>
                   </a:solidFill>
-                  <a:latin typeface="+mn-lt"/>
-                  <a:ea typeface="+mn-ea"/>
-                  <a:cs typeface="+mn-cs"/>
-                </a:rPr>
-                <a:t>Replaces 48-hour retrospective report latency with</a:t>
-              </a:r>
-              <a:br>
+                </a:rPr>
+                <a:t>Scores news and social signals automatically with FinBERT and a </a:t>
+              </a:r>
+            </a:p>
+            <a:p>
+              <a:pPr>
+                <a:lnSpc>
+                  <a:spcPts val="1200"/>
+                </a:lnSpc>
+              </a:pPr>
+              <a:r>
                 <a:rPr lang="en-US" sz="820" dirty="0">
                   <a:solidFill>
                     <a:srgbClr val="334155"/>
                   </a:solidFill>
-                  <a:latin typeface="+mn-lt"/>
-                  <a:ea typeface="+mn-ea"/>
-                  <a:cs typeface="+mn-cs"/>
-                </a:rPr>
-              </a:br>
-              <a:r>
-                <a:rPr lang="en-US" sz="820" dirty="0">
-                  <a:solidFill>
-                    <a:srgbClr val="334155"/>
-                  </a:solidFill>
-                  <a:latin typeface="+mn-lt"/>
-                  <a:ea typeface="+mn-ea"/>
-                  <a:cs typeface="+mn-cs"/>
-                </a:rPr>
-                <a:t>continuous automated sentiment monitoring across</a:t>
-              </a:r>
-              <a:br>
-                <a:rPr lang="en-US" sz="820" dirty="0">
-                  <a:solidFill>
-                    <a:srgbClr val="334155"/>
-                  </a:solidFill>
-                  <a:latin typeface="+mn-lt"/>
-                  <a:ea typeface="+mn-ea"/>
-                  <a:cs typeface="+mn-cs"/>
-                </a:rPr>
-              </a:br>
-              <a:r>
-                <a:rPr lang="en-US" sz="820" dirty="0">
-                  <a:solidFill>
-                    <a:srgbClr val="334155"/>
-                  </a:solidFill>
-                  <a:latin typeface="+mn-lt"/>
-                  <a:ea typeface="+mn-ea"/>
-                  <a:cs typeface="+mn-cs"/>
-                </a:rPr>
-                <a:t>10-K filings, news wire feeds, and litigation disclosures.</a:t>
-              </a:r>
+                </a:rPr>
+                <a:t>Keyword taxonomy, so analysts see high-impact events sooner.</a:t>
+              </a:r>
+              <a:endParaRPr lang="en-US" sz="820" dirty="0">
+                <a:solidFill>
+                  <a:srgbClr val="334155"/>
+                </a:solidFill>
+                <a:latin typeface="+mn-lt"/>
+                <a:ea typeface="+mn-ea"/>
+                <a:cs typeface="+mn-cs"/>
+              </a:endParaRPr>
             </a:p>
           </p:txBody>
         </p:sp>
@@ -16636,34 +16324,38 @@
           <p:spPr>
             <a:xfrm>
               <a:off x="833438" y="2990850"/>
-              <a:ext cx="1986678" cy="176212"/>
-            </a:xfrm>
-            <a:prstGeom prst="rect">
-              <a:avLst/>
-            </a:prstGeom>
-            <a:noFill/>
-            <a:ln>
-              <a:noFill/>
-            </a:ln>
-          </p:spPr>
-          <p:txBody>
-            <a:bodyPr wrap="none" lIns="0" tIns="0" rIns="0" bIns="0" anchor="t" anchorCtr="0">
-              <a:spAutoFit/>
-            </a:bodyPr>
-            <a:lstStyle/>
-            <a:p>
-              <a:pPr algn="l"/>
+              <a:ext cx="1183016" cy="138499"/>
+            </a:xfrm>
+            <a:prstGeom prst="rect">
+              <a:avLst/>
+            </a:prstGeom>
+            <a:noFill/>
+            <a:ln>
+              <a:noFill/>
+            </a:ln>
+          </p:spPr>
+          <p:txBody>
+            <a:bodyPr wrap="none" lIns="0" tIns="0" rIns="0" bIns="0" anchor="t" anchorCtr="0">
+              <a:spAutoFit/>
+            </a:bodyPr>
+            <a:lstStyle/>
+            <a:p>
               <a:r>
                 <a:rPr lang="en-US" sz="900" b="1" dirty="0">
                   <a:solidFill>
                     <a:schemeClr val="accent1"/>
                   </a:solidFill>
-                  <a:latin typeface="+mn-lt"/>
-                  <a:ea typeface="+mn-ea"/>
-                  <a:cs typeface="+mn-cs"/>
-                </a:rPr>
-                <a:t>CreditWatch Outlook Pre-Emption</a:t>
-              </a:r>
+                </a:rPr>
+                <a:t>Early Warning Signals</a:t>
+              </a:r>
+              <a:endParaRPr lang="en-US" sz="900" b="1" dirty="0">
+                <a:solidFill>
+                  <a:schemeClr val="accent1"/>
+                </a:solidFill>
+                <a:latin typeface="+mn-lt"/>
+                <a:ea typeface="+mn-ea"/>
+                <a:cs typeface="+mn-cs"/>
+              </a:endParaRPr>
             </a:p>
           </p:txBody>
         </p:sp>
@@ -16676,23 +16368,23 @@
           <p:spPr>
             <a:xfrm>
               <a:off x="833438" y="3181350"/>
-              <a:ext cx="2411379" cy="466725"/>
-            </a:xfrm>
-            <a:prstGeom prst="rect">
-              <a:avLst/>
-            </a:prstGeom>
-            <a:noFill/>
-            <a:ln>
-              <a:noFill/>
-            </a:ln>
-          </p:spPr>
-          <p:txBody>
-            <a:bodyPr wrap="none" lIns="0" tIns="0" rIns="0" bIns="0" anchor="t" anchorCtr="0">
-              <a:spAutoFit/>
-            </a:bodyPr>
-            <a:lstStyle/>
-            <a:p>
-              <a:pPr algn="l">
+              <a:ext cx="2744341" cy="293157"/>
+            </a:xfrm>
+            <a:prstGeom prst="rect">
+              <a:avLst/>
+            </a:prstGeom>
+            <a:noFill/>
+            <a:ln>
+              <a:noFill/>
+            </a:ln>
+          </p:spPr>
+          <p:txBody>
+            <a:bodyPr wrap="none" lIns="0" tIns="0" rIns="0" bIns="0" anchor="t" anchorCtr="0">
+              <a:spAutoFit/>
+            </a:bodyPr>
+            <a:lstStyle/>
+            <a:p>
+              <a:pPr>
                 <a:lnSpc>
                   <a:spcPts val="1200"/>
                 </a:lnSpc>
@@ -16702,54 +16394,32 @@
                   <a:solidFill>
                     <a:srgbClr val="334155"/>
                   </a:solidFill>
-                  <a:latin typeface="+mn-lt"/>
-                  <a:ea typeface="+mn-ea"/>
-                  <a:cs typeface="+mn-cs"/>
-                </a:rPr>
-                <a:t>Detects early credit deterioration and supplier stress</a:t>
-              </a:r>
-              <a:br>
+                </a:rPr>
+                <a:t>Flags negative credit and geopolitical events early as inputs</a:t>
+              </a:r>
+            </a:p>
+            <a:p>
+              <a:pPr>
+                <a:lnSpc>
+                  <a:spcPts val="1200"/>
+                </a:lnSpc>
+              </a:pPr>
+              <a:r>
                 <a:rPr lang="en-US" sz="820" dirty="0">
                   <a:solidFill>
                     <a:srgbClr val="334155"/>
                   </a:solidFill>
-                  <a:latin typeface="+mn-lt"/>
-                  <a:ea typeface="+mn-ea"/>
-                  <a:cs typeface="+mn-cs"/>
-                </a:rPr>
-              </a:br>
-              <a:r>
-                <a:rPr lang="en-US" sz="820" dirty="0">
-                  <a:solidFill>
-                    <a:srgbClr val="334155"/>
-                  </a:solidFill>
-                  <a:latin typeface="+mn-lt"/>
-                  <a:ea typeface="+mn-ea"/>
-                  <a:cs typeface="+mn-cs"/>
-                </a:rPr>
-                <a:t>weeks before official bond covenant breaches occur,</a:t>
-              </a:r>
-              <a:br>
-                <a:rPr lang="en-US" sz="820" dirty="0">
-                  <a:solidFill>
-                    <a:srgbClr val="334155"/>
-                  </a:solidFill>
-                  <a:latin typeface="+mn-lt"/>
-                  <a:ea typeface="+mn-ea"/>
-                  <a:cs typeface="+mn-cs"/>
-                </a:rPr>
-              </a:br>
-              <a:r>
-                <a:rPr lang="en-US" sz="820" dirty="0">
-                  <a:solidFill>
-                    <a:srgbClr val="334155"/>
-                  </a:solidFill>
-                  <a:latin typeface="+mn-lt"/>
-                  <a:ea typeface="+mn-ea"/>
-                  <a:cs typeface="+mn-cs"/>
-                </a:rPr>
-                <a:t>supporting preemptive CreditWatch placement.</a:t>
-              </a:r>
+                </a:rPr>
+                <a:t>to analyst review</a:t>
+              </a:r>
+              <a:endParaRPr lang="en-US" sz="820" dirty="0">
+                <a:solidFill>
+                  <a:srgbClr val="334155"/>
+                </a:solidFill>
+                <a:latin typeface="+mn-lt"/>
+                <a:ea typeface="+mn-ea"/>
+                <a:cs typeface="+mn-cs"/>
+              </a:endParaRPr>
             </a:p>
           </p:txBody>
         </p:sp>
@@ -16795,34 +16465,38 @@
           <p:spPr>
             <a:xfrm>
               <a:off x="833438" y="4019550"/>
-              <a:ext cx="1972132" cy="176212"/>
-            </a:xfrm>
-            <a:prstGeom prst="rect">
-              <a:avLst/>
-            </a:prstGeom>
-            <a:noFill/>
-            <a:ln>
-              <a:noFill/>
-            </a:ln>
-          </p:spPr>
-          <p:txBody>
-            <a:bodyPr wrap="none" lIns="0" tIns="0" rIns="0" bIns="0" anchor="t" anchorCtr="0">
-              <a:spAutoFit/>
-            </a:bodyPr>
-            <a:lstStyle/>
-            <a:p>
-              <a:pPr algn="l"/>
+              <a:ext cx="968214" cy="138499"/>
+            </a:xfrm>
+            <a:prstGeom prst="rect">
+              <a:avLst/>
+            </a:prstGeom>
+            <a:noFill/>
+            <a:ln>
+              <a:noFill/>
+            </a:ln>
+          </p:spPr>
+          <p:txBody>
+            <a:bodyPr wrap="none" lIns="0" tIns="0" rIns="0" bIns="0" anchor="t" anchorCtr="0">
+              <a:spAutoFit/>
+            </a:bodyPr>
+            <a:lstStyle/>
+            <a:p>
               <a:r>
                 <a:rPr lang="en-US" sz="900" b="1" dirty="0">
                   <a:solidFill>
                     <a:schemeClr val="accent1"/>
                   </a:solidFill>
-                  <a:latin typeface="+mn-lt"/>
-                  <a:ea typeface="+mn-ea"/>
-                  <a:cs typeface="+mn-cs"/>
-                </a:rPr>
-                <a:t>Audit-Proof Methodology Tracing</a:t>
-              </a:r>
+                </a:rPr>
+                <a:t>Traceable Scoring</a:t>
+              </a:r>
+              <a:endParaRPr lang="en-US" sz="900" b="1" dirty="0">
+                <a:solidFill>
+                  <a:schemeClr val="accent1"/>
+                </a:solidFill>
+                <a:latin typeface="+mn-lt"/>
+                <a:ea typeface="+mn-ea"/>
+                <a:cs typeface="+mn-cs"/>
+              </a:endParaRPr>
             </a:p>
           </p:txBody>
         </p:sp>
@@ -16835,23 +16509,23 @@
           <p:spPr>
             <a:xfrm>
               <a:off x="833438" y="4210050"/>
-              <a:ext cx="2424407" cy="466725"/>
-            </a:xfrm>
-            <a:prstGeom prst="rect">
-              <a:avLst/>
-            </a:prstGeom>
-            <a:noFill/>
-            <a:ln>
-              <a:noFill/>
-            </a:ln>
-          </p:spPr>
-          <p:txBody>
-            <a:bodyPr wrap="none" lIns="0" tIns="0" rIns="0" bIns="0" anchor="t" anchorCtr="0">
-              <a:spAutoFit/>
-            </a:bodyPr>
-            <a:lstStyle/>
-            <a:p>
-              <a:pPr algn="l">
+              <a:ext cx="2792431" cy="293157"/>
+            </a:xfrm>
+            <a:prstGeom prst="rect">
+              <a:avLst/>
+            </a:prstGeom>
+            <a:noFill/>
+            <a:ln>
+              <a:noFill/>
+            </a:ln>
+          </p:spPr>
+          <p:txBody>
+            <a:bodyPr wrap="none" lIns="0" tIns="0" rIns="0" bIns="0" anchor="t" anchorCtr="0">
+              <a:spAutoFit/>
+            </a:bodyPr>
+            <a:lstStyle/>
+            <a:p>
+              <a:pPr>
                 <a:lnSpc>
                   <a:spcPts val="1200"/>
                 </a:lnSpc>
@@ -16861,54 +16535,32 @@
                   <a:solidFill>
                     <a:srgbClr val="334155"/>
                   </a:solidFill>
-                  <a:latin typeface="+mn-lt"/>
-                  <a:ea typeface="+mn-ea"/>
-                  <a:cs typeface="+mn-cs"/>
-                </a:rPr>
-                <a:t>Immutable PostgreSQL logs tie every rating signal to</a:t>
-              </a:r>
-              <a:br>
+                </a:rPr>
+                <a:t>Each signal keeps its source, category, sentiment and impact</a:t>
+              </a:r>
+            </a:p>
+            <a:p>
+              <a:pPr>
+                <a:lnSpc>
+                  <a:spcPts val="1200"/>
+                </a:lnSpc>
+              </a:pPr>
+              <a:r>
                 <a:rPr lang="en-US" sz="820" dirty="0">
                   <a:solidFill>
                     <a:srgbClr val="334155"/>
                   </a:solidFill>
-                  <a:latin typeface="+mn-lt"/>
-                  <a:ea typeface="+mn-ea"/>
-                  <a:cs typeface="+mn-cs"/>
-                </a:rPr>
-              </a:br>
-              <a:r>
-                <a:rPr lang="en-US" sz="820" dirty="0">
-                  <a:solidFill>
-                    <a:srgbClr val="334155"/>
-                  </a:solidFill>
-                  <a:latin typeface="+mn-lt"/>
-                  <a:ea typeface="+mn-ea"/>
-                  <a:cs typeface="+mn-cs"/>
-                </a:rPr>
-                <a:t>exact keywords, source URLs, and FinBERT weights,</a:t>
-              </a:r>
-              <a:br>
-                <a:rPr lang="en-US" sz="820" dirty="0">
-                  <a:solidFill>
-                    <a:srgbClr val="334155"/>
-                  </a:solidFill>
-                  <a:latin typeface="+mn-lt"/>
-                  <a:ea typeface="+mn-ea"/>
-                  <a:cs typeface="+mn-cs"/>
-                </a:rPr>
-              </a:br>
-              <a:r>
-                <a:rPr lang="en-US" sz="820" dirty="0">
-                  <a:solidFill>
-                    <a:srgbClr val="334155"/>
-                  </a:solidFill>
-                  <a:latin typeface="+mn-lt"/>
-                  <a:ea typeface="+mn-ea"/>
-                  <a:cs typeface="+mn-cs"/>
-                </a:rPr>
-                <a:t>guaranteeing complete regulatory auditability.</a:t>
-              </a:r>
+                </a:rPr>
+                <a:t>score in a PostgreSQL audit trail.</a:t>
+              </a:r>
+              <a:endParaRPr lang="en-US" sz="820" dirty="0">
+                <a:solidFill>
+                  <a:srgbClr val="334155"/>
+                </a:solidFill>
+                <a:latin typeface="+mn-lt"/>
+                <a:ea typeface="+mn-ea"/>
+                <a:cs typeface="+mn-cs"/>
+              </a:endParaRPr>
             </a:p>
           </p:txBody>
         </p:sp>
@@ -16954,34 +16606,38 @@
           <p:spPr>
             <a:xfrm>
               <a:off x="833438" y="5099050"/>
-              <a:ext cx="1504296" cy="161925"/>
-            </a:xfrm>
-            <a:prstGeom prst="rect">
-              <a:avLst/>
-            </a:prstGeom>
-            <a:noFill/>
-            <a:ln>
-              <a:noFill/>
-            </a:ln>
-          </p:spPr>
-          <p:txBody>
-            <a:bodyPr wrap="none" lIns="0" tIns="0" rIns="0" bIns="0" anchor="t" anchorCtr="0">
-              <a:spAutoFit/>
-            </a:bodyPr>
-            <a:lstStyle/>
-            <a:p>
-              <a:pPr algn="l"/>
+              <a:ext cx="1652697" cy="126188"/>
+            </a:xfrm>
+            <a:prstGeom prst="rect">
+              <a:avLst/>
+            </a:prstGeom>
+            <a:noFill/>
+            <a:ln>
+              <a:noFill/>
+            </a:ln>
+          </p:spPr>
+          <p:txBody>
+            <a:bodyPr wrap="none" lIns="0" tIns="0" rIns="0" bIns="0" anchor="t" anchorCtr="0">
+              <a:spAutoFit/>
+            </a:bodyPr>
+            <a:lstStyle/>
+            <a:p>
               <a:r>
                 <a:rPr lang="en-US" sz="820" b="1" dirty="0">
                   <a:solidFill>
                     <a:schemeClr val="accent1"/>
                   </a:solidFill>
-                  <a:latin typeface="+mn-lt"/>
-                  <a:ea typeface="+mn-ea"/>
-                  <a:cs typeface="+mn-cs"/>
-                </a:rPr>
-                <a:t>QUANTIFIED DESK IMPACT</a:t>
-              </a:r>
+                </a:rPr>
+                <a:t>PROTOTYPE RESULT / 7 scenarios</a:t>
+              </a:r>
+              <a:endParaRPr lang="en-US" sz="820" b="1" dirty="0">
+                <a:solidFill>
+                  <a:schemeClr val="accent1"/>
+                </a:solidFill>
+                <a:latin typeface="+mn-lt"/>
+                <a:ea typeface="+mn-ea"/>
+                <a:cs typeface="+mn-cs"/>
+              </a:endParaRPr>
             </a:p>
           </p:txBody>
         </p:sp>
@@ -17034,27 +16690,26 @@
           <p:spPr>
             <a:xfrm>
               <a:off x="833438" y="5670550"/>
-              <a:ext cx="2396761" cy="161925"/>
-            </a:xfrm>
-            <a:prstGeom prst="rect">
-              <a:avLst/>
-            </a:prstGeom>
-            <a:noFill/>
-            <a:ln>
-              <a:noFill/>
-            </a:ln>
-          </p:spPr>
-          <p:txBody>
-            <a:bodyPr wrap="none" lIns="0" tIns="0" rIns="0" bIns="0" anchor="t" anchorCtr="0">
-              <a:spAutoFit/>
-            </a:bodyPr>
-            <a:lstStyle/>
-            <a:p>
-              <a:pPr marL="76200" indent="-76200" algn="l">
+              <a:ext cx="1739259" cy="126188"/>
+            </a:xfrm>
+            <a:prstGeom prst="rect">
+              <a:avLst/>
+            </a:prstGeom>
+            <a:noFill/>
+            <a:ln>
+              <a:noFill/>
+            </a:ln>
+          </p:spPr>
+          <p:txBody>
+            <a:bodyPr wrap="none" lIns="0" tIns="0" rIns="0" bIns="0" anchor="t" anchorCtr="0">
+              <a:spAutoFit/>
+            </a:bodyPr>
+            <a:lstStyle/>
+            <a:p>
+              <a:pPr marL="76200" indent="-76200">
                 <a:buClr>
                   <a:srgbClr val="334155"/>
                 </a:buClr>
-                <a:buSzTx/>
                 <a:buFontTx/>
                 <a:buChar char="•"/>
               </a:pPr>
@@ -17063,12 +16718,17 @@
                   <a:solidFill>
                     <a:srgbClr val="334155"/>
                   </a:solidFill>
-                  <a:latin typeface="+mn-lt"/>
-                  <a:ea typeface="+mn-ea"/>
-                  <a:cs typeface="+mn-cs"/>
-                </a:rPr>
-                <a:t>Surveillance latency reduced from 48h to &lt;15m</a:t>
-              </a:r>
+                </a:rPr>
+                <a:t>15 assets, $585M synthetic portfolio</a:t>
+              </a:r>
+              <a:endParaRPr lang="en-US" sz="820" dirty="0">
+                <a:solidFill>
+                  <a:srgbClr val="334155"/>
+                </a:solidFill>
+                <a:latin typeface="+mn-lt"/>
+                <a:ea typeface="+mn-ea"/>
+                <a:cs typeface="+mn-cs"/>
+              </a:endParaRPr>
             </a:p>
           </p:txBody>
         </p:sp>
@@ -17081,27 +16741,26 @@
           <p:spPr>
             <a:xfrm>
               <a:off x="833438" y="5861050"/>
-              <a:ext cx="2444828" cy="161925"/>
-            </a:xfrm>
-            <a:prstGeom prst="rect">
-              <a:avLst/>
-            </a:prstGeom>
-            <a:noFill/>
-            <a:ln>
-              <a:noFill/>
-            </a:ln>
-          </p:spPr>
-          <p:txBody>
-            <a:bodyPr wrap="none" lIns="0" tIns="0" rIns="0" bIns="0" anchor="t" anchorCtr="0">
-              <a:spAutoFit/>
-            </a:bodyPr>
-            <a:lstStyle/>
-            <a:p>
-              <a:pPr marL="76200" indent="-76200" algn="l">
+              <a:ext cx="1457130" cy="126188"/>
+            </a:xfrm>
+            <a:prstGeom prst="rect">
+              <a:avLst/>
+            </a:prstGeom>
+            <a:noFill/>
+            <a:ln>
+              <a:noFill/>
+            </a:ln>
+          </p:spPr>
+          <p:txBody>
+            <a:bodyPr wrap="none" lIns="0" tIns="0" rIns="0" bIns="0" anchor="t" anchorCtr="0">
+              <a:spAutoFit/>
+            </a:bodyPr>
+            <a:lstStyle/>
+            <a:p>
+              <a:pPr marL="76200" indent="-76200">
                 <a:buClr>
                   <a:srgbClr val="1D4ED8"/>
                 </a:buClr>
-                <a:buSzTx/>
                 <a:buFontTx/>
                 <a:buChar char="•"/>
               </a:pPr>
@@ -17110,12 +16769,17 @@
                   <a:solidFill>
                     <a:srgbClr val="1D4ED8"/>
                   </a:solidFill>
-                  <a:latin typeface="+mn-lt"/>
-                  <a:ea typeface="+mn-ea"/>
-                  <a:cs typeface="+mn-cs"/>
-                </a:rPr>
-                <a:t>100% keyword explainability for SEC compliance</a:t>
-              </a:r>
+                </a:rPr>
+                <a:t>Keyword rules are inspectable</a:t>
+              </a:r>
+              <a:endParaRPr lang="en-US" sz="820" dirty="0">
+                <a:solidFill>
+                  <a:srgbClr val="1D4ED8"/>
+                </a:solidFill>
+                <a:latin typeface="+mn-lt"/>
+                <a:ea typeface="+mn-ea"/>
+                <a:cs typeface="+mn-cs"/>
+              </a:endParaRPr>
             </a:p>
           </p:txBody>
         </p:sp>
@@ -17349,34 +17013,38 @@
           <p:spPr>
             <a:xfrm>
               <a:off x="4510088" y="1962150"/>
-              <a:ext cx="1719792" cy="176212"/>
-            </a:xfrm>
-            <a:prstGeom prst="rect">
-              <a:avLst/>
-            </a:prstGeom>
-            <a:noFill/>
-            <a:ln>
-              <a:noFill/>
-            </a:ln>
-          </p:spPr>
-          <p:txBody>
-            <a:bodyPr wrap="none" lIns="0" tIns="0" rIns="0" bIns="0" anchor="t" anchorCtr="0">
-              <a:spAutoFit/>
-            </a:bodyPr>
-            <a:lstStyle/>
-            <a:p>
-              <a:pPr algn="l"/>
+              <a:ext cx="1275990" cy="138499"/>
+            </a:xfrm>
+            <a:prstGeom prst="rect">
+              <a:avLst/>
+            </a:prstGeom>
+            <a:noFill/>
+            <a:ln>
+              <a:noFill/>
+            </a:ln>
+          </p:spPr>
+          <p:txBody>
+            <a:bodyPr wrap="none" lIns="0" tIns="0" rIns="0" bIns="0" anchor="t" anchorCtr="0">
+              <a:spAutoFit/>
+            </a:bodyPr>
+            <a:lstStyle/>
+            <a:p>
               <a:r>
                 <a:rPr lang="en-US" sz="900" b="1" dirty="0">
                   <a:solidFill>
                     <a:srgbClr val="065F46"/>
                   </a:solidFill>
-                  <a:latin typeface="+mn-lt"/>
-                  <a:ea typeface="+mn-ea"/>
-                  <a:cs typeface="+mn-cs"/>
-                </a:rPr>
-                <a:t>Intraday Multi-Asset Tail-Risk</a:t>
-              </a:r>
+                </a:rPr>
+                <a:t>Multi-Asset Stress View</a:t>
+              </a:r>
+              <a:endParaRPr lang="en-US" sz="900" b="1" dirty="0">
+                <a:solidFill>
+                  <a:srgbClr val="065F46"/>
+                </a:solidFill>
+                <a:latin typeface="+mn-lt"/>
+                <a:ea typeface="+mn-ea"/>
+                <a:cs typeface="+mn-cs"/>
+              </a:endParaRPr>
             </a:p>
           </p:txBody>
         </p:sp>
@@ -17389,23 +17057,23 @@
           <p:spPr>
             <a:xfrm>
               <a:off x="4510088" y="2152650"/>
-              <a:ext cx="2424240" cy="466725"/>
-            </a:xfrm>
-            <a:prstGeom prst="rect">
-              <a:avLst/>
-            </a:prstGeom>
-            <a:noFill/>
-            <a:ln>
-              <a:noFill/>
-            </a:ln>
-          </p:spPr>
-          <p:txBody>
-            <a:bodyPr wrap="none" lIns="0" tIns="0" rIns="0" bIns="0" anchor="t" anchorCtr="0">
-              <a:spAutoFit/>
-            </a:bodyPr>
-            <a:lstStyle/>
-            <a:p>
-              <a:pPr algn="l">
+              <a:ext cx="2330766" cy="293157"/>
+            </a:xfrm>
+            <a:prstGeom prst="rect">
+              <a:avLst/>
+            </a:prstGeom>
+            <a:noFill/>
+            <a:ln>
+              <a:noFill/>
+            </a:ln>
+          </p:spPr>
+          <p:txBody>
+            <a:bodyPr wrap="none" lIns="0" tIns="0" rIns="0" bIns="0" anchor="t" anchorCtr="0">
+              <a:spAutoFit/>
+            </a:bodyPr>
+            <a:lstStyle/>
+            <a:p>
+              <a:pPr>
                 <a:lnSpc>
                   <a:spcPts val="1200"/>
                 </a:lnSpc>
@@ -17415,54 +17083,32 @@
                   <a:solidFill>
                     <a:srgbClr val="334155"/>
                   </a:solidFill>
-                  <a:latin typeface="+mn-lt"/>
-                  <a:ea typeface="+mn-ea"/>
-                  <a:cs typeface="+mn-cs"/>
-                </a:rPr>
-                <a:t>Replaces overnight batch reports with real-time</a:t>
-              </a:r>
-              <a:br>
+                </a:rPr>
+                <a:t>Shows loss, VaR and worst-hit asset across bonds, </a:t>
+              </a:r>
+            </a:p>
+            <a:p>
+              <a:pPr>
+                <a:lnSpc>
+                  <a:spcPts val="1200"/>
+                </a:lnSpc>
+              </a:pPr>
+              <a:r>
                 <a:rPr lang="en-US" sz="820" dirty="0">
                   <a:solidFill>
                     <a:srgbClr val="334155"/>
                   </a:solidFill>
-                  <a:latin typeface="+mn-lt"/>
-                  <a:ea typeface="+mn-ea"/>
-                  <a:cs typeface="+mn-cs"/>
-                </a:rPr>
-              </a:br>
-              <a:r>
-                <a:rPr lang="en-US" sz="820" dirty="0">
-                  <a:solidFill>
-                    <a:srgbClr val="334155"/>
-                  </a:solidFill>
-                  <a:latin typeface="+mn-lt"/>
-                  <a:ea typeface="+mn-ea"/>
-                  <a:cs typeface="+mn-cs"/>
-                </a:rPr>
-                <a:t>cross-asset factor sensitivities across equities, bonds,</a:t>
-              </a:r>
-              <a:br>
-                <a:rPr lang="en-US" sz="820" dirty="0">
-                  <a:solidFill>
-                    <a:srgbClr val="334155"/>
-                  </a:solidFill>
-                  <a:latin typeface="+mn-lt"/>
-                  <a:ea typeface="+mn-ea"/>
-                  <a:cs typeface="+mn-cs"/>
-                </a:rPr>
-              </a:br>
-              <a:r>
-                <a:rPr lang="en-US" sz="820" dirty="0">
-                  <a:solidFill>
-                    <a:srgbClr val="334155"/>
-                  </a:solidFill>
-                  <a:latin typeface="+mn-lt"/>
-                  <a:ea typeface="+mn-ea"/>
-                  <a:cs typeface="+mn-cs"/>
-                </a:rPr>
-                <a:t>loans, and derivative overlays during active hours.</a:t>
-              </a:r>
+                </a:rPr>
+                <a:t>loans, equities and derivatives.</a:t>
+              </a:r>
+              <a:endParaRPr lang="en-US" sz="820" dirty="0">
+                <a:solidFill>
+                  <a:srgbClr val="334155"/>
+                </a:solidFill>
+                <a:latin typeface="+mn-lt"/>
+                <a:ea typeface="+mn-ea"/>
+                <a:cs typeface="+mn-cs"/>
+              </a:endParaRPr>
             </a:p>
           </p:txBody>
         </p:sp>
@@ -17508,34 +17154,38 @@
           <p:spPr>
             <a:xfrm>
               <a:off x="4510088" y="2990850"/>
-              <a:ext cx="2070853" cy="176212"/>
-            </a:xfrm>
-            <a:prstGeom prst="rect">
-              <a:avLst/>
-            </a:prstGeom>
-            <a:noFill/>
-            <a:ln>
-              <a:noFill/>
-            </a:ln>
-          </p:spPr>
-          <p:txBody>
-            <a:bodyPr wrap="none" lIns="0" tIns="0" rIns="0" bIns="0" anchor="t" anchorCtr="0">
-              <a:spAutoFit/>
-            </a:bodyPr>
-            <a:lstStyle/>
-            <a:p>
-              <a:pPr algn="l"/>
+              <a:ext cx="1352934" cy="138499"/>
+            </a:xfrm>
+            <a:prstGeom prst="rect">
+              <a:avLst/>
+            </a:prstGeom>
+            <a:noFill/>
+            <a:ln>
+              <a:noFill/>
+            </a:ln>
+          </p:spPr>
+          <p:txBody>
+            <a:bodyPr wrap="none" lIns="0" tIns="0" rIns="0" bIns="0" anchor="t" anchorCtr="0">
+              <a:spAutoFit/>
+            </a:bodyPr>
+            <a:lstStyle/>
+            <a:p>
               <a:r>
                 <a:rPr lang="en-US" sz="900" b="1" dirty="0">
                   <a:solidFill>
                     <a:srgbClr val="065F46"/>
                   </a:solidFill>
-                  <a:latin typeface="+mn-lt"/>
-                  <a:ea typeface="+mn-ea"/>
-                  <a:cs typeface="+mn-cs"/>
-                </a:rPr>
-                <a:t>Rule A1 Automated Capital Defense</a:t>
-              </a:r>
+                </a:rPr>
+                <a:t>Automatic Stress Trigger</a:t>
+              </a:r>
+              <a:endParaRPr lang="en-US" sz="900" b="1" dirty="0">
+                <a:solidFill>
+                  <a:srgbClr val="065F46"/>
+                </a:solidFill>
+                <a:latin typeface="+mn-lt"/>
+                <a:ea typeface="+mn-ea"/>
+                <a:cs typeface="+mn-cs"/>
+              </a:endParaRPr>
             </a:p>
           </p:txBody>
         </p:sp>
@@ -17548,23 +17198,23 @@
           <p:spPr>
             <a:xfrm>
               <a:off x="4510088" y="3181350"/>
-              <a:ext cx="2451421" cy="466725"/>
-            </a:xfrm>
-            <a:prstGeom prst="rect">
-              <a:avLst/>
-            </a:prstGeom>
-            <a:noFill/>
-            <a:ln>
-              <a:noFill/>
-            </a:ln>
-          </p:spPr>
-          <p:txBody>
-            <a:bodyPr wrap="none" lIns="0" tIns="0" rIns="0" bIns="0" anchor="t" anchorCtr="0">
-              <a:spAutoFit/>
-            </a:bodyPr>
-            <a:lstStyle/>
-            <a:p>
-              <a:pPr algn="l">
+              <a:ext cx="2731517" cy="293157"/>
+            </a:xfrm>
+            <a:prstGeom prst="rect">
+              <a:avLst/>
+            </a:prstGeom>
+            <a:noFill/>
+            <a:ln>
+              <a:noFill/>
+            </a:ln>
+          </p:spPr>
+          <p:txBody>
+            <a:bodyPr wrap="none" lIns="0" tIns="0" rIns="0" bIns="0" anchor="t" anchorCtr="0">
+              <a:spAutoFit/>
+            </a:bodyPr>
+            <a:lstStyle/>
+            <a:p>
+              <a:pPr>
                 <a:lnSpc>
                   <a:spcPts val="1200"/>
                 </a:lnSpc>
@@ -17574,54 +17224,32 @@
                   <a:solidFill>
                     <a:srgbClr val="334155"/>
                   </a:solidFill>
-                  <a:latin typeface="+mn-lt"/>
-                  <a:ea typeface="+mn-ea"/>
-                  <a:cs typeface="+mn-cs"/>
-                </a:rPr>
-                <a:t>Automated trigger prompts dynamic hedging orders,</a:t>
-              </a:r>
-              <a:br>
+                </a:rPr>
+                <a:t>Impact score 7 or higher runs the matching stress scenario </a:t>
+              </a:r>
+            </a:p>
+            <a:p>
+              <a:pPr>
+                <a:lnSpc>
+                  <a:spcPts val="1200"/>
+                </a:lnSpc>
+              </a:pPr>
+              <a:r>
                 <a:rPr lang="en-US" sz="820" dirty="0">
                   <a:solidFill>
                     <a:srgbClr val="334155"/>
                   </a:solidFill>
-                  <a:latin typeface="+mn-lt"/>
-                  <a:ea typeface="+mn-ea"/>
-                  <a:cs typeface="+mn-cs"/>
-                </a:rPr>
-              </a:br>
-              <a:r>
-                <a:rPr lang="en-US" sz="820" dirty="0">
-                  <a:solidFill>
-                    <a:srgbClr val="334155"/>
-                  </a:solidFill>
-                  <a:latin typeface="+mn-lt"/>
-                  <a:ea typeface="+mn-ea"/>
-                  <a:cs typeface="+mn-cs"/>
-                </a:rPr>
-                <a:t>preserving capital before market contagion spreads</a:t>
-              </a:r>
-              <a:br>
-                <a:rPr lang="en-US" sz="820" dirty="0">
-                  <a:solidFill>
-                    <a:srgbClr val="334155"/>
-                  </a:solidFill>
-                  <a:latin typeface="+mn-lt"/>
-                  <a:ea typeface="+mn-ea"/>
-                  <a:cs typeface="+mn-cs"/>
-                </a:rPr>
-              </a:br>
-              <a:r>
-                <a:rPr lang="en-US" sz="820" dirty="0">
-                  <a:solidFill>
-                    <a:srgbClr val="334155"/>
-                  </a:solidFill>
-                  <a:latin typeface="+mn-lt"/>
-                  <a:ea typeface="+mn-ea"/>
-                  <a:cs typeface="+mn-cs"/>
-                </a:rPr>
-                <a:t>across correlated credit and equity tranches.</a:t>
-              </a:r>
+                </a:rPr>
+                <a:t>automatically. No trades or hedging orders are generated.</a:t>
+              </a:r>
+              <a:endParaRPr lang="en-US" sz="820" dirty="0">
+                <a:solidFill>
+                  <a:srgbClr val="334155"/>
+                </a:solidFill>
+                <a:latin typeface="+mn-lt"/>
+                <a:ea typeface="+mn-ea"/>
+                <a:cs typeface="+mn-cs"/>
+              </a:endParaRPr>
             </a:p>
           </p:txBody>
         </p:sp>
@@ -17707,23 +17335,23 @@
           <p:spPr>
             <a:xfrm>
               <a:off x="4510088" y="4210050"/>
-              <a:ext cx="2408046" cy="466725"/>
-            </a:xfrm>
-            <a:prstGeom prst="rect">
-              <a:avLst/>
-            </a:prstGeom>
-            <a:noFill/>
-            <a:ln>
-              <a:noFill/>
-            </a:ln>
-          </p:spPr>
-          <p:txBody>
-            <a:bodyPr wrap="none" lIns="0" tIns="0" rIns="0" bIns="0" anchor="t" anchorCtr="0">
-              <a:spAutoFit/>
-            </a:bodyPr>
-            <a:lstStyle/>
-            <a:p>
-              <a:pPr algn="l">
+              <a:ext cx="2418932" cy="447045"/>
+            </a:xfrm>
+            <a:prstGeom prst="rect">
+              <a:avLst/>
+            </a:prstGeom>
+            <a:noFill/>
+            <a:ln>
+              <a:noFill/>
+            </a:ln>
+          </p:spPr>
+          <p:txBody>
+            <a:bodyPr wrap="none" lIns="0" tIns="0" rIns="0" bIns="0" anchor="t" anchorCtr="0">
+              <a:spAutoFit/>
+            </a:bodyPr>
+            <a:lstStyle/>
+            <a:p>
+              <a:pPr>
                 <a:lnSpc>
                   <a:spcPts val="1200"/>
                 </a:lnSpc>
@@ -17779,7 +17407,26 @@
                   <a:ea typeface="+mn-ea"/>
                   <a:cs typeface="+mn-cs"/>
                 </a:rPr>
-                <a:t>waterfall redraws in under 80 milliseconds.</a:t>
+                <a:t>waterfall redraws </a:t>
+              </a:r>
+              <a:r>
+                <a:rPr lang="en-US" sz="820" dirty="0">
+                  <a:solidFill>
+                    <a:srgbClr val="334155"/>
+                  </a:solidFill>
+                </a:rPr>
+                <a:t>with instant chart updates.</a:t>
+              </a:r>
+              <a:r>
+                <a:rPr lang="en-US" sz="820" dirty="0">
+                  <a:solidFill>
+                    <a:srgbClr val="334155"/>
+                  </a:solidFill>
+                  <a:latin typeface="+mn-lt"/>
+                  <a:ea typeface="+mn-ea"/>
+                  <a:cs typeface="+mn-cs"/>
+                </a:rPr>
+                <a:t>.</a:t>
               </a:r>
             </a:p>
           </p:txBody>
@@ -17826,34 +17473,38 @@
           <p:spPr>
             <a:xfrm>
               <a:off x="4510088" y="5099050"/>
-              <a:ext cx="1849762" cy="161925"/>
-            </a:xfrm>
-            <a:prstGeom prst="rect">
-              <a:avLst/>
-            </a:prstGeom>
-            <a:noFill/>
-            <a:ln>
-              <a:noFill/>
-            </a:ln>
-          </p:spPr>
-          <p:txBody>
-            <a:bodyPr wrap="none" lIns="0" tIns="0" rIns="0" bIns="0" anchor="t" anchorCtr="0">
-              <a:spAutoFit/>
-            </a:bodyPr>
-            <a:lstStyle/>
-            <a:p>
-              <a:pPr algn="l"/>
+              <a:ext cx="878446" cy="126188"/>
+            </a:xfrm>
+            <a:prstGeom prst="rect">
+              <a:avLst/>
+            </a:prstGeom>
+            <a:noFill/>
+            <a:ln>
+              <a:noFill/>
+            </a:ln>
+          </p:spPr>
+          <p:txBody>
+            <a:bodyPr wrap="none" lIns="0" tIns="0" rIns="0" bIns="0" anchor="t" anchorCtr="0">
+              <a:spAutoFit/>
+            </a:bodyPr>
+            <a:lstStyle/>
+            <a:p>
               <a:r>
                 <a:rPr lang="en-US" sz="820" b="1" dirty="0">
                   <a:solidFill>
                     <a:srgbClr val="065F46"/>
                   </a:solidFill>
-                  <a:latin typeface="+mn-lt"/>
-                  <a:ea typeface="+mn-ea"/>
-                  <a:cs typeface="+mn-cs"/>
-                </a:rPr>
-                <a:t>CAPITAL PRESERVATION IMPACT</a:t>
-              </a:r>
+                </a:rPr>
+                <a:t>EXAMPLE RESULT</a:t>
+              </a:r>
+              <a:endParaRPr lang="en-US" sz="820" b="1" dirty="0">
+                <a:solidFill>
+                  <a:srgbClr val="065F46"/>
+                </a:solidFill>
+                <a:latin typeface="+mn-lt"/>
+                <a:ea typeface="+mn-ea"/>
+                <a:cs typeface="+mn-cs"/>
+              </a:endParaRPr>
             </a:p>
           </p:txBody>
         </p:sp>
@@ -17865,26 +17516,25 @@
           </p:nvSpPr>
           <p:spPr>
             <a:xfrm>
-              <a:off x="4505706" y="5327650"/>
-              <a:ext cx="1004011" cy="352044"/>
-            </a:xfrm>
-            <a:prstGeom prst="rect">
-              <a:avLst/>
-            </a:prstGeom>
-            <a:noFill/>
-            <a:ln>
-              <a:noFill/>
-            </a:ln>
-          </p:spPr>
-          <p:txBody>
-            <a:bodyPr wrap="none" lIns="0" tIns="0" rIns="0" bIns="0" anchor="t" anchorCtr="0">
-              <a:spAutoFit/>
-            </a:bodyPr>
-            <a:lstStyle/>
-            <a:p>
-              <a:pPr algn="l"/>
-              <a:r>
-                <a:rPr lang="en-US" sz="1800" b="1" dirty="0">
+              <a:off x="4510088" y="5342128"/>
+              <a:ext cx="1013098" cy="276999"/>
+            </a:xfrm>
+            <a:prstGeom prst="rect">
+              <a:avLst/>
+            </a:prstGeom>
+            <a:noFill/>
+            <a:ln>
+              <a:noFill/>
+            </a:ln>
+          </p:spPr>
+          <p:txBody>
+            <a:bodyPr wrap="none" lIns="0" tIns="0" rIns="0" bIns="0" anchor="t" anchorCtr="0">
+              <a:spAutoFit/>
+            </a:bodyPr>
+            <a:lstStyle/>
+            <a:p>
+              <a:r>
+                <a:rPr lang="en-US" b="1" dirty="0">
                   <a:solidFill>
                     <a:schemeClr val="accent2"/>
                   </a:solidFill>
@@ -17892,8 +17542,16 @@
                   <a:ea typeface="Consolas"/>
                   <a:cs typeface="Consolas"/>
                 </a:rPr>
-                <a:t>+$29.5M</a:t>
-              </a:r>
+                <a:t>-$55.44M</a:t>
+              </a:r>
+              <a:endParaRPr lang="en-US" sz="1800" b="1" dirty="0">
+                <a:solidFill>
+                  <a:schemeClr val="accent2"/>
+                </a:solidFill>
+                <a:latin typeface="Consolas"/>
+                <a:ea typeface="Consolas"/>
+                <a:cs typeface="Consolas"/>
+              </a:endParaRPr>
             </a:p>
           </p:txBody>
         </p:sp>
@@ -17906,27 +17564,26 @@
           <p:spPr>
             <a:xfrm>
               <a:off x="4510088" y="5670550"/>
-              <a:ext cx="2238884" cy="161925"/>
-            </a:xfrm>
-            <a:prstGeom prst="rect">
-              <a:avLst/>
-            </a:prstGeom>
-            <a:noFill/>
-            <a:ln>
-              <a:noFill/>
-            </a:ln>
-          </p:spPr>
-          <p:txBody>
-            <a:bodyPr wrap="none" lIns="0" tIns="0" rIns="0" bIns="0" anchor="t" anchorCtr="0">
-              <a:spAutoFit/>
-            </a:bodyPr>
-            <a:lstStyle/>
-            <a:p>
-              <a:pPr marL="76200" indent="-76200" algn="l">
+              <a:ext cx="1824217" cy="126188"/>
+            </a:xfrm>
+            <a:prstGeom prst="rect">
+              <a:avLst/>
+            </a:prstGeom>
+            <a:noFill/>
+            <a:ln>
+              <a:noFill/>
+            </a:ln>
+          </p:spPr>
+          <p:txBody>
+            <a:bodyPr wrap="none" lIns="0" tIns="0" rIns="0" bIns="0" anchor="t" anchorCtr="0">
+              <a:spAutoFit/>
+            </a:bodyPr>
+            <a:lstStyle/>
+            <a:p>
+              <a:pPr marL="76200" indent="-76200">
                 <a:buClr>
                   <a:srgbClr val="334155"/>
                 </a:buClr>
-                <a:buSzTx/>
                 <a:buFontTx/>
                 <a:buChar char="•"/>
               </a:pPr>
@@ -17935,12 +17592,17 @@
                   <a:solidFill>
                     <a:srgbClr val="334155"/>
                   </a:solidFill>
-                  <a:latin typeface="+mn-lt"/>
-                  <a:ea typeface="+mn-ea"/>
-                  <a:cs typeface="+mn-cs"/>
-                </a:rPr>
-                <a:t>25.4% unhedged loss recovered dynamically</a:t>
-              </a:r>
+                </a:rPr>
+                <a:t>Geopolitical Crisis: -9.48% of portfolio</a:t>
+              </a:r>
+              <a:endParaRPr lang="en-US" sz="820" dirty="0">
+                <a:solidFill>
+                  <a:srgbClr val="334155"/>
+                </a:solidFill>
+                <a:latin typeface="+mn-lt"/>
+                <a:ea typeface="+mn-ea"/>
+                <a:cs typeface="+mn-cs"/>
+              </a:endParaRPr>
             </a:p>
           </p:txBody>
         </p:sp>
@@ -17953,27 +17615,26 @@
           <p:spPr>
             <a:xfrm>
               <a:off x="4510088" y="5861050"/>
-              <a:ext cx="2303892" cy="161925"/>
-            </a:xfrm>
-            <a:prstGeom prst="rect">
-              <a:avLst/>
-            </a:prstGeom>
-            <a:noFill/>
-            <a:ln>
-              <a:noFill/>
-            </a:ln>
-          </p:spPr>
-          <p:txBody>
-            <a:bodyPr wrap="none" lIns="0" tIns="0" rIns="0" bIns="0" anchor="t" anchorCtr="0">
-              <a:spAutoFit/>
-            </a:bodyPr>
-            <a:lstStyle/>
-            <a:p>
-              <a:pPr marL="76200" indent="-76200" algn="l">
+              <a:ext cx="1897955" cy="126188"/>
+            </a:xfrm>
+            <a:prstGeom prst="rect">
+              <a:avLst/>
+            </a:prstGeom>
+            <a:noFill/>
+            <a:ln>
+              <a:noFill/>
+            </a:ln>
+          </p:spPr>
+          <p:txBody>
+            <a:bodyPr wrap="none" lIns="0" tIns="0" rIns="0" bIns="0" anchor="t" anchorCtr="0">
+              <a:spAutoFit/>
+            </a:bodyPr>
+            <a:lstStyle/>
+            <a:p>
+              <a:pPr marL="76200" indent="-76200">
                 <a:buClr>
                   <a:srgbClr val="047857"/>
                 </a:buClr>
-                <a:buSzTx/>
                 <a:buFontTx/>
                 <a:buChar char="•"/>
               </a:pPr>
@@ -17982,12 +17643,17 @@
                   <a:solidFill>
                     <a:srgbClr val="047857"/>
                   </a:solidFill>
-                  <a:latin typeface="+mn-lt"/>
-                  <a:ea typeface="+mn-ea"/>
-                  <a:cs typeface="+mn-cs"/>
-                </a:rPr>
-                <a:t>85.2% total portfolio value preserved in stress</a:t>
-              </a:r>
+                </a:rPr>
+                <a:t>1-day VaR $50.9M (95%), $72.0M (99%)</a:t>
+              </a:r>
+              <a:endParaRPr lang="en-US" sz="820" dirty="0">
+                <a:solidFill>
+                  <a:srgbClr val="047857"/>
+                </a:solidFill>
+                <a:latin typeface="+mn-lt"/>
+                <a:ea typeface="+mn-ea"/>
+                <a:cs typeface="+mn-cs"/>
+              </a:endParaRPr>
             </a:p>
           </p:txBody>
         </p:sp>
@@ -18261,23 +17927,23 @@
           <p:spPr>
             <a:xfrm>
               <a:off x="8186738" y="2152650"/>
-              <a:ext cx="2400173" cy="466725"/>
-            </a:xfrm>
-            <a:prstGeom prst="rect">
-              <a:avLst/>
-            </a:prstGeom>
-            <a:noFill/>
-            <a:ln>
-              <a:noFill/>
-            </a:ln>
-          </p:spPr>
-          <p:txBody>
-            <a:bodyPr wrap="none" lIns="0" tIns="0" rIns="0" bIns="0" anchor="t" anchorCtr="0">
-              <a:spAutoFit/>
-            </a:bodyPr>
-            <a:lstStyle/>
-            <a:p>
-              <a:pPr algn="l">
+              <a:ext cx="2407710" cy="447045"/>
+            </a:xfrm>
+            <a:prstGeom prst="rect">
+              <a:avLst/>
+            </a:prstGeom>
+            <a:noFill/>
+            <a:ln>
+              <a:noFill/>
+            </a:ln>
+          </p:spPr>
+          <p:txBody>
+            <a:bodyPr wrap="none" lIns="0" tIns="0" rIns="0" bIns="0" anchor="t" anchorCtr="0">
+              <a:spAutoFit/>
+            </a:bodyPr>
+            <a:lstStyle/>
+            <a:p>
+              <a:pPr>
                 <a:lnSpc>
                   <a:spcPts val="1200"/>
                 </a:lnSpc>
@@ -18329,12 +17995,17 @@
                   <a:solidFill>
                     <a:srgbClr val="334155"/>
                   </a:solidFill>
-                  <a:latin typeface="+mn-lt"/>
-                  <a:ea typeface="+mn-ea"/>
-                  <a:cs typeface="+mn-cs"/>
-                </a:rPr>
-                <a:t>designed for C-suite and board risk oversight.</a:t>
-              </a:r>
+                </a:rPr>
+                <a:t>to support risk reviews.</a:t>
+              </a:r>
+              <a:endParaRPr lang="en-US" sz="820" dirty="0">
+                <a:solidFill>
+                  <a:srgbClr val="334155"/>
+                </a:solidFill>
+                <a:latin typeface="+mn-lt"/>
+                <a:ea typeface="+mn-ea"/>
+                <a:cs typeface="+mn-cs"/>
+              </a:endParaRPr>
             </a:p>
           </p:txBody>
         </p:sp>
@@ -18380,34 +18051,38 @@
           <p:spPr>
             <a:xfrm>
               <a:off x="8186738" y="2990850"/>
-              <a:ext cx="2004576" cy="176212"/>
-            </a:xfrm>
-            <a:prstGeom prst="rect">
-              <a:avLst/>
-            </a:prstGeom>
-            <a:noFill/>
-            <a:ln>
-              <a:noFill/>
-            </a:ln>
-          </p:spPr>
-          <p:txBody>
-            <a:bodyPr wrap="none" lIns="0" tIns="0" rIns="0" bIns="0" anchor="t" anchorCtr="0">
-              <a:spAutoFit/>
-            </a:bodyPr>
-            <a:lstStyle/>
-            <a:p>
-              <a:pPr algn="l"/>
+              <a:ext cx="1854675" cy="138499"/>
+            </a:xfrm>
+            <a:prstGeom prst="rect">
+              <a:avLst/>
+            </a:prstGeom>
+            <a:noFill/>
+            <a:ln>
+              <a:noFill/>
+            </a:ln>
+          </p:spPr>
+          <p:txBody>
+            <a:bodyPr wrap="none" lIns="0" tIns="0" rIns="0" bIns="0" anchor="t" anchorCtr="0">
+              <a:spAutoFit/>
+            </a:bodyPr>
+            <a:lstStyle/>
+            <a:p>
               <a:r>
                 <a:rPr lang="en-US" sz="900" b="1" dirty="0">
                   <a:solidFill>
                     <a:srgbClr val="92400E"/>
                   </a:solidFill>
-                  <a:latin typeface="+mn-lt"/>
-                  <a:ea typeface="+mn-ea"/>
-                  <a:cs typeface="+mn-cs"/>
-                </a:rPr>
-                <a:t>Basel III &amp; FRTB Audit Compliance</a:t>
-              </a:r>
+                </a:rPr>
+                <a:t>Standardized Scenario Framework</a:t>
+              </a:r>
+              <a:endParaRPr lang="en-US" sz="900" b="1" dirty="0">
+                <a:solidFill>
+                  <a:srgbClr val="92400E"/>
+                </a:solidFill>
+                <a:latin typeface="+mn-lt"/>
+                <a:ea typeface="+mn-ea"/>
+                <a:cs typeface="+mn-cs"/>
+              </a:endParaRPr>
             </a:p>
           </p:txBody>
         </p:sp>
@@ -18420,23 +18095,23 @@
           <p:spPr>
             <a:xfrm>
               <a:off x="8186738" y="3181350"/>
-              <a:ext cx="2280683" cy="466725"/>
-            </a:xfrm>
-            <a:prstGeom prst="rect">
-              <a:avLst/>
-            </a:prstGeom>
-            <a:noFill/>
-            <a:ln>
-              <a:noFill/>
-            </a:ln>
-          </p:spPr>
-          <p:txBody>
-            <a:bodyPr wrap="none" lIns="0" tIns="0" rIns="0" bIns="0" anchor="t" anchorCtr="0">
-              <a:spAutoFit/>
-            </a:bodyPr>
-            <a:lstStyle/>
-            <a:p>
-              <a:pPr algn="l">
+              <a:ext cx="3002425" cy="293157"/>
+            </a:xfrm>
+            <a:prstGeom prst="rect">
+              <a:avLst/>
+            </a:prstGeom>
+            <a:noFill/>
+            <a:ln>
+              <a:noFill/>
+            </a:ln>
+          </p:spPr>
+          <p:txBody>
+            <a:bodyPr wrap="none" lIns="0" tIns="0" rIns="0" bIns="0" anchor="t" anchorCtr="0">
+              <a:spAutoFit/>
+            </a:bodyPr>
+            <a:lstStyle/>
+            <a:p>
+              <a:pPr>
                 <a:lnSpc>
                   <a:spcPts val="1200"/>
                 </a:lnSpc>
@@ -18446,54 +18121,32 @@
                   <a:solidFill>
                     <a:srgbClr val="334155"/>
                   </a:solidFill>
-                  <a:latin typeface="+mn-lt"/>
-                  <a:ea typeface="+mn-ea"/>
-                  <a:cs typeface="+mn-cs"/>
-                </a:rPr>
-                <a:t>Standardized stress testing framework aligns with</a:t>
-              </a:r>
-              <a:br>
+                </a:rPr>
+                <a:t>Seven fixed stress scenarios with adjustable shocks. A prototype, </a:t>
+              </a:r>
+            </a:p>
+            <a:p>
+              <a:pPr>
+                <a:lnSpc>
+                  <a:spcPts val="1200"/>
+                </a:lnSpc>
+              </a:pPr>
+              <a:r>
                 <a:rPr lang="en-US" sz="820" dirty="0">
                   <a:solidFill>
                     <a:srgbClr val="334155"/>
                   </a:solidFill>
-                  <a:latin typeface="+mn-lt"/>
-                  <a:ea typeface="+mn-ea"/>
-                  <a:cs typeface="+mn-cs"/>
-                </a:rPr>
-              </a:br>
-              <a:r>
-                <a:rPr lang="en-US" sz="820" dirty="0">
-                  <a:solidFill>
-                    <a:srgbClr val="334155"/>
-                  </a:solidFill>
-                  <a:latin typeface="+mn-lt"/>
-                  <a:ea typeface="+mn-ea"/>
-                  <a:cs typeface="+mn-cs"/>
-                </a:rPr>
-                <a:t>Fundamental Review of the Trading Book (FRTB)</a:t>
-              </a:r>
-              <a:br>
-                <a:rPr lang="en-US" sz="820" dirty="0">
-                  <a:solidFill>
-                    <a:srgbClr val="334155"/>
-                  </a:solidFill>
-                  <a:latin typeface="+mn-lt"/>
-                  <a:ea typeface="+mn-ea"/>
-                  <a:cs typeface="+mn-cs"/>
-                </a:rPr>
-              </a:br>
-              <a:r>
-                <a:rPr lang="en-US" sz="820" dirty="0">
-                  <a:solidFill>
-                    <a:srgbClr val="334155"/>
-                  </a:solidFill>
-                  <a:latin typeface="+mn-lt"/>
-                  <a:ea typeface="+mn-ea"/>
-                  <a:cs typeface="+mn-cs"/>
-                </a:rPr>
-                <a:t>and IFRS 9 expected credit loss regulations.</a:t>
-              </a:r>
+                </a:rPr>
+                <a:t>not a regulatory compliance system</a:t>
+              </a:r>
+              <a:endParaRPr lang="en-US" sz="820" dirty="0">
+                <a:solidFill>
+                  <a:srgbClr val="334155"/>
+                </a:solidFill>
+                <a:latin typeface="+mn-lt"/>
+                <a:ea typeface="+mn-ea"/>
+                <a:cs typeface="+mn-cs"/>
+              </a:endParaRPr>
             </a:p>
           </p:txBody>
         </p:sp>
@@ -18579,23 +18232,23 @@
           <p:spPr>
             <a:xfrm>
               <a:off x="8186738" y="4210050"/>
-              <a:ext cx="2486828" cy="466725"/>
-            </a:xfrm>
-            <a:prstGeom prst="rect">
-              <a:avLst/>
-            </a:prstGeom>
-            <a:noFill/>
-            <a:ln>
-              <a:noFill/>
-            </a:ln>
-          </p:spPr>
-          <p:txBody>
-            <a:bodyPr wrap="none" lIns="0" tIns="0" rIns="0" bIns="0" anchor="t" anchorCtr="0">
-              <a:spAutoFit/>
-            </a:bodyPr>
-            <a:lstStyle/>
-            <a:p>
-              <a:pPr algn="l">
+              <a:ext cx="2502288" cy="293157"/>
+            </a:xfrm>
+            <a:prstGeom prst="rect">
+              <a:avLst/>
+            </a:prstGeom>
+            <a:noFill/>
+            <a:ln>
+              <a:noFill/>
+            </a:ln>
+          </p:spPr>
+          <p:txBody>
+            <a:bodyPr wrap="none" lIns="0" tIns="0" rIns="0" bIns="0" anchor="t" anchorCtr="0">
+              <a:spAutoFit/>
+            </a:bodyPr>
+            <a:lstStyle/>
+            <a:p>
+              <a:pPr>
                 <a:lnSpc>
                   <a:spcPts val="1200"/>
                 </a:lnSpc>
@@ -18630,9 +18283,17 @@
                   <a:ea typeface="+mn-ea"/>
                   <a:cs typeface="+mn-cs"/>
                 </a:rPr>
-                <a:t>and regulatory investigations before they manifest</a:t>
-              </a:r>
-              <a:br>
+                <a:t>and regulatory investigations </a:t>
+              </a:r>
+              <a:r>
+                <a:rPr lang="en-US" sz="820" dirty="0">
+                  <a:solidFill>
+                    <a:srgbClr val="334155"/>
+                  </a:solidFill>
+                </a:rPr>
+                <a:t>to flag them early</a:t>
+              </a:r>
+              <a:r>
                 <a:rPr lang="en-US" sz="820" dirty="0">
                   <a:solidFill>
                     <a:srgbClr val="334155"/>
@@ -18641,17 +18302,7 @@
                   <a:ea typeface="+mn-ea"/>
                   <a:cs typeface="+mn-cs"/>
                 </a:rPr>
-              </a:br>
-              <a:r>
-                <a:rPr lang="en-US" sz="820" dirty="0">
-                  <a:solidFill>
-                    <a:srgbClr val="334155"/>
-                  </a:solidFill>
-                  <a:latin typeface="+mn-lt"/>
-                  <a:ea typeface="+mn-ea"/>
-                  <a:cs typeface="+mn-cs"/>
-                </a:rPr>
-                <a:t>as commercial debt impairments.</a:t>
+                <a:t>.</a:t>
               </a:r>
             </a:p>
           </p:txBody>
@@ -18738,25 +18389,24 @@
           <p:spPr>
             <a:xfrm>
               <a:off x="8182356" y="5327650"/>
-              <a:ext cx="551383" cy="352044"/>
-            </a:xfrm>
-            <a:prstGeom prst="rect">
-              <a:avLst/>
-            </a:prstGeom>
-            <a:noFill/>
-            <a:ln>
-              <a:noFill/>
-            </a:ln>
-          </p:spPr>
-          <p:txBody>
-            <a:bodyPr wrap="none" lIns="0" tIns="0" rIns="0" bIns="0" anchor="t" anchorCtr="0">
-              <a:spAutoFit/>
-            </a:bodyPr>
-            <a:lstStyle/>
-            <a:p>
-              <a:pPr algn="l"/>
-              <a:r>
-                <a:rPr lang="en-US" sz="1800" b="1" dirty="0">
+              <a:ext cx="1266372" cy="276999"/>
+            </a:xfrm>
+            <a:prstGeom prst="rect">
+              <a:avLst/>
+            </a:prstGeom>
+            <a:noFill/>
+            <a:ln>
+              <a:noFill/>
+            </a:ln>
+          </p:spPr>
+          <p:txBody>
+            <a:bodyPr wrap="none" lIns="0" tIns="0" rIns="0" bIns="0" anchor="t" anchorCtr="0">
+              <a:spAutoFit/>
+            </a:bodyPr>
+            <a:lstStyle/>
+            <a:p>
+              <a:r>
+                <a:rPr lang="en-US" b="1" dirty="0">
                   <a:solidFill>
                     <a:srgbClr val="B45309"/>
                   </a:solidFill>
@@ -18764,8 +18414,16 @@
                   <a:ea typeface="Consolas"/>
                   <a:cs typeface="Consolas"/>
                 </a:rPr>
-                <a:t>100%</a:t>
-              </a:r>
+                <a:t>PostgreSQL</a:t>
+              </a:r>
+              <a:endParaRPr lang="en-US" sz="1800" b="1" dirty="0">
+                <a:solidFill>
+                  <a:srgbClr val="B45309"/>
+                </a:solidFill>
+                <a:latin typeface="Consolas"/>
+                <a:ea typeface="Consolas"/>
+                <a:cs typeface="Consolas"/>
+              </a:endParaRPr>
             </a:p>
           </p:txBody>
         </p:sp>
@@ -18778,27 +18436,26 @@
           <p:spPr>
             <a:xfrm>
               <a:off x="8186738" y="5670550"/>
-              <a:ext cx="2122219" cy="161925"/>
-            </a:xfrm>
-            <a:prstGeom prst="rect">
-              <a:avLst/>
-            </a:prstGeom>
-            <a:noFill/>
-            <a:ln>
-              <a:noFill/>
-            </a:ln>
-          </p:spPr>
-          <p:txBody>
-            <a:bodyPr wrap="none" lIns="0" tIns="0" rIns="0" bIns="0" anchor="t" anchorCtr="0">
-              <a:spAutoFit/>
-            </a:bodyPr>
-            <a:lstStyle/>
-            <a:p>
-              <a:pPr marL="76200" indent="-76200" algn="l">
+              <a:ext cx="2883803" cy="252377"/>
+            </a:xfrm>
+            <a:prstGeom prst="rect">
+              <a:avLst/>
+            </a:prstGeom>
+            <a:noFill/>
+            <a:ln>
+              <a:noFill/>
+            </a:ln>
+          </p:spPr>
+          <p:txBody>
+            <a:bodyPr wrap="none" lIns="0" tIns="0" rIns="0" bIns="0" anchor="t" anchorCtr="0">
+              <a:spAutoFit/>
+            </a:bodyPr>
+            <a:lstStyle/>
+            <a:p>
+              <a:pPr marL="76200" indent="-76200">
                 <a:buClr>
                   <a:srgbClr val="334155"/>
                 </a:buClr>
-                <a:buSzTx/>
                 <a:buFontTx/>
                 <a:buChar char="•"/>
               </a:pPr>
@@ -18807,12 +18464,34 @@
                   <a:solidFill>
                     <a:srgbClr val="334155"/>
                   </a:solidFill>
-                  <a:latin typeface="+mn-lt"/>
-                  <a:ea typeface="+mn-ea"/>
-                  <a:cs typeface="+mn-cs"/>
-                </a:rPr>
-                <a:t>Reproducible math with zero LLM opacity</a:t>
-              </a:r>
+                </a:rPr>
+                <a:t>Reproducible math; every run saved. </a:t>
+              </a:r>
+            </a:p>
+            <a:p>
+              <a:pPr marL="76200" indent="-76200">
+                <a:buClr>
+                  <a:srgbClr val="334155"/>
+                </a:buClr>
+                <a:buFontTx/>
+                <a:buChar char="•"/>
+              </a:pPr>
+              <a:r>
+                <a:rPr lang="en-US" sz="820" dirty="0">
+                  <a:solidFill>
+                    <a:srgbClr val="334155"/>
+                  </a:solidFill>
+                </a:rPr>
+                <a:t>FinBERT is a neural model, with keyword rules for event type.</a:t>
+              </a:r>
+              <a:endParaRPr lang="en-US" sz="820" dirty="0">
+                <a:solidFill>
+                  <a:srgbClr val="334155"/>
+                </a:solidFill>
+                <a:latin typeface="+mn-lt"/>
+                <a:ea typeface="+mn-ea"/>
+                <a:cs typeface="+mn-cs"/>
+              </a:endParaRPr>
             </a:p>
           </p:txBody>
         </p:sp>

</xml_diff>

<commit_message>
docs: regenerate slide PNGs from updated presentation.pptx
</commit_message>
<xml_diff>
--- a/docs/presentation.pptx
+++ b/docs/presentation.pptx
@@ -4324,7 +4324,7 @@
           <p:spPr>
             <a:xfrm>
               <a:off x="9063038" y="4813300"/>
-              <a:ext cx="1463241" cy="161925"/>
+              <a:ext cx="1170192" cy="126188"/>
             </a:xfrm>
             <a:prstGeom prst="rect">
               <a:avLst/>
@@ -4350,7 +4350,7 @@
                   <a:ea typeface="+mn-ea"/>
                   <a:cs typeface="+mn-cs"/>
                 </a:rPr>
-                <a:t>Sub-Second Reactive Pipeline</a:t>
+                <a:t>Event-driven risk pipeline</a:t>
               </a:r>
             </a:p>
           </p:txBody>
@@ -11238,7 +11238,7 @@
           <p:spPr>
             <a:xfrm>
               <a:off x="4681538" y="2317750"/>
-              <a:ext cx="1675448" cy="176212"/>
+              <a:ext cx="1025922" cy="138767"/>
             </a:xfrm>
             <a:prstGeom prst="rect">
               <a:avLst/>
@@ -11264,21 +11264,21 @@
                   <a:ea typeface="Consolas"/>
                   <a:cs typeface="Consolas"/>
                 </a:rPr>
-                <a:t>0.35 * |sentiment| * 10 +</a:t>
-              </a:r>
-            </a:p>
-          </p:txBody>
-        </p:sp>
-        <p:sp>
-          <p:nvSpPr>
-            <p:cNvPr id="59" name="TextBox 59"/>
-            <p:cNvSpPr txBox="1"/>
-            <p:nvPr/>
-          </p:nvSpPr>
-          <p:spPr>
-            <a:xfrm>
-              <a:off x="4681538" y="2489200"/>
-              <a:ext cx="1941995" cy="176212"/>
+                <a:t>(weighted sum) *</a:t>
+              </a:r>
+            </a:p>
+          </p:txBody>
+        </p:sp>
+        <p:sp>
+          <p:nvSpPr>
+            <p:cNvPr id="60" name="TextBox 60"/>
+            <p:cNvSpPr txBox="1"/>
+            <p:nvPr/>
+          </p:nvSpPr>
+          <p:spPr>
+            <a:xfrm>
+              <a:off x="4681538" y="2567769"/>
+              <a:ext cx="1667123" cy="138767"/>
             </a:xfrm>
             <a:prstGeom prst="rect">
               <a:avLst/>
@@ -11298,53 +11298,13 @@
               <a:r>
                 <a:rPr lang="en-US" sz="900" dirty="0">
                   <a:solidFill>
-                    <a:srgbClr val="FCD34D"/>
+                    <a:srgbClr val="F472B6"/>
                   </a:solidFill>
                   <a:latin typeface="Consolas"/>
                   <a:ea typeface="Consolas"/>
                   <a:cs typeface="Consolas"/>
                 </a:rPr>
-                <a:t>0.35 * severity_weight * 10 +</a:t>
-              </a:r>
-            </a:p>
-          </p:txBody>
-        </p:sp>
-        <p:sp>
-          <p:nvSpPr>
-            <p:cNvPr id="60" name="TextBox 60"/>
-            <p:cNvSpPr txBox="1"/>
-            <p:nvPr/>
-          </p:nvSpPr>
-          <p:spPr>
-            <a:xfrm>
-              <a:off x="4681538" y="2660650"/>
-              <a:ext cx="2008632" cy="176212"/>
-            </a:xfrm>
-            <a:prstGeom prst="rect">
-              <a:avLst/>
-            </a:prstGeom>
-            <a:noFill/>
-            <a:ln>
-              <a:noFill/>
-            </a:ln>
-          </p:spPr>
-          <p:txBody>
-            <a:bodyPr wrap="none" lIns="0" tIns="0" rIns="0" bIns="0" anchor="t" anchorCtr="0">
-              <a:spAutoFit/>
-            </a:bodyPr>
-            <a:lstStyle/>
-            <a:p>
-              <a:pPr algn="l"/>
-              <a:r>
-                <a:rPr lang="en-US" sz="900" dirty="0">
-                  <a:solidFill>
-                    <a:srgbClr val="F472B6"/>
-                  </a:solidFill>
-                  <a:latin typeface="Consolas"/>
-                  <a:ea typeface="Consolas"/>
-                  <a:cs typeface="Consolas"/>
-                </a:rPr>
-                <a:t>0.30 * source_credibility * 10</a:t>
+                <a:t>(0.85 + 0.15 * confidence)</a:t>
               </a:r>
             </a:p>
           </p:txBody>
@@ -11357,7 +11317,7 @@
           </p:nvSpPr>
           <p:spPr>
             <a:xfrm>
-              <a:off x="4529138" y="2851150"/>
+              <a:off x="4540397" y="2763044"/>
               <a:ext cx="609257" cy="176212"/>
             </a:xfrm>
             <a:prstGeom prst="rect">
@@ -12678,9 +12638,9 @@
         </p:nvGrpSpPr>
         <p:grpSpPr>
           <a:xfrm>
-            <a:off x="1216761" y="1348617"/>
+            <a:off x="1216761" y="1298575"/>
             <a:ext cx="9449730" cy="3429000"/>
-            <a:chOff x="576263" y="1359008"/>
+            <a:chOff x="576263" y="1308966"/>
             <a:chExt cx="11049000" cy="3429000"/>
           </a:xfrm>
         </p:grpSpPr>
@@ -12692,7 +12652,7 @@
           </p:nvSpPr>
           <p:spPr>
             <a:xfrm>
-              <a:off x="576263" y="1359008"/>
+              <a:off x="576263" y="1308966"/>
               <a:ext cx="11049000" cy="3429000"/>
             </a:xfrm>
             <a:prstGeom prst="roundRect">
@@ -14141,8 +14101,8 @@
           </p:nvSpPr>
           <p:spPr>
             <a:xfrm>
-              <a:off x="7981262" y="3003550"/>
-              <a:ext cx="458577" cy="161925"/>
+              <a:off x="7974389" y="3003550"/>
+              <a:ext cx="472324" cy="126188"/>
             </a:xfrm>
             <a:prstGeom prst="rect">
               <a:avLst/>
@@ -14168,7 +14128,7 @@
                   <a:ea typeface="Consolas"/>
                   <a:cs typeface="Consolas"/>
                 </a:rPr>
-                <a:t>-$23.1M</a:t>
+                <a:t>-$7.25M</a:t>
               </a:r>
             </a:p>
           </p:txBody>
@@ -14309,8 +14269,8 @@
           </p:nvSpPr>
           <p:spPr>
             <a:xfrm>
-              <a:off x="9074943" y="2867025"/>
-              <a:ext cx="809625" cy="933450"/>
+              <a:off x="9074943" y="2671374"/>
+              <a:ext cx="809625" cy="1129101"/>
             </a:xfrm>
             <a:prstGeom prst="roundRect">
               <a:avLst>
@@ -14340,7 +14300,7 @@
           </p:nvSpPr>
           <p:spPr>
             <a:xfrm>
-              <a:off x="9255334" y="2671376"/>
+              <a:off x="9255334" y="2461825"/>
               <a:ext cx="448842" cy="138499"/>
             </a:xfrm>
             <a:prstGeom prst="rect">
@@ -16606,7 +16566,7 @@
           <p:spPr>
             <a:xfrm>
               <a:off x="833438" y="5099050"/>
-              <a:ext cx="1652697" cy="126188"/>
+              <a:ext cx="1003480" cy="126188"/>
             </a:xfrm>
             <a:prstGeom prst="rect">
               <a:avLst/>
@@ -16628,7 +16588,7 @@
                     <a:schemeClr val="accent1"/>
                   </a:solidFill>
                 </a:rPr>
-                <a:t>PROTOTYPE RESULT / 7 scenarios</a:t>
+                <a:t>PROTOTYPE RESULT</a:t>
               </a:r>
               <a:endParaRPr lang="en-US" sz="820" b="1" dirty="0">
                 <a:solidFill>
@@ -16650,34 +16610,38 @@
           <p:spPr>
             <a:xfrm>
               <a:off x="829056" y="5327650"/>
-              <a:ext cx="684657" cy="352044"/>
-            </a:xfrm>
-            <a:prstGeom prst="rect">
-              <a:avLst/>
-            </a:prstGeom>
-            <a:noFill/>
-            <a:ln>
-              <a:noFill/>
-            </a:ln>
-          </p:spPr>
-          <p:txBody>
-            <a:bodyPr wrap="none" lIns="0" tIns="0" rIns="0" bIns="0" anchor="t" anchorCtr="0">
-              <a:spAutoFit/>
-            </a:bodyPr>
-            <a:lstStyle/>
-            <a:p>
-              <a:pPr algn="l"/>
-              <a:r>
-                <a:rPr lang="en-US" sz="1800" b="1" dirty="0">
+              <a:ext cx="1196738" cy="276999"/>
+            </a:xfrm>
+            <a:prstGeom prst="rect">
+              <a:avLst/>
+            </a:prstGeom>
+            <a:noFill/>
+            <a:ln>
+              <a:noFill/>
+            </a:ln>
+          </p:spPr>
+          <p:txBody>
+            <a:bodyPr wrap="none" lIns="0" tIns="0" rIns="0" bIns="0" anchor="t" anchorCtr="0">
+              <a:spAutoFit/>
+            </a:bodyPr>
+            <a:lstStyle/>
+            <a:p>
+              <a:r>
+                <a:rPr lang="en-US" b="1" dirty="0">
                   <a:solidFill>
                     <a:schemeClr val="accent1"/>
                   </a:solidFill>
-                  <a:latin typeface="Consolas"/>
-                  <a:ea typeface="Consolas"/>
-                  <a:cs typeface="Consolas"/>
-                </a:rPr>
-                <a:t>98.5%</a:t>
-              </a:r>
+                </a:rPr>
+                <a:t>7 scenarios</a:t>
+              </a:r>
+              <a:endParaRPr lang="en-US" sz="1800" b="1" dirty="0">
+                <a:solidFill>
+                  <a:schemeClr val="accent1"/>
+                </a:solidFill>
+                <a:latin typeface="Consolas"/>
+                <a:ea typeface="Consolas"/>
+                <a:cs typeface="Consolas"/>
+              </a:endParaRPr>
             </a:p>
           </p:txBody>
         </p:sp>
@@ -17417,17 +17381,14 @@
                 </a:rPr>
                 <a:t>with instant chart updates.</a:t>
               </a:r>
-              <a:r>
-                <a:rPr lang="en-US" sz="820" dirty="0">
-                  <a:solidFill>
-                    <a:srgbClr val="334155"/>
-                  </a:solidFill>
-                  <a:latin typeface="+mn-lt"/>
-                  <a:ea typeface="+mn-ea"/>
-                  <a:cs typeface="+mn-cs"/>
-                </a:rPr>
-                <a:t>.</a:t>
-              </a:r>
+              <a:endParaRPr lang="en-US" sz="820" dirty="0">
+                <a:solidFill>
+                  <a:srgbClr val="334155"/>
+                </a:solidFill>
+                <a:latin typeface="+mn-lt"/>
+                <a:ea typeface="+mn-ea"/>
+                <a:cs typeface="+mn-cs"/>
+              </a:endParaRPr>
             </a:p>
           </p:txBody>
         </p:sp>
@@ -19028,7 +18989,7 @@
           <p:spPr>
             <a:xfrm>
               <a:off x="757238" y="1457325"/>
-              <a:ext cx="3699659" cy="176212"/>
+              <a:ext cx="3339056" cy="138499"/>
             </a:xfrm>
             <a:prstGeom prst="rect">
               <a:avLst/>
@@ -19054,7 +19015,7 @@
                   <a:ea typeface="+mn-ea"/>
                   <a:cs typeface="+mn-cs"/>
                 </a:rPr>
-                <a:t>DOCUMENTED ASSUMPTIONS &amp; RATIONALE (A1–A8)</a:t>
+                <a:t>DOCUMENTED ASSUMPTIONS &amp; RATIONALE (A1–A9)</a:t>
               </a:r>
             </a:p>
           </p:txBody>

</xml_diff>